<commit_message>
Add GitHub link to README file
</commit_message>
<xml_diff>
--- a/Introduction-Azure-Account-Setup.pptx
+++ b/Introduction-Azure-Account-Setup.pptx
@@ -1,35 +1,35 @@
 
 <file path=ppt/presentation.xml><?xml version="1.0" encoding="utf-8"?>
-<p:presentation xmlns:a="http://schemas.openxmlformats.org/drawingml/2006/main" xmlns:r="http://schemas.openxmlformats.org/officeDocument/2006/relationships" xmlns:p="http://schemas.openxmlformats.org/presentationml/2006/main" saveSubsetFonts="1" autoCompressPictures="0">
+<p:presentation xmlns:a="http://schemas.openxmlformats.org/drawingml/2006/main" xmlns:r="http://schemas.openxmlformats.org/officeDocument/2006/relationships" xmlns:p="http://schemas.openxmlformats.org/presentationml/2006/main" autoCompressPictures="0">
   <p:sldMasterIdLst>
     <p:sldMasterId id="2147483648" r:id="rId1"/>
   </p:sldMasterIdLst>
+  <p:notesMasterIdLst>
+    <p:notesMasterId r:id="rId4"/>
+  </p:notesMasterIdLst>
   <p:sldIdLst>
-    <p:sldId id="256" r:id="rId7"/>
-    <p:sldId id="257" r:id="rId8"/>
-    <p:sldId id="258" r:id="rId9"/>
-    <p:sldId id="259" r:id="rId10"/>
-    <p:sldId id="260" r:id="rId11"/>
-    <p:sldId id="261" r:id="rId6"/>
-    <p:sldId id="262" r:id="rId5"/>
-    <p:sldId id="263" r:id="rId4"/>
-    <p:sldId id="264" r:id="rId3"/>
-    <p:sldId id="265" r:id="rId2"/>
-    <p:sldId id="266" r:id="rId17"/>
-    <p:sldId id="267" r:id="rId18"/>
-    <p:sldId id="268" r:id="rId19"/>
-    <p:sldId id="269" r:id="rId20"/>
-    <p:sldId id="270" r:id="rId21"/>
-    <p:sldId id="271" r:id="rId22"/>
-    <p:sldId id="272" r:id="rId23"/>
-    <p:sldId id="273" r:id="rId24"/>
-    <p:sldId id="274" r:id="rId25"/>
-    <p:sldId id="275" r:id="rId26"/>
-    <p:sldId id="276" r:id="rId27"/>
+    <p:sldId id="256" r:id="rId3"/>
+    <p:sldId id="257" r:id="rId5"/>
+    <p:sldId id="258" r:id="rId6"/>
+    <p:sldId id="259" r:id="rId7"/>
+    <p:sldId id="260" r:id="rId8"/>
+    <p:sldId id="261" r:id="rId9"/>
+    <p:sldId id="262" r:id="rId10"/>
+    <p:sldId id="263" r:id="rId11"/>
+    <p:sldId id="264" r:id="rId12"/>
+    <p:sldId id="265" r:id="rId13"/>
+    <p:sldId id="266" r:id="rId14"/>
+    <p:sldId id="267" r:id="rId15"/>
+    <p:sldId id="268" r:id="rId16"/>
+    <p:sldId id="269" r:id="rId17"/>
+    <p:sldId id="270" r:id="rId18"/>
+    <p:sldId id="271" r:id="rId19"/>
+    <p:sldId id="272" r:id="rId20"/>
+    <p:sldId id="273" r:id="rId21"/>
+    <p:sldId id="274" r:id="rId22"/>
+    <p:sldId id="275" r:id="rId23"/>
+    <p:sldId id="276" r:id="rId24"/>
   </p:sldIdLst>
-  <p:notesMasterIdLst>
-    <p:notesMasterId r:id="rId12"/>
-  </p:notesMasterIdLst>
   <p:sldSz cx="12192000" cy="6858000"/>
   <p:notesSz cx="6858000" cy="12192000"/>
   <p:defaultTextStyle>
@@ -209,7 +209,6 @@
           <a:p>
             <a:fld id="{5282F153-3F37-0F45-9E97-73ACFA13230C}" type="datetimeFigureOut">
               <a:rPr lang="en-US"/>
-              <a:t>7/23/19</a:t>
             </a:fld>
             <a:endParaRPr lang="en-US"/>
           </a:p>
@@ -276,6 +275,7 @@
               <a:rPr lang="en-US"/>
               <a:t>Click to edit Master text styles</a:t>
             </a:r>
+            <a:endParaRPr lang="en-US"/>
           </a:p>
           <a:p>
             <a:pPr lvl="1"/>
@@ -283,6 +283,7 @@
               <a:rPr lang="en-US"/>
               <a:t>Second level</a:t>
             </a:r>
+            <a:endParaRPr lang="en-US"/>
           </a:p>
           <a:p>
             <a:pPr lvl="2"/>
@@ -290,6 +291,7 @@
               <a:rPr lang="en-US"/>
               <a:t>Third level</a:t>
             </a:r>
+            <a:endParaRPr lang="en-US"/>
           </a:p>
           <a:p>
             <a:pPr lvl="3"/>
@@ -297,6 +299,7 @@
               <a:rPr lang="en-US"/>
               <a:t>Fourth level</a:t>
             </a:r>
+            <a:endParaRPr lang="en-US"/>
           </a:p>
           <a:p>
             <a:pPr lvl="4"/>
@@ -304,6 +307,7 @@
               <a:rPr lang="en-US"/>
               <a:t>Fifth level</a:t>
             </a:r>
+            <a:endParaRPr lang="en-US"/>
           </a:p>
         </p:txBody>
       </p:sp>
@@ -367,18 +371,12 @@
           <a:p>
             <a:fld id="{CE5E9CC1-C706-0F49-92D6-E571CC5EEA8F}" type="slidenum">
               <a:rPr lang="en-US"/>
-              <a:t>‹#›</a:t>
             </a:fld>
             <a:endParaRPr lang="en-US"/>
           </a:p>
         </p:txBody>
       </p:sp>
     </p:spTree>
-    <p:extLst>
-      <p:ext uri="{BB962C8B-B14F-4D97-AF65-F5344CB8AC3E}">
-        <p14:creationId xmlns:p14="http://schemas.microsoft.com/office/powerpoint/2010/main" val="1024086991"/>
-      </p:ext>
-    </p:extLst>
   </p:cSld>
   <p:clrMap bg1="lt1" tx1="dk1" bg2="lt2" tx2="dk2" accent1="accent1" accent2="accent2" accent3="accent3" accent4="accent4" accent5="accent5" accent6="accent6" hlink="hlink" folHlink="folHlink"/>
   <p:notesStyle>
@@ -477,7 +475,7 @@
 </file>
 
 <file path=ppt/notesSlides/notesSlide1.xml><?xml version="1.0" encoding="utf-8"?>
-<p:notes xmlns:a="http://schemas.openxmlformats.org/drawingml/2006/main" xmlns:p="http://schemas.openxmlformats.org/presentationml/2006/main" xmlns:r="http://schemas.openxmlformats.org/officeDocument/2006/relationships">
+<p:notes xmlns:a="http://schemas.openxmlformats.org/drawingml/2006/main" xmlns:r="http://schemas.openxmlformats.org/officeDocument/2006/relationships" xmlns:p="http://schemas.openxmlformats.org/presentationml/2006/main">
   <p:cSld>
     <p:spTree>
       <p:nvGrpSpPr>
@@ -512,18 +510,14 @@
             <a:spLocks noGrp="1"/>
           </p:cNvSpPr>
           <p:nvPr>
-            <p:ph type="body" idx="3" sz="quarter"/>
+            <p:ph type="body" sz="quarter" idx="3"/>
           </p:nvPr>
         </p:nvSpPr>
         <p:spPr/>
         <p:txBody>
           <a:bodyPr/>
           <a:lstStyle/>
-          <a:p>
-            <a:r>
-              <a:t>Day 1, first thing. Everyone needs their own subscription before Module 1 — the whole course is hands-on against real Azure. Budget ~20 minutes and expect two or three people to hit the card step or a blocked school account; the fixes are in the notes on those slides.</a:t>
-            </a:r>
-          </a:p>
+          <a:p/>
         </p:txBody>
       </p:sp>
       <p:sp>
@@ -533,7 +527,7 @@
             <a:spLocks noGrp="1"/>
           </p:cNvSpPr>
           <p:nvPr>
-            <p:ph type="sldNum" idx="5" sz="quarter"/>
+            <p:ph type="sldNum" sz="quarter" idx="5"/>
           </p:nvPr>
         </p:nvSpPr>
         <p:spPr/>
@@ -547,7 +541,7 @@
 </file>
 
 <file path=ppt/notesSlides/notesSlide10.xml><?xml version="1.0" encoding="utf-8"?>
-<p:notes xmlns:a="http://schemas.openxmlformats.org/drawingml/2006/main" xmlns:p="http://schemas.openxmlformats.org/presentationml/2006/main" xmlns:r="http://schemas.openxmlformats.org/officeDocument/2006/relationships">
+<p:notes xmlns:a="http://schemas.openxmlformats.org/drawingml/2006/main" xmlns:r="http://schemas.openxmlformats.org/officeDocument/2006/relationships" xmlns:p="http://schemas.openxmlformats.org/presentationml/2006/main">
   <p:cSld>
     <p:spTree>
       <p:nvGrpSpPr>
@@ -582,18 +576,14 @@
             <a:spLocks noGrp="1"/>
           </p:cNvSpPr>
           <p:nvPr>
-            <p:ph type="body" idx="3" sz="quarter"/>
+            <p:ph type="body" sz="quarter" idx="3"/>
           </p:nvPr>
         </p:nvSpPr>
         <p:spPr/>
         <p:txBody>
           <a:bodyPr/>
           <a:lstStyle/>
-          <a:p>
-            <a:r>
-              <a:t>Students who put a school address here get locked out later when that account is deprovisioned at the end of the year.</a:t>
-            </a:r>
-          </a:p>
+          <a:p/>
         </p:txBody>
       </p:sp>
       <p:sp>
@@ -603,7 +593,7 @@
             <a:spLocks noGrp="1"/>
           </p:cNvSpPr>
           <p:nvPr>
-            <p:ph type="sldNum" idx="5" sz="quarter"/>
+            <p:ph type="sldNum" sz="quarter" idx="5"/>
           </p:nvPr>
         </p:nvSpPr>
         <p:spPr/>
@@ -617,7 +607,7 @@
 </file>
 
 <file path=ppt/notesSlides/notesSlide11.xml><?xml version="1.0" encoding="utf-8"?>
-<p:notes xmlns:a="http://schemas.openxmlformats.org/drawingml/2006/main" xmlns:p="http://schemas.openxmlformats.org/presentationml/2006/main" xmlns:r="http://schemas.openxmlformats.org/officeDocument/2006/relationships">
+<p:notes xmlns:a="http://schemas.openxmlformats.org/drawingml/2006/main" xmlns:r="http://schemas.openxmlformats.org/officeDocument/2006/relationships" xmlns:p="http://schemas.openxmlformats.org/presentationml/2006/main">
   <p:cSld>
     <p:spTree>
       <p:nvGrpSpPr>
@@ -652,18 +642,14 @@
             <a:spLocks noGrp="1"/>
           </p:cNvSpPr>
           <p:nvPr>
-            <p:ph type="body" idx="3" sz="quarter"/>
+            <p:ph type="body" sz="quarter" idx="3"/>
           </p:nvPr>
         </p:nvSpPr>
         <p:spPr/>
         <p:txBody>
           <a:bodyPr/>
           <a:lstStyle/>
-          <a:p>
-            <a:r>
-              <a:t>Ireland here means euro billing, which is why the budget later is in €. Steps 2 and 3 are phone verification and the card.</a:t>
-            </a:r>
-          </a:p>
+          <a:p/>
         </p:txBody>
       </p:sp>
       <p:sp>
@@ -673,7 +659,7 @@
             <a:spLocks noGrp="1"/>
           </p:cNvSpPr>
           <p:nvPr>
-            <p:ph type="sldNum" idx="5" sz="quarter"/>
+            <p:ph type="sldNum" sz="quarter" idx="5"/>
           </p:nvPr>
         </p:nvSpPr>
         <p:spPr/>
@@ -687,7 +673,7 @@
 </file>
 
 <file path=ppt/notesSlides/notesSlide12.xml><?xml version="1.0" encoding="utf-8"?>
-<p:notes xmlns:a="http://schemas.openxmlformats.org/drawingml/2006/main" xmlns:p="http://schemas.openxmlformats.org/presentationml/2006/main" xmlns:r="http://schemas.openxmlformats.org/officeDocument/2006/relationships">
+<p:notes xmlns:a="http://schemas.openxmlformats.org/drawingml/2006/main" xmlns:r="http://schemas.openxmlformats.org/officeDocument/2006/relationships" xmlns:p="http://schemas.openxmlformats.org/presentationml/2006/main">
   <p:cSld>
     <p:spTree>
       <p:nvGrpSpPr>
@@ -722,18 +708,14 @@
             <a:spLocks noGrp="1"/>
           </p:cNvSpPr>
           <p:nvPr>
-            <p:ph type="body" idx="3" sz="quarter"/>
+            <p:ph type="body" sz="quarter" idx="3"/>
           </p:nvPr>
         </p:nvSpPr>
         <p:spPr/>
         <p:txBody>
           <a:bodyPr/>
           <a:lstStyle/>
-          <a:p>
-            <a:r>
-              <a:t>Expect one or two students with no usable card. Options: Azure for Students (USD100, no card, needs an eligible school email), or pairing up with a classmate for the hands-on labs. Do not let this block the session — keep moving and sort it at the break.</a:t>
-            </a:r>
-          </a:p>
+          <a:p/>
         </p:txBody>
       </p:sp>
       <p:sp>
@@ -743,7 +725,7 @@
             <a:spLocks noGrp="1"/>
           </p:cNvSpPr>
           <p:nvPr>
-            <p:ph type="sldNum" idx="5" sz="quarter"/>
+            <p:ph type="sldNum" sz="quarter" idx="5"/>
           </p:nvPr>
         </p:nvSpPr>
         <p:spPr/>
@@ -757,7 +739,7 @@
 </file>
 
 <file path=ppt/notesSlides/notesSlide13.xml><?xml version="1.0" encoding="utf-8"?>
-<p:notes xmlns:a="http://schemas.openxmlformats.org/drawingml/2006/main" xmlns:p="http://schemas.openxmlformats.org/presentationml/2006/main" xmlns:r="http://schemas.openxmlformats.org/officeDocument/2006/relationships">
+<p:notes xmlns:a="http://schemas.openxmlformats.org/drawingml/2006/main" xmlns:r="http://schemas.openxmlformats.org/officeDocument/2006/relationships" xmlns:p="http://schemas.openxmlformats.org/presentationml/2006/main">
   <p:cSld>
     <p:spTree>
       <p:nvGrpSpPr>
@@ -792,18 +774,14 @@
             <a:spLocks noGrp="1"/>
           </p:cNvSpPr>
           <p:nvPr>
-            <p:ph type="body" idx="3" sz="quarter"/>
+            <p:ph type="body" sz="quarter" idx="3"/>
           </p:nvPr>
         </p:nvSpPr>
         <p:spPr/>
         <p:txBody>
           <a:bodyPr/>
           <a:lstStyle/>
-          <a:p>
-            <a:r>
-              <a:t>Good moment to run the Day 1 experience poll while the slower sign-ups catch up.</a:t>
-            </a:r>
-          </a:p>
+          <a:p/>
         </p:txBody>
       </p:sp>
       <p:sp>
@@ -813,7 +791,7 @@
             <a:spLocks noGrp="1"/>
           </p:cNvSpPr>
           <p:nvPr>
-            <p:ph type="sldNum" idx="5" sz="quarter"/>
+            <p:ph type="sldNum" sz="quarter" idx="5"/>
           </p:nvPr>
         </p:nvSpPr>
         <p:spPr/>
@@ -827,7 +805,7 @@
 </file>
 
 <file path=ppt/notesSlides/notesSlide14.xml><?xml version="1.0" encoding="utf-8"?>
-<p:notes xmlns:a="http://schemas.openxmlformats.org/drawingml/2006/main" xmlns:p="http://schemas.openxmlformats.org/presentationml/2006/main" xmlns:r="http://schemas.openxmlformats.org/officeDocument/2006/relationships">
+<p:notes xmlns:a="http://schemas.openxmlformats.org/drawingml/2006/main" xmlns:r="http://schemas.openxmlformats.org/officeDocument/2006/relationships" xmlns:p="http://schemas.openxmlformats.org/presentationml/2006/main">
   <p:cSld>
     <p:spTree>
       <p:nvGrpSpPr>
@@ -862,18 +840,14 @@
             <a:spLocks noGrp="1"/>
           </p:cNvSpPr>
           <p:nvPr>
-            <p:ph type="body" idx="3" sz="quarter"/>
+            <p:ph type="body" sz="quarter" idx="3"/>
           </p:nvPr>
         </p:nvSpPr>
         <p:spPr/>
         <p:txBody>
           <a:bodyPr/>
           <a:lstStyle/>
-          <a:p>
-            <a:r>
-              <a:t>This one is in the deck because it happened live during authoring. It looks alarming and it is not. Private window is the fastest fix in a classroom.</a:t>
-            </a:r>
-          </a:p>
+          <a:p/>
         </p:txBody>
       </p:sp>
       <p:sp>
@@ -883,7 +857,7 @@
             <a:spLocks noGrp="1"/>
           </p:cNvSpPr>
           <p:nvPr>
-            <p:ph type="sldNum" idx="5" sz="quarter"/>
+            <p:ph type="sldNum" sz="quarter" idx="5"/>
           </p:nvPr>
         </p:nvSpPr>
         <p:spPr/>
@@ -897,7 +871,7 @@
 </file>
 
 <file path=ppt/notesSlides/notesSlide15.xml><?xml version="1.0" encoding="utf-8"?>
-<p:notes xmlns:a="http://schemas.openxmlformats.org/drawingml/2006/main" xmlns:p="http://schemas.openxmlformats.org/presentationml/2006/main" xmlns:r="http://schemas.openxmlformats.org/officeDocument/2006/relationships">
+<p:notes xmlns:a="http://schemas.openxmlformats.org/drawingml/2006/main" xmlns:r="http://schemas.openxmlformats.org/officeDocument/2006/relationships" xmlns:p="http://schemas.openxmlformats.org/presentationml/2006/main">
   <p:cSld>
     <p:spTree>
       <p:nvGrpSpPr>
@@ -932,18 +906,14 @@
             <a:spLocks noGrp="1"/>
           </p:cNvSpPr>
           <p:nvPr>
-            <p:ph type="body" idx="3" sz="quarter"/>
+            <p:ph type="body" sz="quarter" idx="3"/>
           </p:nvPr>
         </p:nvSpPr>
         <p:spPr/>
         <p:txBody>
           <a:bodyPr/>
           <a:lstStyle/>
-          <a:p>
-            <a:r>
-              <a:t>Second thing that looks broken but isn't. Tell them to close the welcome dialog and carry on; the credits banner resolves itself.</a:t>
-            </a:r>
-          </a:p>
+          <a:p/>
         </p:txBody>
       </p:sp>
       <p:sp>
@@ -953,7 +923,7 @@
             <a:spLocks noGrp="1"/>
           </p:cNvSpPr>
           <p:nvPr>
-            <p:ph type="sldNum" idx="5" sz="quarter"/>
+            <p:ph type="sldNum" sz="quarter" idx="5"/>
           </p:nvPr>
         </p:nvSpPr>
         <p:spPr/>
@@ -967,7 +937,7 @@
 </file>
 
 <file path=ppt/notesSlides/notesSlide16.xml><?xml version="1.0" encoding="utf-8"?>
-<p:notes xmlns:a="http://schemas.openxmlformats.org/drawingml/2006/main" xmlns:p="http://schemas.openxmlformats.org/presentationml/2006/main" xmlns:r="http://schemas.openxmlformats.org/officeDocument/2006/relationships">
+<p:notes xmlns:a="http://schemas.openxmlformats.org/drawingml/2006/main" xmlns:r="http://schemas.openxmlformats.org/officeDocument/2006/relationships" xmlns:p="http://schemas.openxmlformats.org/presentationml/2006/main">
   <p:cSld>
     <p:spTree>
       <p:nvGrpSpPr>
@@ -1002,18 +972,14 @@
             <a:spLocks noGrp="1"/>
           </p:cNvSpPr>
           <p:nvPr>
-            <p:ph type="body" idx="3" sz="quarter"/>
+            <p:ph type="body" sz="quarter" idx="3"/>
           </p:nvPr>
         </p:nvSpPr>
         <p:spPr/>
         <p:txBody>
           <a:bodyPr/>
           <a:lstStyle/>
-          <a:p>
-            <a:r>
-              <a:t>Make the point explicitly: the guardrail goes up before the first resource, not after the first surprise.</a:t>
-            </a:r>
-          </a:p>
+          <a:p/>
         </p:txBody>
       </p:sp>
       <p:sp>
@@ -1023,7 +989,7 @@
             <a:spLocks noGrp="1"/>
           </p:cNvSpPr>
           <p:nvPr>
-            <p:ph type="sldNum" idx="5" sz="quarter"/>
+            <p:ph type="sldNum" sz="quarter" idx="5"/>
           </p:nvPr>
         </p:nvSpPr>
         <p:spPr/>
@@ -1037,7 +1003,7 @@
 </file>
 
 <file path=ppt/notesSlides/notesSlide17.xml><?xml version="1.0" encoding="utf-8"?>
-<p:notes xmlns:a="http://schemas.openxmlformats.org/drawingml/2006/main" xmlns:p="http://schemas.openxmlformats.org/presentationml/2006/main" xmlns:r="http://schemas.openxmlformats.org/officeDocument/2006/relationships">
+<p:notes xmlns:a="http://schemas.openxmlformats.org/drawingml/2006/main" xmlns:r="http://schemas.openxmlformats.org/officeDocument/2006/relationships" xmlns:p="http://schemas.openxmlformats.org/presentationml/2006/main">
   <p:cSld>
     <p:spTree>
       <p:nvGrpSpPr>
@@ -1072,18 +1038,14 @@
             <a:spLocks noGrp="1"/>
           </p:cNvSpPr>
           <p:nvPr>
-            <p:ph type="body" idx="3" sz="quarter"/>
+            <p:ph type="body" sz="quarter" idx="3"/>
           </p:nvPr>
         </p:nvSpPr>
         <p:spPr/>
         <p:txBody>
           <a:bodyPr/>
           <a:lstStyle/>
-          <a:p>
-            <a:r>
-              <a:t>Scope is the vocabulary to plant now; it comes back in Module 3 with RBAC.</a:t>
-            </a:r>
-          </a:p>
+          <a:p/>
         </p:txBody>
       </p:sp>
       <p:sp>
@@ -1093,7 +1055,7 @@
             <a:spLocks noGrp="1"/>
           </p:cNvSpPr>
           <p:nvPr>
-            <p:ph type="sldNum" idx="5" sz="quarter"/>
+            <p:ph type="sldNum" sz="quarter" idx="5"/>
           </p:nvPr>
         </p:nvSpPr>
         <p:spPr/>
@@ -1107,7 +1069,7 @@
 </file>
 
 <file path=ppt/notesSlides/notesSlide18.xml><?xml version="1.0" encoding="utf-8"?>
-<p:notes xmlns:a="http://schemas.openxmlformats.org/drawingml/2006/main" xmlns:p="http://schemas.openxmlformats.org/presentationml/2006/main" xmlns:r="http://schemas.openxmlformats.org/officeDocument/2006/relationships">
+<p:notes xmlns:a="http://schemas.openxmlformats.org/drawingml/2006/main" xmlns:r="http://schemas.openxmlformats.org/officeDocument/2006/relationships" xmlns:p="http://schemas.openxmlformats.org/presentationml/2006/main">
   <p:cSld>
     <p:spTree>
       <p:nvGrpSpPr>
@@ -1142,18 +1104,14 @@
             <a:spLocks noGrp="1"/>
           </p:cNvSpPr>
           <p:nvPr>
-            <p:ph type="body" idx="3" sz="quarter"/>
+            <p:ph type="body" sz="quarter" idx="3"/>
           </p:nvPr>
         </p:nvSpPr>
         <p:spPr/>
         <p:txBody>
           <a:bodyPr/>
           <a:lstStyle/>
-          <a:p>
-            <a:r>
-              <a:t>Point at the 30-day expiry: the course runs inside that window, but their credit does not last the semester.</a:t>
-            </a:r>
-          </a:p>
+          <a:p/>
         </p:txBody>
       </p:sp>
       <p:sp>
@@ -1163,7 +1121,7 @@
             <a:spLocks noGrp="1"/>
           </p:cNvSpPr>
           <p:nvPr>
-            <p:ph type="sldNum" idx="5" sz="quarter"/>
+            <p:ph type="sldNum" sz="quarter" idx="5"/>
           </p:nvPr>
         </p:nvSpPr>
         <p:spPr/>
@@ -1177,7 +1135,7 @@
 </file>
 
 <file path=ppt/notesSlides/notesSlide19.xml><?xml version="1.0" encoding="utf-8"?>
-<p:notes xmlns:a="http://schemas.openxmlformats.org/drawingml/2006/main" xmlns:p="http://schemas.openxmlformats.org/presentationml/2006/main" xmlns:r="http://schemas.openxmlformats.org/officeDocument/2006/relationships">
+<p:notes xmlns:a="http://schemas.openxmlformats.org/drawingml/2006/main" xmlns:r="http://schemas.openxmlformats.org/officeDocument/2006/relationships" xmlns:p="http://schemas.openxmlformats.org/presentationml/2006/main">
   <p:cSld>
     <p:spTree>
       <p:nvGrpSpPr>
@@ -1212,18 +1170,14 @@
             <a:spLocks noGrp="1"/>
           </p:cNvSpPr>
           <p:nvPr>
-            <p:ph type="body" idx="3" sz="quarter"/>
+            <p:ph type="body" sz="quarter" idx="3"/>
           </p:nvPr>
         </p:nvSpPr>
         <p:spPr/>
         <p:txBody>
           <a:bodyPr/>
           <a:lstStyle/>
-          <a:p>
-            <a:r>
-              <a:t>Any small number works. What matters is that the budget exists and is scoped to the billing account so it catches everything.</a:t>
-            </a:r>
-          </a:p>
+          <a:p/>
         </p:txBody>
       </p:sp>
       <p:sp>
@@ -1233,7 +1187,7 @@
             <a:spLocks noGrp="1"/>
           </p:cNvSpPr>
           <p:nvPr>
-            <p:ph type="sldNum" idx="5" sz="quarter"/>
+            <p:ph type="sldNum" sz="quarter" idx="5"/>
           </p:nvPr>
         </p:nvSpPr>
         <p:spPr/>
@@ -1247,7 +1201,7 @@
 </file>
 
 <file path=ppt/notesSlides/notesSlide2.xml><?xml version="1.0" encoding="utf-8"?>
-<p:notes xmlns:a="http://schemas.openxmlformats.org/drawingml/2006/main" xmlns:p="http://schemas.openxmlformats.org/presentationml/2006/main" xmlns:r="http://schemas.openxmlformats.org/officeDocument/2006/relationships">
+<p:notes xmlns:a="http://schemas.openxmlformats.org/drawingml/2006/main" xmlns:r="http://schemas.openxmlformats.org/officeDocument/2006/relationships" xmlns:p="http://schemas.openxmlformats.org/presentationml/2006/main">
   <p:cSld>
     <p:spTree>
       <p:nvGrpSpPr>
@@ -1282,18 +1236,14 @@
             <a:spLocks noGrp="1"/>
           </p:cNvSpPr>
           <p:nvPr>
-            <p:ph type="body" idx="3" sz="quarter"/>
+            <p:ph type="body" sz="quarter" idx="3"/>
           </p:nvPr>
         </p:nvSpPr>
         <p:spPr/>
         <p:txBody>
           <a:bodyPr/>
           <a:lstStyle/>
-          <a:p>
-            <a:r>
-              <a:t>Everything here is done by the students, on their own machines. Trainer drives the same flow on screen so nobody is stranded. Nothing in this session costs money if the budget alert at the end is actually set.</a:t>
-            </a:r>
-          </a:p>
+          <a:p/>
         </p:txBody>
       </p:sp>
       <p:sp>
@@ -1303,7 +1253,7 @@
             <a:spLocks noGrp="1"/>
           </p:cNvSpPr>
           <p:nvPr>
-            <p:ph type="sldNum" idx="5" sz="quarter"/>
+            <p:ph type="sldNum" sz="quarter" idx="5"/>
           </p:nvPr>
         </p:nvSpPr>
         <p:spPr/>
@@ -1317,7 +1267,7 @@
 </file>
 
 <file path=ppt/notesSlides/notesSlide20.xml><?xml version="1.0" encoding="utf-8"?>
-<p:notes xmlns:a="http://schemas.openxmlformats.org/drawingml/2006/main" xmlns:p="http://schemas.openxmlformats.org/presentationml/2006/main" xmlns:r="http://schemas.openxmlformats.org/officeDocument/2006/relationships">
+<p:notes xmlns:a="http://schemas.openxmlformats.org/drawingml/2006/main" xmlns:r="http://schemas.openxmlformats.org/officeDocument/2006/relationships" xmlns:p="http://schemas.openxmlformats.org/presentationml/2006/main">
   <p:cSld>
     <p:spTree>
       <p:nvGrpSpPr>
@@ -1352,18 +1302,14 @@
             <a:spLocks noGrp="1"/>
           </p:cNvSpPr>
           <p:nvPr>
-            <p:ph type="body" idx="3" sz="quarter"/>
+            <p:ph type="body" sz="quarter" idx="3"/>
           </p:nvPr>
         </p:nvSpPr>
         <p:spPr/>
         <p:txBody>
           <a:bodyPr/>
           <a:lstStyle/>
-          <a:p>
-            <a:r>
-              <a:t>Say this twice: a budget is a notification, not a cap. The only real cap on a free account is the spending protection, which stops at the credit. Anyone on pay-as-you-go needs to treat this alert as their early warning and delete resource groups when a module ends.</a:t>
-            </a:r>
-          </a:p>
+          <a:p/>
         </p:txBody>
       </p:sp>
       <p:sp>
@@ -1373,7 +1319,7 @@
             <a:spLocks noGrp="1"/>
           </p:cNvSpPr>
           <p:nvPr>
-            <p:ph type="sldNum" idx="5" sz="quarter"/>
+            <p:ph type="sldNum" sz="quarter" idx="5"/>
           </p:nvPr>
         </p:nvSpPr>
         <p:spPr/>
@@ -1387,7 +1333,7 @@
 </file>
 
 <file path=ppt/notesSlides/notesSlide21.xml><?xml version="1.0" encoding="utf-8"?>
-<p:notes xmlns:a="http://schemas.openxmlformats.org/drawingml/2006/main" xmlns:p="http://schemas.openxmlformats.org/presentationml/2006/main" xmlns:r="http://schemas.openxmlformats.org/officeDocument/2006/relationships">
+<p:notes xmlns:a="http://schemas.openxmlformats.org/drawingml/2006/main" xmlns:r="http://schemas.openxmlformats.org/officeDocument/2006/relationships" xmlns:p="http://schemas.openxmlformats.org/presentationml/2006/main">
   <p:cSld>
     <p:spTree>
       <p:nvGrpSpPr>
@@ -1422,18 +1368,14 @@
             <a:spLocks noGrp="1"/>
           </p:cNvSpPr>
           <p:nvPr>
-            <p:ph type="body" idx="3" sz="quarter"/>
+            <p:ph type="body" sz="quarter" idx="3"/>
           </p:nvPr>
         </p:nvSpPr>
         <p:spPr/>
         <p:txBody>
           <a:bodyPr/>
           <a:lstStyle/>
-          <a:p>
-            <a:r>
-              <a:t>Bridge into Module 1. Before moving on, check by show of hands that every student reached the budget-alert screen — this is the only session where a straggler blocks everything that follows.</a:t>
-            </a:r>
-          </a:p>
+          <a:p/>
         </p:txBody>
       </p:sp>
       <p:sp>
@@ -1443,7 +1385,7 @@
             <a:spLocks noGrp="1"/>
           </p:cNvSpPr>
           <p:nvPr>
-            <p:ph type="sldNum" idx="5" sz="quarter"/>
+            <p:ph type="sldNum" sz="quarter" idx="5"/>
           </p:nvPr>
         </p:nvSpPr>
         <p:spPr/>
@@ -1457,7 +1399,7 @@
 </file>
 
 <file path=ppt/notesSlides/notesSlide3.xml><?xml version="1.0" encoding="utf-8"?>
-<p:notes xmlns:a="http://schemas.openxmlformats.org/drawingml/2006/main" xmlns:p="http://schemas.openxmlformats.org/presentationml/2006/main" xmlns:r="http://schemas.openxmlformats.org/officeDocument/2006/relationships">
+<p:notes xmlns:a="http://schemas.openxmlformats.org/drawingml/2006/main" xmlns:r="http://schemas.openxmlformats.org/officeDocument/2006/relationships" xmlns:p="http://schemas.openxmlformats.org/presentationml/2006/main">
   <p:cSld>
     <p:spTree>
       <p:nvGrpSpPr>
@@ -1492,18 +1434,14 @@
             <a:spLocks noGrp="1"/>
           </p:cNvSpPr>
           <p:nvPr>
-            <p:ph type="body" idx="3" sz="quarter"/>
+            <p:ph type="body" sz="quarter" idx="3"/>
           </p:nvPr>
         </p:nvSpPr>
         <p:spPr/>
         <p:txBody>
           <a:bodyPr/>
           <a:lstStyle/>
-          <a:p>
-            <a:r>
-              <a:t>Send them to azure.microsoft.com/free. Both routes ask for a card — the difference is the USD200 credit and the spending protection that comes with the free account.</a:t>
-            </a:r>
-          </a:p>
+          <a:p/>
         </p:txBody>
       </p:sp>
       <p:sp>
@@ -1513,7 +1451,7 @@
             <a:spLocks noGrp="1"/>
           </p:cNvSpPr>
           <p:nvPr>
-            <p:ph type="sldNum" idx="5" sz="quarter"/>
+            <p:ph type="sldNum" sz="quarter" idx="5"/>
           </p:nvPr>
         </p:nvSpPr>
         <p:spPr/>
@@ -1527,7 +1465,7 @@
 </file>
 
 <file path=ppt/notesSlides/notesSlide4.xml><?xml version="1.0" encoding="utf-8"?>
-<p:notes xmlns:a="http://schemas.openxmlformats.org/drawingml/2006/main" xmlns:p="http://schemas.openxmlformats.org/presentationml/2006/main" xmlns:r="http://schemas.openxmlformats.org/officeDocument/2006/relationships">
+<p:notes xmlns:a="http://schemas.openxmlformats.org/drawingml/2006/main" xmlns:r="http://schemas.openxmlformats.org/officeDocument/2006/relationships" xmlns:p="http://schemas.openxmlformats.org/presentationml/2006/main">
   <p:cSld>
     <p:spTree>
       <p:nvGrpSpPr>
@@ -1562,18 +1500,14 @@
             <a:spLocks noGrp="1"/>
           </p:cNvSpPr>
           <p:nvPr>
-            <p:ph type="body" idx="3" sz="quarter"/>
+            <p:ph type="body" sz="quarter" idx="3"/>
           </p:nvPr>
         </p:nvSpPr>
         <p:spPr/>
         <p:txBody>
           <a:bodyPr/>
           <a:lstStyle/>
-          <a:p>
-            <a:r>
-              <a:t>The line that matters in a classroom is spending protection: nothing is billed unless the student explicitly upgrades to pay-as-you-go. Free account is new-customers-only — anyone who has already used one goes pay-as-you-go and leans harder on the budget alert at the end of this deck.</a:t>
-            </a:r>
-          </a:p>
+          <a:p/>
         </p:txBody>
       </p:sp>
       <p:sp>
@@ -1583,7 +1517,7 @@
             <a:spLocks noGrp="1"/>
           </p:cNvSpPr>
           <p:nvPr>
-            <p:ph type="sldNum" idx="5" sz="quarter"/>
+            <p:ph type="sldNum" sz="quarter" idx="5"/>
           </p:nvPr>
         </p:nvSpPr>
         <p:spPr/>
@@ -1597,7 +1531,7 @@
 </file>
 
 <file path=ppt/notesSlides/notesSlide5.xml><?xml version="1.0" encoding="utf-8"?>
-<p:notes xmlns:a="http://schemas.openxmlformats.org/drawingml/2006/main" xmlns:p="http://schemas.openxmlformats.org/presentationml/2006/main" xmlns:r="http://schemas.openxmlformats.org/officeDocument/2006/relationships">
+<p:notes xmlns:a="http://schemas.openxmlformats.org/drawingml/2006/main" xmlns:r="http://schemas.openxmlformats.org/officeDocument/2006/relationships" xmlns:p="http://schemas.openxmlformats.org/presentationml/2006/main">
   <p:cSld>
     <p:spTree>
       <p:nvGrpSpPr>
@@ -1632,18 +1566,14 @@
             <a:spLocks noGrp="1"/>
           </p:cNvSpPr>
           <p:nvPr>
-            <p:ph type="body" idx="3" sz="quarter"/>
+            <p:ph type="body" sz="quarter" idx="3"/>
           </p:nvPr>
         </p:nvSpPr>
         <p:spPr/>
         <p:txBody>
           <a:bodyPr/>
           <a:lstStyle/>
-          <a:p>
-            <a:r>
-              <a:t>An ÉSTIAM or employer account is very often blocked by tenant policy from creating its own subscription, and even when it works the admin owns the subscription, not the student. Personal Microsoft account only.</a:t>
-            </a:r>
-          </a:p>
+          <a:p/>
         </p:txBody>
       </p:sp>
       <p:sp>
@@ -1653,7 +1583,7 @@
             <a:spLocks noGrp="1"/>
           </p:cNvSpPr>
           <p:nvPr>
-            <p:ph type="sldNum" idx="5" sz="quarter"/>
+            <p:ph type="sldNum" sz="quarter" idx="5"/>
           </p:nvPr>
         </p:nvSpPr>
         <p:spPr/>
@@ -1667,7 +1597,7 @@
 </file>
 
 <file path=ppt/notesSlides/notesSlide6.xml><?xml version="1.0" encoding="utf-8"?>
-<p:notes xmlns:a="http://schemas.openxmlformats.org/drawingml/2006/main" xmlns:p="http://schemas.openxmlformats.org/presentationml/2006/main" xmlns:r="http://schemas.openxmlformats.org/officeDocument/2006/relationships">
+<p:notes xmlns:a="http://schemas.openxmlformats.org/drawingml/2006/main" xmlns:r="http://schemas.openxmlformats.org/officeDocument/2006/relationships" xmlns:p="http://schemas.openxmlformats.org/presentationml/2006/main">
   <p:cSld>
     <p:spTree>
       <p:nvGrpSpPr>
@@ -1702,18 +1632,14 @@
             <a:spLocks noGrp="1"/>
           </p:cNvSpPr>
           <p:nvPr>
-            <p:ph type="body" idx="3" sz="quarter"/>
+            <p:ph type="body" sz="quarter" idx="3"/>
           </p:nvPr>
         </p:nvSpPr>
         <p:spPr/>
         <p:txBody>
           <a:bodyPr/>
           <a:lstStyle/>
-          <a:p>
-            <a:r>
-              <a:t>This is the fork in the road. Students who already have an @outlook.com / @hotmail.com address skip the next four slides and go straight to the Azure free account form.</a:t>
-            </a:r>
-          </a:p>
+          <a:p/>
         </p:txBody>
       </p:sp>
       <p:sp>
@@ -1723,7 +1649,7 @@
             <a:spLocks noGrp="1"/>
           </p:cNvSpPr>
           <p:nvPr>
-            <p:ph type="sldNum" idx="5" sz="quarter"/>
+            <p:ph type="sldNum" sz="quarter" idx="5"/>
           </p:nvPr>
         </p:nvSpPr>
         <p:spPr/>
@@ -1737,7 +1663,7 @@
 </file>
 
 <file path=ppt/notesSlides/notesSlide7.xml><?xml version="1.0" encoding="utf-8"?>
-<p:notes xmlns:a="http://schemas.openxmlformats.org/drawingml/2006/main" xmlns:p="http://schemas.openxmlformats.org/presentationml/2006/main" xmlns:r="http://schemas.openxmlformats.org/officeDocument/2006/relationships">
+<p:notes xmlns:a="http://schemas.openxmlformats.org/drawingml/2006/main" xmlns:r="http://schemas.openxmlformats.org/officeDocument/2006/relationships" xmlns:p="http://schemas.openxmlformats.org/presentationml/2006/main">
   <p:cSld>
     <p:spTree>
       <p:nvGrpSpPr>
@@ -1772,18 +1698,14 @@
             <a:spLocks noGrp="1"/>
           </p:cNvSpPr>
           <p:nvPr>
-            <p:ph type="body" idx="3" sz="quarter"/>
+            <p:ph type="body" sz="quarter" idx="3"/>
           </p:nvPr>
         </p:nvSpPr>
         <p:spPr/>
         <p:txBody>
           <a:bodyPr/>
           <a:lstStyle/>
-          <a:p>
-            <a:r>
-              <a:t>Either works. Registering an existing address avoids a second inbox to remember, which matters because Azure billing alerts land there.</a:t>
-            </a:r>
-          </a:p>
+          <a:p/>
         </p:txBody>
       </p:sp>
       <p:sp>
@@ -1793,7 +1715,7 @@
             <a:spLocks noGrp="1"/>
           </p:cNvSpPr>
           <p:nvPr>
-            <p:ph type="sldNum" idx="5" sz="quarter"/>
+            <p:ph type="sldNum" sz="quarter" idx="5"/>
           </p:nvPr>
         </p:nvSpPr>
         <p:spPr/>
@@ -1807,7 +1729,7 @@
 </file>
 
 <file path=ppt/notesSlides/notesSlide8.xml><?xml version="1.0" encoding="utf-8"?>
-<p:notes xmlns:a="http://schemas.openxmlformats.org/drawingml/2006/main" xmlns:p="http://schemas.openxmlformats.org/presentationml/2006/main" xmlns:r="http://schemas.openxmlformats.org/officeDocument/2006/relationships">
+<p:notes xmlns:a="http://schemas.openxmlformats.org/drawingml/2006/main" xmlns:r="http://schemas.openxmlformats.org/officeDocument/2006/relationships" xmlns:p="http://schemas.openxmlformats.org/presentationml/2006/main">
   <p:cSld>
     <p:spTree>
       <p:nvGrpSpPr>
@@ -1842,18 +1764,14 @@
             <a:spLocks noGrp="1"/>
           </p:cNvSpPr>
           <p:nvPr>
-            <p:ph type="body" idx="3" sz="quarter"/>
+            <p:ph type="body" sz="quarter" idx="3"/>
           </p:nvPr>
         </p:nvSpPr>
         <p:spPr/>
         <p:txBody>
           <a:bodyPr/>
           <a:lstStyle/>
-          <a:p>
-            <a:r>
-              <a:t>Worth flagging the distinction now so nobody assumes this is the billing country.</a:t>
-            </a:r>
-          </a:p>
+          <a:p/>
         </p:txBody>
       </p:sp>
       <p:sp>
@@ -1863,7 +1781,7 @@
             <a:spLocks noGrp="1"/>
           </p:cNvSpPr>
           <p:nvPr>
-            <p:ph type="sldNum" idx="5" sz="quarter"/>
+            <p:ph type="sldNum" sz="quarter" idx="5"/>
           </p:nvPr>
         </p:nvSpPr>
         <p:spPr/>
@@ -1877,7 +1795,7 @@
 </file>
 
 <file path=ppt/notesSlides/notesSlide9.xml><?xml version="1.0" encoding="utf-8"?>
-<p:notes xmlns:a="http://schemas.openxmlformats.org/drawingml/2006/main" xmlns:p="http://schemas.openxmlformats.org/presentationml/2006/main" xmlns:r="http://schemas.openxmlformats.org/officeDocument/2006/relationships">
+<p:notes xmlns:a="http://schemas.openxmlformats.org/drawingml/2006/main" xmlns:r="http://schemas.openxmlformats.org/officeDocument/2006/relationships" xmlns:p="http://schemas.openxmlformats.org/presentationml/2006/main">
   <p:cSld>
     <p:spTree>
       <p:nvGrpSpPr>
@@ -1912,18 +1830,14 @@
             <a:spLocks noGrp="1"/>
           </p:cNvSpPr>
           <p:nvPr>
-            <p:ph type="body" idx="3" sz="quarter"/>
+            <p:ph type="body" sz="quarter" idx="3"/>
           </p:nvPr>
         </p:nvSpPr>
         <p:spPr/>
         <p:txBody>
           <a:bodyPr/>
           <a:lstStyle/>
-          <a:p>
-            <a:r>
-              <a:t>Mismatched name and card is a common cause of the sign-up being rejected at step 3 of 3.</a:t>
-            </a:r>
-          </a:p>
+          <a:p/>
         </p:txBody>
       </p:sp>
       <p:sp>
@@ -1933,7 +1847,7 @@
             <a:spLocks noGrp="1"/>
           </p:cNvSpPr>
           <p:nvPr>
-            <p:ph type="sldNum" idx="5" sz="quarter"/>
+            <p:ph type="sldNum" sz="quarter" idx="5"/>
           </p:nvPr>
         </p:nvSpPr>
         <p:spPr/>
@@ -1979,6 +1893,11 @@
 <file path=ppt/slideMasters/slideMaster1.xml><?xml version="1.0" encoding="utf-8"?>
 <p:sldMaster xmlns:a="http://schemas.openxmlformats.org/drawingml/2006/main" xmlns:r="http://schemas.openxmlformats.org/officeDocument/2006/relationships" xmlns:p="http://schemas.openxmlformats.org/presentationml/2006/main">
   <p:cSld>
+    <p:bg>
+      <p:bgRef idx="1001">
+        <a:schemeClr val="bg1"/>
+      </p:bgRef>
+    </p:bg>
     <p:spTree>
       <p:nvGrpSpPr>
         <p:cNvPr id="1" name=""/>
@@ -2022,7 +1941,7 @@
         <a:spcBef>
           <a:spcPct val="20000"/>
         </a:spcBef>
-        <a:buFont typeface="Arial" pitchFamily="34" charset="0"/>
+        <a:buFont typeface="Arial" panose="020B0604020202020204" pitchFamily="34" charset="0"/>
         <a:buChar char="•"/>
         <a:defRPr sz="3200" kern="1200">
           <a:solidFill>
@@ -2037,7 +1956,7 @@
         <a:spcBef>
           <a:spcPct val="20000"/>
         </a:spcBef>
-        <a:buFont typeface="Arial" pitchFamily="34" charset="0"/>
+        <a:buFont typeface="Arial" panose="020B0604020202020204" pitchFamily="34" charset="0"/>
         <a:buChar char="–"/>
         <a:defRPr sz="2800" kern="1200">
           <a:solidFill>
@@ -2052,7 +1971,7 @@
         <a:spcBef>
           <a:spcPct val="20000"/>
         </a:spcBef>
-        <a:buFont typeface="Arial" pitchFamily="34" charset="0"/>
+        <a:buFont typeface="Arial" panose="020B0604020202020204" pitchFamily="34" charset="0"/>
         <a:buChar char="•"/>
         <a:defRPr sz="2400" kern="1200">
           <a:solidFill>
@@ -2067,7 +1986,7 @@
         <a:spcBef>
           <a:spcPct val="20000"/>
         </a:spcBef>
-        <a:buFont typeface="Arial" pitchFamily="34" charset="0"/>
+        <a:buFont typeface="Arial" panose="020B0604020202020204" pitchFamily="34" charset="0"/>
         <a:buChar char="–"/>
         <a:defRPr sz="2000" kern="1200">
           <a:solidFill>
@@ -2082,7 +2001,7 @@
         <a:spcBef>
           <a:spcPct val="20000"/>
         </a:spcBef>
-        <a:buFont typeface="Arial" pitchFamily="34" charset="0"/>
+        <a:buFont typeface="Arial" panose="020B0604020202020204" pitchFamily="34" charset="0"/>
         <a:buChar char="»"/>
         <a:defRPr sz="2000" kern="1200">
           <a:solidFill>
@@ -2097,7 +2016,7 @@
         <a:spcBef>
           <a:spcPct val="20000"/>
         </a:spcBef>
-        <a:buFont typeface="Arial" pitchFamily="34" charset="0"/>
+        <a:buFont typeface="Arial" panose="020B0604020202020204" pitchFamily="34" charset="0"/>
         <a:buChar char="•"/>
         <a:defRPr sz="2000" kern="1200">
           <a:solidFill>
@@ -2112,7 +2031,7 @@
         <a:spcBef>
           <a:spcPct val="20000"/>
         </a:spcBef>
-        <a:buFont typeface="Arial" pitchFamily="34" charset="0"/>
+        <a:buFont typeface="Arial" panose="020B0604020202020204" pitchFamily="34" charset="0"/>
         <a:buChar char="•"/>
         <a:defRPr sz="2000" kern="1200">
           <a:solidFill>
@@ -2127,7 +2046,7 @@
         <a:spcBef>
           <a:spcPct val="20000"/>
         </a:spcBef>
-        <a:buFont typeface="Arial" pitchFamily="34" charset="0"/>
+        <a:buFont typeface="Arial" panose="020B0604020202020204" pitchFamily="34" charset="0"/>
         <a:buChar char="•"/>
         <a:defRPr sz="2000" kern="1200">
           <a:solidFill>
@@ -2142,7 +2061,7 @@
         <a:spcBef>
           <a:spcPct val="20000"/>
         </a:spcBef>
-        <a:buFont typeface="Arial" pitchFamily="34" charset="0"/>
+        <a:buFont typeface="Arial" panose="020B0604020202020204" pitchFamily="34" charset="0"/>
         <a:buChar char="•"/>
         <a:defRPr sz="2000" kern="1200">
           <a:solidFill>
@@ -2254,13 +2173,14 @@
 </file>
 
 <file path=ppt/slides/slide1.xml><?xml version="1.0" encoding="utf-8"?>
-<p:sld xmlns:a="http://schemas.openxmlformats.org/drawingml/2006/main" xmlns:p="http://schemas.openxmlformats.org/presentationml/2006/main" xmlns:r="http://schemas.openxmlformats.org/officeDocument/2006/relationships">
+<p:sld xmlns:a="http://schemas.openxmlformats.org/drawingml/2006/main" xmlns:r="http://schemas.openxmlformats.org/officeDocument/2006/relationships" xmlns:p="http://schemas.openxmlformats.org/presentationml/2006/main">
   <p:cSld>
     <p:bg>
       <p:bgPr>
         <a:solidFill>
           <a:srgbClr val="1E2761"/>
         </a:solidFill>
+        <a:effectLst/>
       </p:bgPr>
     </p:bg>
     <p:spTree>
@@ -2287,7 +2207,6 @@
           <a:solidFill>
             <a:srgbClr val="141B47"/>
           </a:solidFill>
-          <a:ln/>
         </p:spPr>
       </p:sp>
       <p:sp>
@@ -2309,7 +2228,6 @@
               <a:alpha val="15000"/>
             </a:srgbClr>
           </a:solidFill>
-          <a:ln/>
         </p:spPr>
       </p:sp>
       <p:sp>
@@ -2327,23 +2245,22 @@
             <a:avLst/>
           </a:prstGeom>
           <a:noFill/>
-          <a:ln/>
         </p:spPr>
         <p:txBody>
           <a:bodyPr wrap="square" lIns="0" tIns="0" rIns="0" bIns="0" rtlCol="0" anchor="ctr"/>
           <a:lstStyle/>
           <a:p>
-            <a:pPr indent="0" marL="0">
+            <a:pPr marL="0" indent="0">
               <a:buNone/>
             </a:pPr>
             <a:r>
-              <a:rPr lang="en-US" sz="1500" b="1" spc="300" kern="0" dirty="0">
+              <a:rPr lang="en-US" sz="1500" b="1" kern="0" spc="300" dirty="0">
                 <a:solidFill>
                   <a:srgbClr val="F2A93B"/>
                 </a:solidFill>
-                <a:latin typeface="Calibri" pitchFamily="34" charset="0"/>
-                <a:ea typeface="Calibri" pitchFamily="34" charset="-122"/>
-                <a:cs typeface="Calibri" pitchFamily="34" charset="-120"/>
+                <a:latin typeface="Calibri" panose="020F0502020204030204" pitchFamily="34" charset="0"/>
+                <a:ea typeface="Calibri" panose="020F0502020204030204" pitchFamily="34" charset="-122"/>
+                <a:cs typeface="Calibri" panose="020F0502020204030204" pitchFamily="34" charset="-120"/>
               </a:rPr>
               <a:t>INTRODUCTION</a:t>
             </a:r>
@@ -2366,13 +2283,12 @@
             <a:avLst/>
           </a:prstGeom>
           <a:noFill/>
-          <a:ln/>
         </p:spPr>
         <p:txBody>
           <a:bodyPr wrap="square" lIns="0" tIns="0" rIns="0" bIns="0" rtlCol="0" anchor="ctr"/>
           <a:lstStyle/>
           <a:p>
-            <a:pPr indent="0" marL="0">
+            <a:pPr marL="0" indent="0">
               <a:buNone/>
             </a:pPr>
             <a:r>
@@ -2380,9 +2296,9 @@
                 <a:solidFill>
                   <a:srgbClr val="FFFFFF"/>
                 </a:solidFill>
-                <a:latin typeface="Cambria" pitchFamily="34" charset="0"/>
-                <a:ea typeface="Cambria" pitchFamily="34" charset="-122"/>
-                <a:cs typeface="Cambria" pitchFamily="34" charset="-120"/>
+                <a:latin typeface="Cambria" panose="02040503050406030204" pitchFamily="34" charset="0"/>
+                <a:ea typeface="Cambria" panose="02040503050406030204" pitchFamily="34" charset="-122"/>
+                <a:cs typeface="Cambria" panose="02040503050406030204" pitchFamily="34" charset="-120"/>
               </a:rPr>
               <a:t>Getting Set Up</a:t>
             </a:r>
@@ -2405,13 +2321,12 @@
             <a:avLst/>
           </a:prstGeom>
           <a:noFill/>
-          <a:ln/>
         </p:spPr>
         <p:txBody>
           <a:bodyPr wrap="square" lIns="0" tIns="0" rIns="0" bIns="0" rtlCol="0" anchor="ctr"/>
           <a:lstStyle/>
           <a:p>
-            <a:pPr indent="0" marL="0">
+            <a:pPr marL="0" indent="0">
               <a:buNone/>
             </a:pPr>
             <a:r>
@@ -2419,9 +2334,9 @@
                 <a:solidFill>
                   <a:srgbClr val="CADCFC"/>
                 </a:solidFill>
-                <a:latin typeface="Calibri" pitchFamily="34" charset="0"/>
-                <a:ea typeface="Calibri" pitchFamily="34" charset="-122"/>
-                <a:cs typeface="Calibri" pitchFamily="34" charset="-120"/>
+                <a:latin typeface="Calibri" panose="020F0502020204030204" pitchFamily="34" charset="0"/>
+                <a:ea typeface="Calibri" panose="020F0502020204030204" pitchFamily="34" charset="-122"/>
+                <a:cs typeface="Calibri" panose="020F0502020204030204" pitchFamily="34" charset="-120"/>
               </a:rPr>
               <a:t>Your own Azure account — and a spending guardrail before anything else</a:t>
             </a:r>
@@ -2444,13 +2359,12 @@
             <a:avLst/>
           </a:prstGeom>
           <a:noFill/>
-          <a:ln/>
         </p:spPr>
         <p:txBody>
           <a:bodyPr wrap="square" lIns="0" tIns="0" rIns="0" bIns="0" rtlCol="0" anchor="ctr"/>
           <a:lstStyle/>
           <a:p>
-            <a:pPr algn="l" indent="0" marL="0">
+            <a:pPr marL="0" indent="0" algn="l">
               <a:buNone/>
             </a:pPr>
             <a:r>
@@ -2458,9 +2372,9 @@
                 <a:solidFill>
                   <a:srgbClr val="AAB2D5"/>
                 </a:solidFill>
-                <a:latin typeface="Calibri" pitchFamily="34" charset="0"/>
-                <a:ea typeface="Calibri" pitchFamily="34" charset="-122"/>
-                <a:cs typeface="Calibri" pitchFamily="34" charset="-120"/>
+                <a:latin typeface="Calibri" panose="020F0502020204030204" pitchFamily="34" charset="0"/>
+                <a:ea typeface="Calibri" panose="020F0502020204030204" pitchFamily="34" charset="-122"/>
+                <a:cs typeface="Calibri" panose="020F0502020204030204" pitchFamily="34" charset="-120"/>
               </a:rPr>
               <a:t>Modern Enterprise Software Engineering  |  ÉSTIAM  |  Day 1</a:t>
             </a:r>
@@ -2477,13 +2391,14 @@
 </file>
 
 <file path=ppt/slides/slide10.xml><?xml version="1.0" encoding="utf-8"?>
-<p:sld xmlns:a="http://schemas.openxmlformats.org/drawingml/2006/main" xmlns:p="http://schemas.openxmlformats.org/presentationml/2006/main" xmlns:r="http://schemas.openxmlformats.org/officeDocument/2006/relationships">
+<p:sld xmlns:a="http://schemas.openxmlformats.org/drawingml/2006/main" xmlns:r="http://schemas.openxmlformats.org/officeDocument/2006/relationships" xmlns:p="http://schemas.openxmlformats.org/presentationml/2006/main">
   <p:cSld>
     <p:bg>
       <p:bgPr>
         <a:solidFill>
           <a:srgbClr val="FFFFFF"/>
         </a:solidFill>
+        <a:effectLst/>
       </p:bgPr>
     </p:bg>
     <p:spTree>
@@ -2510,7 +2425,7 @@
           <a:noFill/>
         </p:spPr>
         <p:txBody>
-          <a:bodyPr wrap="square" lIns="0" rIns="0" tIns="0" bIns="0">
+          <a:bodyPr wrap="square" lIns="0" tIns="0" rIns="0" bIns="0">
             <a:spAutoFit/>
           </a:bodyPr>
           <a:lstStyle/>
@@ -2520,10 +2435,16 @@
                 <a:solidFill>
                   <a:srgbClr val="F2A93B"/>
                 </a:solidFill>
-                <a:latin typeface="Calibri"/>
+                <a:latin typeface="Calibri" panose="020F0502020204030204"/>
               </a:rPr>
               <a:t>STEP 08</a:t>
             </a:r>
+            <a:endParaRPr sz="1300" b="1" spc="200">
+              <a:solidFill>
+                <a:srgbClr val="F2A93B"/>
+              </a:solidFill>
+              <a:latin typeface="Calibri" panose="020F0502020204030204"/>
+            </a:endParaRPr>
           </a:p>
         </p:txBody>
       </p:sp>
@@ -2544,7 +2465,7 @@
           <a:noFill/>
         </p:spPr>
         <p:txBody>
-          <a:bodyPr wrap="square" lIns="0" rIns="0" tIns="0" bIns="0">
+          <a:bodyPr wrap="square" lIns="0" tIns="0" rIns="0" bIns="0">
             <a:spAutoFit/>
           </a:bodyPr>
           <a:lstStyle/>
@@ -2554,10 +2475,16 @@
                 <a:solidFill>
                   <a:srgbClr val="1E2761"/>
                 </a:solidFill>
-                <a:latin typeface="Cambria"/>
+                <a:latin typeface="Cambria" panose="02040503050406030204"/>
               </a:rPr>
               <a:t>Add a recovery email</a:t>
             </a:r>
+            <a:endParaRPr sz="3000" b="1">
+              <a:solidFill>
+                <a:srgbClr val="1E2761"/>
+              </a:solidFill>
+              <a:latin typeface="Cambria" panose="02040503050406030204"/>
+            </a:endParaRPr>
           </a:p>
         </p:txBody>
       </p:sp>
@@ -2578,7 +2505,7 @@
           <a:noFill/>
         </p:spPr>
         <p:txBody>
-          <a:bodyPr wrap="square" lIns="0" rIns="0" tIns="0" bIns="0">
+          <a:bodyPr wrap="square" lIns="0" tIns="0" rIns="0" bIns="0">
             <a:spAutoFit/>
           </a:bodyPr>
           <a:lstStyle/>
@@ -2588,10 +2515,16 @@
                 <a:solidFill>
                   <a:srgbClr val="1F2430"/>
                 </a:solidFill>
-                <a:latin typeface="Calibri"/>
+                <a:latin typeface="Calibri" panose="020F0502020204030204"/>
               </a:rPr>
               <a:t>An alternate personal address. Microsoft sends a security code there in the next step — again, not a work or school email.</a:t>
             </a:r>
+            <a:endParaRPr sz="1400" b="0">
+              <a:solidFill>
+                <a:srgbClr val="1F2430"/>
+              </a:solidFill>
+              <a:latin typeface="Calibri" panose="020F0502020204030204"/>
+            </a:endParaRPr>
           </a:p>
         </p:txBody>
       </p:sp>
@@ -2604,7 +2537,7 @@
           <p:nvPr/>
         </p:nvPicPr>
         <p:blipFill>
-          <a:blip r:embed="rId2"/>
+          <a:blip r:embed="rId1"/>
           <a:stretch>
             <a:fillRect/>
           </a:stretch>
@@ -2639,13 +2572,12 @@
             <a:avLst/>
           </a:prstGeom>
           <a:noFill/>
-          <a:ln/>
         </p:spPr>
         <p:txBody>
           <a:bodyPr wrap="square" lIns="0" tIns="0" rIns="0" bIns="0" rtlCol="0" anchor="ctr"/>
           <a:lstStyle/>
           <a:p>
-            <a:pPr algn="l" indent="0" marL="0">
+            <a:pPr marL="0" indent="0" algn="l">
               <a:buNone/>
             </a:pPr>
             <a:r>
@@ -2653,9 +2585,9 @@
                 <a:solidFill>
                   <a:srgbClr val="6B7280"/>
                 </a:solidFill>
-                <a:latin typeface="Calibri" pitchFamily="34" charset="0"/>
-                <a:ea typeface="Calibri" pitchFamily="34" charset="-122"/>
-                <a:cs typeface="Calibri" pitchFamily="34" charset="-120"/>
+                <a:latin typeface="Calibri" panose="020F0502020204030204" pitchFamily="34" charset="0"/>
+                <a:ea typeface="Calibri" panose="020F0502020204030204" pitchFamily="34" charset="-122"/>
+                <a:cs typeface="Calibri" panose="020F0502020204030204" pitchFamily="34" charset="-120"/>
               </a:rPr>
               <a:t>Modern Enterprise Software Engineering  |  ÉSTIAM  |  Day 1</a:t>
             </a:r>
@@ -2672,13 +2604,14 @@
 </file>
 
 <file path=ppt/slides/slide11.xml><?xml version="1.0" encoding="utf-8"?>
-<p:sld xmlns:a="http://schemas.openxmlformats.org/drawingml/2006/main" xmlns:p="http://schemas.openxmlformats.org/presentationml/2006/main" xmlns:r="http://schemas.openxmlformats.org/officeDocument/2006/relationships">
+<p:sld xmlns:a="http://schemas.openxmlformats.org/drawingml/2006/main" xmlns:r="http://schemas.openxmlformats.org/officeDocument/2006/relationships" xmlns:p="http://schemas.openxmlformats.org/presentationml/2006/main">
   <p:cSld>
     <p:bg>
       <p:bgPr>
         <a:solidFill>
           <a:srgbClr val="FFFFFF"/>
         </a:solidFill>
+        <a:effectLst/>
       </p:bgPr>
     </p:bg>
     <p:spTree>
@@ -2705,7 +2638,7 @@
           <a:noFill/>
         </p:spPr>
         <p:txBody>
-          <a:bodyPr wrap="square" lIns="0" rIns="0" tIns="0" bIns="0">
+          <a:bodyPr wrap="square" lIns="0" tIns="0" rIns="0" bIns="0">
             <a:spAutoFit/>
           </a:bodyPr>
           <a:lstStyle/>
@@ -2715,10 +2648,16 @@
                 <a:solidFill>
                   <a:srgbClr val="F2A93B"/>
                 </a:solidFill>
-                <a:latin typeface="Calibri"/>
+                <a:latin typeface="Calibri" panose="020F0502020204030204"/>
               </a:rPr>
               <a:t>STEP 09</a:t>
             </a:r>
+            <a:endParaRPr sz="1300" b="1" spc="200">
+              <a:solidFill>
+                <a:srgbClr val="F2A93B"/>
+              </a:solidFill>
+              <a:latin typeface="Calibri" panose="020F0502020204030204"/>
+            </a:endParaRPr>
           </a:p>
         </p:txBody>
       </p:sp>
@@ -2739,7 +2678,7 @@
           <a:noFill/>
         </p:spPr>
         <p:txBody>
-          <a:bodyPr wrap="square" lIns="0" rIns="0" tIns="0" bIns="0">
+          <a:bodyPr wrap="square" lIns="0" tIns="0" rIns="0" bIns="0">
             <a:spAutoFit/>
           </a:bodyPr>
           <a:lstStyle/>
@@ -2749,10 +2688,16 @@
                 <a:solidFill>
                   <a:srgbClr val="1E2761"/>
                 </a:solidFill>
-                <a:latin typeface="Cambria"/>
+                <a:latin typeface="Cambria" panose="02040503050406030204"/>
               </a:rPr>
               <a:t>Azure free account — step 1 of 3</a:t>
             </a:r>
+            <a:endParaRPr sz="3000" b="1">
+              <a:solidFill>
+                <a:srgbClr val="1E2761"/>
+              </a:solidFill>
+              <a:latin typeface="Cambria" panose="02040503050406030204"/>
+            </a:endParaRPr>
           </a:p>
         </p:txBody>
       </p:sp>
@@ -2773,7 +2718,7 @@
           <a:noFill/>
         </p:spPr>
         <p:txBody>
-          <a:bodyPr wrap="square" lIns="0" rIns="0" tIns="0" bIns="0">
+          <a:bodyPr wrap="square" lIns="0" tIns="0" rIns="0" bIns="0">
             <a:spAutoFit/>
           </a:bodyPr>
           <a:lstStyle/>
@@ -2783,10 +2728,16 @@
                 <a:solidFill>
                   <a:srgbClr val="1F2430"/>
                 </a:solidFill>
-                <a:latin typeface="Calibri"/>
+                <a:latin typeface="Calibri" panose="020F0502020204030204"/>
               </a:rPr>
               <a:t>Profile information: personal use, country/region, name, notification email, phone. The country/region choice is permanent and sets the billing currency.</a:t>
             </a:r>
+            <a:endParaRPr sz="1400" b="0">
+              <a:solidFill>
+                <a:srgbClr val="1F2430"/>
+              </a:solidFill>
+              <a:latin typeface="Calibri" panose="020F0502020204030204"/>
+            </a:endParaRPr>
           </a:p>
         </p:txBody>
       </p:sp>
@@ -2799,7 +2750,7 @@
           <p:nvPr/>
         </p:nvPicPr>
         <p:blipFill>
-          <a:blip r:embed="rId2"/>
+          <a:blip r:embed="rId1"/>
           <a:stretch>
             <a:fillRect/>
           </a:stretch>
@@ -2834,13 +2785,12 @@
             <a:avLst/>
           </a:prstGeom>
           <a:noFill/>
-          <a:ln/>
         </p:spPr>
         <p:txBody>
           <a:bodyPr wrap="square" lIns="0" tIns="0" rIns="0" bIns="0" rtlCol="0" anchor="ctr"/>
           <a:lstStyle/>
           <a:p>
-            <a:pPr algn="l" indent="0" marL="0">
+            <a:pPr marL="0" indent="0" algn="l">
               <a:buNone/>
             </a:pPr>
             <a:r>
@@ -2848,9 +2798,9 @@
                 <a:solidFill>
                   <a:srgbClr val="6B7280"/>
                 </a:solidFill>
-                <a:latin typeface="Calibri" pitchFamily="34" charset="0"/>
-                <a:ea typeface="Calibri" pitchFamily="34" charset="-122"/>
-                <a:cs typeface="Calibri" pitchFamily="34" charset="-120"/>
+                <a:latin typeface="Calibri" panose="020F0502020204030204" pitchFamily="34" charset="0"/>
+                <a:ea typeface="Calibri" panose="020F0502020204030204" pitchFamily="34" charset="-122"/>
+                <a:cs typeface="Calibri" panose="020F0502020204030204" pitchFamily="34" charset="-120"/>
               </a:rPr>
               <a:t>Modern Enterprise Software Engineering  |  ÉSTIAM  |  Day 1</a:t>
             </a:r>
@@ -2867,13 +2817,14 @@
 </file>
 
 <file path=ppt/slides/slide12.xml><?xml version="1.0" encoding="utf-8"?>
-<p:sld xmlns:a="http://schemas.openxmlformats.org/drawingml/2006/main" xmlns:p="http://schemas.openxmlformats.org/presentationml/2006/main" xmlns:r="http://schemas.openxmlformats.org/officeDocument/2006/relationships">
+<p:sld xmlns:a="http://schemas.openxmlformats.org/drawingml/2006/main" xmlns:r="http://schemas.openxmlformats.org/officeDocument/2006/relationships" xmlns:p="http://schemas.openxmlformats.org/presentationml/2006/main">
   <p:cSld>
     <p:bg>
       <p:bgPr>
         <a:solidFill>
           <a:srgbClr val="FFFFFF"/>
         </a:solidFill>
+        <a:effectLst/>
       </p:bgPr>
     </p:bg>
     <p:spTree>
@@ -2900,7 +2851,7 @@
           <a:noFill/>
         </p:spPr>
         <p:txBody>
-          <a:bodyPr wrap="square" lIns="0" rIns="0" tIns="0" bIns="0">
+          <a:bodyPr wrap="square" lIns="0" tIns="0" rIns="0" bIns="0">
             <a:spAutoFit/>
           </a:bodyPr>
           <a:lstStyle/>
@@ -2910,10 +2861,16 @@
                 <a:solidFill>
                   <a:srgbClr val="F2A93B"/>
                 </a:solidFill>
-                <a:latin typeface="Calibri"/>
+                <a:latin typeface="Calibri" panose="020F0502020204030204"/>
               </a:rPr>
               <a:t>STEP 10</a:t>
             </a:r>
+            <a:endParaRPr sz="1300" b="1" spc="200">
+              <a:solidFill>
+                <a:srgbClr val="F2A93B"/>
+              </a:solidFill>
+              <a:latin typeface="Calibri" panose="020F0502020204030204"/>
+            </a:endParaRPr>
           </a:p>
         </p:txBody>
       </p:sp>
@@ -2934,7 +2891,7 @@
           <a:noFill/>
         </p:spPr>
         <p:txBody>
-          <a:bodyPr wrap="square" lIns="0" rIns="0" tIns="0" bIns="0">
+          <a:bodyPr wrap="square" lIns="0" tIns="0" rIns="0" bIns="0">
             <a:spAutoFit/>
           </a:bodyPr>
           <a:lstStyle/>
@@ -2944,10 +2901,16 @@
                 <a:solidFill>
                   <a:srgbClr val="1E2761"/>
                 </a:solidFill>
-                <a:latin typeface="Cambria"/>
+                <a:latin typeface="Cambria" panose="02040503050406030204"/>
               </a:rPr>
               <a:t>Step 3 of 3 — card verification</a:t>
             </a:r>
+            <a:endParaRPr sz="3000" b="1">
+              <a:solidFill>
+                <a:srgbClr val="1E2761"/>
+              </a:solidFill>
+              <a:latin typeface="Cambria" panose="02040503050406030204"/>
+            </a:endParaRPr>
           </a:p>
         </p:txBody>
       </p:sp>
@@ -2968,7 +2931,7 @@
           <a:noFill/>
         </p:spPr>
         <p:txBody>
-          <a:bodyPr wrap="square" lIns="0" rIns="0" tIns="0" bIns="0">
+          <a:bodyPr wrap="square" lIns="0" tIns="0" rIns="0" bIns="0">
             <a:spAutoFit/>
           </a:bodyPr>
           <a:lstStyle/>
@@ -2978,10 +2941,16 @@
                 <a:solidFill>
                   <a:srgbClr val="1F2430"/>
                 </a:solidFill>
-                <a:latin typeface="Calibri"/>
+                <a:latin typeface="Calibri" panose="020F0502020204030204"/>
               </a:rPr>
               <a:t>A real card is required for identity verification. It is not charged unless you move to pay-as-you-go; a small temporary authorisation may appear and reverse.</a:t>
             </a:r>
+            <a:endParaRPr sz="1400" b="0">
+              <a:solidFill>
+                <a:srgbClr val="1F2430"/>
+              </a:solidFill>
+              <a:latin typeface="Calibri" panose="020F0502020204030204"/>
+            </a:endParaRPr>
           </a:p>
         </p:txBody>
       </p:sp>
@@ -2994,7 +2963,7 @@
           <p:nvPr/>
         </p:nvPicPr>
         <p:blipFill>
-          <a:blip r:embed="rId2"/>
+          <a:blip r:embed="rId1"/>
           <a:stretch>
             <a:fillRect/>
           </a:stretch>
@@ -3029,13 +2998,12 @@
             <a:avLst/>
           </a:prstGeom>
           <a:noFill/>
-          <a:ln/>
         </p:spPr>
         <p:txBody>
           <a:bodyPr wrap="square" lIns="0" tIns="0" rIns="0" bIns="0" rtlCol="0" anchor="ctr"/>
           <a:lstStyle/>
           <a:p>
-            <a:pPr algn="l" indent="0" marL="0">
+            <a:pPr marL="0" indent="0" algn="l">
               <a:buNone/>
             </a:pPr>
             <a:r>
@@ -3043,9 +3011,9 @@
                 <a:solidFill>
                   <a:srgbClr val="6B7280"/>
                 </a:solidFill>
-                <a:latin typeface="Calibri" pitchFamily="34" charset="0"/>
-                <a:ea typeface="Calibri" pitchFamily="34" charset="-122"/>
-                <a:cs typeface="Calibri" pitchFamily="34" charset="-120"/>
+                <a:latin typeface="Calibri" panose="020F0502020204030204" pitchFamily="34" charset="0"/>
+                <a:ea typeface="Calibri" panose="020F0502020204030204" pitchFamily="34" charset="-122"/>
+                <a:cs typeface="Calibri" panose="020F0502020204030204" pitchFamily="34" charset="-120"/>
               </a:rPr>
               <a:t>Modern Enterprise Software Engineering  |  ÉSTIAM  |  Day 1</a:t>
             </a:r>
@@ -3062,13 +3030,14 @@
 </file>
 
 <file path=ppt/slides/slide13.xml><?xml version="1.0" encoding="utf-8"?>
-<p:sld xmlns:a="http://schemas.openxmlformats.org/drawingml/2006/main" xmlns:p="http://schemas.openxmlformats.org/presentationml/2006/main" xmlns:r="http://schemas.openxmlformats.org/officeDocument/2006/relationships">
+<p:sld xmlns:a="http://schemas.openxmlformats.org/drawingml/2006/main" xmlns:r="http://schemas.openxmlformats.org/officeDocument/2006/relationships" xmlns:p="http://schemas.openxmlformats.org/presentationml/2006/main">
   <p:cSld>
     <p:bg>
       <p:bgPr>
         <a:solidFill>
           <a:srgbClr val="FFFFFF"/>
         </a:solidFill>
+        <a:effectLst/>
       </p:bgPr>
     </p:bg>
     <p:spTree>
@@ -3095,7 +3064,7 @@
           <a:noFill/>
         </p:spPr>
         <p:txBody>
-          <a:bodyPr wrap="square" lIns="0" rIns="0" tIns="0" bIns="0">
+          <a:bodyPr wrap="square" lIns="0" tIns="0" rIns="0" bIns="0">
             <a:spAutoFit/>
           </a:bodyPr>
           <a:lstStyle/>
@@ -3105,10 +3074,16 @@
                 <a:solidFill>
                   <a:srgbClr val="F2A93B"/>
                 </a:solidFill>
-                <a:latin typeface="Calibri"/>
+                <a:latin typeface="Calibri" panose="020F0502020204030204"/>
               </a:rPr>
               <a:t>STEP 11</a:t>
             </a:r>
+            <a:endParaRPr sz="1300" b="1" spc="200">
+              <a:solidFill>
+                <a:srgbClr val="F2A93B"/>
+              </a:solidFill>
+              <a:latin typeface="Calibri" panose="020F0502020204030204"/>
+            </a:endParaRPr>
           </a:p>
         </p:txBody>
       </p:sp>
@@ -3129,7 +3104,7 @@
           <a:noFill/>
         </p:spPr>
         <p:txBody>
-          <a:bodyPr wrap="square" lIns="0" rIns="0" tIns="0" bIns="0">
+          <a:bodyPr wrap="square" lIns="0" tIns="0" rIns="0" bIns="0">
             <a:spAutoFit/>
           </a:bodyPr>
           <a:lstStyle/>
@@ -3139,10 +3114,16 @@
                 <a:solidFill>
                   <a:srgbClr val="1E2761"/>
                 </a:solidFill>
-                <a:latin typeface="Cambria"/>
+                <a:latin typeface="Cambria" panose="02040503050406030204"/>
               </a:rPr>
               <a:t>Provisioning the account</a:t>
             </a:r>
+            <a:endParaRPr sz="3000" b="1">
+              <a:solidFill>
+                <a:srgbClr val="1E2761"/>
+              </a:solidFill>
+              <a:latin typeface="Cambria" panose="02040503050406030204"/>
+            </a:endParaRPr>
           </a:p>
         </p:txBody>
       </p:sp>
@@ -3163,7 +3144,7 @@
           <a:noFill/>
         </p:spPr>
         <p:txBody>
-          <a:bodyPr wrap="square" lIns="0" rIns="0" tIns="0" bIns="0">
+          <a:bodyPr wrap="square" lIns="0" tIns="0" rIns="0" bIns="0">
             <a:spAutoFit/>
           </a:bodyPr>
           <a:lstStyle/>
@@ -3173,10 +3154,16 @@
                 <a:solidFill>
                   <a:srgbClr val="1F2430"/>
                 </a:solidFill>
-                <a:latin typeface="Calibri"/>
+                <a:latin typeface="Calibri" panose="020F0502020204030204"/>
               </a:rPr>
               <a:t>Takes a couple of minutes. Check email — some accounts need an extra verification step before Azure finishes.</a:t>
             </a:r>
+            <a:endParaRPr sz="1400" b="0">
+              <a:solidFill>
+                <a:srgbClr val="1F2430"/>
+              </a:solidFill>
+              <a:latin typeface="Calibri" panose="020F0502020204030204"/>
+            </a:endParaRPr>
           </a:p>
         </p:txBody>
       </p:sp>
@@ -3189,7 +3176,7 @@
           <p:nvPr/>
         </p:nvPicPr>
         <p:blipFill>
-          <a:blip r:embed="rId2"/>
+          <a:blip r:embed="rId1"/>
           <a:stretch>
             <a:fillRect/>
           </a:stretch>
@@ -3224,13 +3211,12 @@
             <a:avLst/>
           </a:prstGeom>
           <a:noFill/>
-          <a:ln/>
         </p:spPr>
         <p:txBody>
           <a:bodyPr wrap="square" lIns="0" tIns="0" rIns="0" bIns="0" rtlCol="0" anchor="ctr"/>
           <a:lstStyle/>
           <a:p>
-            <a:pPr algn="l" indent="0" marL="0">
+            <a:pPr marL="0" indent="0" algn="l">
               <a:buNone/>
             </a:pPr>
             <a:r>
@@ -3238,9 +3224,9 @@
                 <a:solidFill>
                   <a:srgbClr val="6B7280"/>
                 </a:solidFill>
-                <a:latin typeface="Calibri" pitchFamily="34" charset="0"/>
-                <a:ea typeface="Calibri" pitchFamily="34" charset="-122"/>
-                <a:cs typeface="Calibri" pitchFamily="34" charset="-120"/>
+                <a:latin typeface="Calibri" panose="020F0502020204030204" pitchFamily="34" charset="0"/>
+                <a:ea typeface="Calibri" panose="020F0502020204030204" pitchFamily="34" charset="-122"/>
+                <a:cs typeface="Calibri" panose="020F0502020204030204" pitchFamily="34" charset="-120"/>
               </a:rPr>
               <a:t>Modern Enterprise Software Engineering  |  ÉSTIAM  |  Day 1</a:t>
             </a:r>
@@ -3257,13 +3243,14 @@
 </file>
 
 <file path=ppt/slides/slide14.xml><?xml version="1.0" encoding="utf-8"?>
-<p:sld xmlns:a="http://schemas.openxmlformats.org/drawingml/2006/main" xmlns:p="http://schemas.openxmlformats.org/presentationml/2006/main" xmlns:r="http://schemas.openxmlformats.org/officeDocument/2006/relationships">
+<p:sld xmlns:a="http://schemas.openxmlformats.org/drawingml/2006/main" xmlns:r="http://schemas.openxmlformats.org/officeDocument/2006/relationships" xmlns:p="http://schemas.openxmlformats.org/presentationml/2006/main">
   <p:cSld>
     <p:bg>
       <p:bgPr>
         <a:solidFill>
           <a:srgbClr val="FFFFFF"/>
         </a:solidFill>
+        <a:effectLst/>
       </p:bgPr>
     </p:bg>
     <p:spTree>
@@ -3290,7 +3277,7 @@
           <a:noFill/>
         </p:spPr>
         <p:txBody>
-          <a:bodyPr wrap="square" lIns="0" rIns="0" tIns="0" bIns="0">
+          <a:bodyPr wrap="square" lIns="0" tIns="0" rIns="0" bIns="0">
             <a:spAutoFit/>
           </a:bodyPr>
           <a:lstStyle/>
@@ -3300,10 +3287,16 @@
                 <a:solidFill>
                   <a:srgbClr val="F2A93B"/>
                 </a:solidFill>
-                <a:latin typeface="Calibri"/>
+                <a:latin typeface="Calibri" panose="020F0502020204030204"/>
               </a:rPr>
               <a:t>STEP 12</a:t>
             </a:r>
+            <a:endParaRPr sz="1300" b="1" spc="200">
+              <a:solidFill>
+                <a:srgbClr val="F2A93B"/>
+              </a:solidFill>
+              <a:latin typeface="Calibri" panose="020F0502020204030204"/>
+            </a:endParaRPr>
           </a:p>
         </p:txBody>
       </p:sp>
@@ -3324,7 +3317,7 @@
           <a:noFill/>
         </p:spPr>
         <p:txBody>
-          <a:bodyPr wrap="square" lIns="0" rIns="0" tIns="0" bIns="0">
+          <a:bodyPr wrap="square" lIns="0" tIns="0" rIns="0" bIns="0">
             <a:spAutoFit/>
           </a:bodyPr>
           <a:lstStyle/>
@@ -3334,10 +3327,16 @@
                 <a:solidFill>
                   <a:srgbClr val="1E2761"/>
                 </a:solidFill>
-                <a:latin typeface="Cambria"/>
+                <a:latin typeface="Cambria" panose="02040503050406030204"/>
               </a:rPr>
               <a:t>When sign-in fails: state_mismatch</a:t>
             </a:r>
+            <a:endParaRPr sz="3000" b="1">
+              <a:solidFill>
+                <a:srgbClr val="1E2761"/>
+              </a:solidFill>
+              <a:latin typeface="Cambria" panose="02040503050406030204"/>
+            </a:endParaRPr>
           </a:p>
         </p:txBody>
       </p:sp>
@@ -3358,7 +3357,7 @@
           <a:noFill/>
         </p:spPr>
         <p:txBody>
-          <a:bodyPr wrap="square" lIns="0" rIns="0" tIns="0" bIns="0">
+          <a:bodyPr wrap="square" lIns="0" tIns="0" rIns="0" bIns="0">
             <a:spAutoFit/>
           </a:bodyPr>
           <a:lstStyle/>
@@ -3368,10 +3367,16 @@
                 <a:solidFill>
                   <a:srgbClr val="1F2430"/>
                 </a:solidFill>
-                <a:latin typeface="Calibri"/>
+                <a:latin typeface="Calibri" panose="020F0502020204030204"/>
               </a:rPr>
               <a:t>Not a broken account — a stale auth state in the browser. Fix: sign out, clear cookies for the site, or reopen in a private window.</a:t>
             </a:r>
+            <a:endParaRPr sz="1400" b="0">
+              <a:solidFill>
+                <a:srgbClr val="1F2430"/>
+              </a:solidFill>
+              <a:latin typeface="Calibri" panose="020F0502020204030204"/>
+            </a:endParaRPr>
           </a:p>
         </p:txBody>
       </p:sp>
@@ -3384,7 +3389,7 @@
           <p:nvPr/>
         </p:nvPicPr>
         <p:blipFill>
-          <a:blip r:embed="rId2"/>
+          <a:blip r:embed="rId1"/>
           <a:stretch>
             <a:fillRect/>
           </a:stretch>
@@ -3419,13 +3424,12 @@
             <a:avLst/>
           </a:prstGeom>
           <a:noFill/>
-          <a:ln/>
         </p:spPr>
         <p:txBody>
           <a:bodyPr wrap="square" lIns="0" tIns="0" rIns="0" bIns="0" rtlCol="0" anchor="ctr"/>
           <a:lstStyle/>
           <a:p>
-            <a:pPr algn="l" indent="0" marL="0">
+            <a:pPr marL="0" indent="0" algn="l">
               <a:buNone/>
             </a:pPr>
             <a:r>
@@ -3433,9 +3437,9 @@
                 <a:solidFill>
                   <a:srgbClr val="6B7280"/>
                 </a:solidFill>
-                <a:latin typeface="Calibri" pitchFamily="34" charset="0"/>
-                <a:ea typeface="Calibri" pitchFamily="34" charset="-122"/>
-                <a:cs typeface="Calibri" pitchFamily="34" charset="-120"/>
+                <a:latin typeface="Calibri" panose="020F0502020204030204" pitchFamily="34" charset="0"/>
+                <a:ea typeface="Calibri" panose="020F0502020204030204" pitchFamily="34" charset="-122"/>
+                <a:cs typeface="Calibri" panose="020F0502020204030204" pitchFamily="34" charset="-120"/>
               </a:rPr>
               <a:t>Modern Enterprise Software Engineering  |  ÉSTIAM  |  Day 1</a:t>
             </a:r>
@@ -3452,13 +3456,14 @@
 </file>
 
 <file path=ppt/slides/slide15.xml><?xml version="1.0" encoding="utf-8"?>
-<p:sld xmlns:a="http://schemas.openxmlformats.org/drawingml/2006/main" xmlns:p="http://schemas.openxmlformats.org/presentationml/2006/main" xmlns:r="http://schemas.openxmlformats.org/officeDocument/2006/relationships">
+<p:sld xmlns:a="http://schemas.openxmlformats.org/drawingml/2006/main" xmlns:r="http://schemas.openxmlformats.org/officeDocument/2006/relationships" xmlns:p="http://schemas.openxmlformats.org/presentationml/2006/main">
   <p:cSld>
     <p:bg>
       <p:bgPr>
         <a:solidFill>
           <a:srgbClr val="FFFFFF"/>
         </a:solidFill>
+        <a:effectLst/>
       </p:bgPr>
     </p:bg>
     <p:spTree>
@@ -3485,7 +3490,7 @@
           <a:noFill/>
         </p:spPr>
         <p:txBody>
-          <a:bodyPr wrap="square" lIns="0" rIns="0" tIns="0" bIns="0">
+          <a:bodyPr wrap="square" lIns="0" tIns="0" rIns="0" bIns="0">
             <a:spAutoFit/>
           </a:bodyPr>
           <a:lstStyle/>
@@ -3495,10 +3500,16 @@
                 <a:solidFill>
                   <a:srgbClr val="F2A93B"/>
                 </a:solidFill>
-                <a:latin typeface="Calibri"/>
+                <a:latin typeface="Calibri" panose="020F0502020204030204"/>
               </a:rPr>
               <a:t>STEP 13</a:t>
             </a:r>
+            <a:endParaRPr sz="1300" b="1" spc="200">
+              <a:solidFill>
+                <a:srgbClr val="F2A93B"/>
+              </a:solidFill>
+              <a:latin typeface="Calibri" panose="020F0502020204030204"/>
+            </a:endParaRPr>
           </a:p>
         </p:txBody>
       </p:sp>
@@ -3519,7 +3530,7 @@
           <a:noFill/>
         </p:spPr>
         <p:txBody>
-          <a:bodyPr wrap="square" lIns="0" rIns="0" tIns="0" bIns="0">
+          <a:bodyPr wrap="square" lIns="0" tIns="0" rIns="0" bIns="0">
             <a:spAutoFit/>
           </a:bodyPr>
           <a:lstStyle/>
@@ -3529,10 +3540,16 @@
                 <a:solidFill>
                   <a:srgbClr val="1E2761"/>
                 </a:solidFill>
-                <a:latin typeface="Cambria"/>
+                <a:latin typeface="Cambria" panose="02040503050406030204"/>
               </a:rPr>
               <a:t>First sign-in to the portal</a:t>
             </a:r>
+            <a:endParaRPr sz="3000" b="1">
+              <a:solidFill>
+                <a:srgbClr val="1E2761"/>
+              </a:solidFill>
+              <a:latin typeface="Cambria" panose="02040503050406030204"/>
+            </a:endParaRPr>
           </a:p>
         </p:txBody>
       </p:sp>
@@ -3553,7 +3570,7 @@
           <a:noFill/>
         </p:spPr>
         <p:txBody>
-          <a:bodyPr wrap="square" lIns="0" rIns="0" tIns="0" bIns="0">
+          <a:bodyPr wrap="square" lIns="0" tIns="0" rIns="0" bIns="0">
             <a:spAutoFit/>
           </a:bodyPr>
           <a:lstStyle/>
@@ -3563,10 +3580,16 @@
                 <a:solidFill>
                   <a:srgbClr val="1F2430"/>
                 </a:solidFill>
-                <a:latin typeface="Calibri"/>
+                <a:latin typeface="Calibri" panose="020F0502020204030204"/>
               </a:rPr>
               <a:t>'You don't have permission to view credits' right after sign-up is normal — billing takes a few minutes to propagate. Refresh later.</a:t>
             </a:r>
+            <a:endParaRPr sz="1400" b="0">
+              <a:solidFill>
+                <a:srgbClr val="1F2430"/>
+              </a:solidFill>
+              <a:latin typeface="Calibri" panose="020F0502020204030204"/>
+            </a:endParaRPr>
           </a:p>
         </p:txBody>
       </p:sp>
@@ -3579,7 +3602,7 @@
           <p:nvPr/>
         </p:nvPicPr>
         <p:blipFill>
-          <a:blip r:embed="rId2"/>
+          <a:blip r:embed="rId1"/>
           <a:stretch>
             <a:fillRect/>
           </a:stretch>
@@ -3614,13 +3637,12 @@
             <a:avLst/>
           </a:prstGeom>
           <a:noFill/>
-          <a:ln/>
         </p:spPr>
         <p:txBody>
           <a:bodyPr wrap="square" lIns="0" tIns="0" rIns="0" bIns="0" rtlCol="0" anchor="ctr"/>
           <a:lstStyle/>
           <a:p>
-            <a:pPr algn="l" indent="0" marL="0">
+            <a:pPr marL="0" indent="0" algn="l">
               <a:buNone/>
             </a:pPr>
             <a:r>
@@ -3628,9 +3650,9 @@
                 <a:solidFill>
                   <a:srgbClr val="6B7280"/>
                 </a:solidFill>
-                <a:latin typeface="Calibri" pitchFamily="34" charset="0"/>
-                <a:ea typeface="Calibri" pitchFamily="34" charset="-122"/>
-                <a:cs typeface="Calibri" pitchFamily="34" charset="-120"/>
+                <a:latin typeface="Calibri" panose="020F0502020204030204" pitchFamily="34" charset="0"/>
+                <a:ea typeface="Calibri" panose="020F0502020204030204" pitchFamily="34" charset="-122"/>
+                <a:cs typeface="Calibri" panose="020F0502020204030204" pitchFamily="34" charset="-120"/>
               </a:rPr>
               <a:t>Modern Enterprise Software Engineering  |  ÉSTIAM  |  Day 1</a:t>
             </a:r>
@@ -3647,13 +3669,14 @@
 </file>
 
 <file path=ppt/slides/slide16.xml><?xml version="1.0" encoding="utf-8"?>
-<p:sld xmlns:a="http://schemas.openxmlformats.org/drawingml/2006/main" xmlns:p="http://schemas.openxmlformats.org/presentationml/2006/main" xmlns:r="http://schemas.openxmlformats.org/officeDocument/2006/relationships">
+<p:sld xmlns:a="http://schemas.openxmlformats.org/drawingml/2006/main" xmlns:r="http://schemas.openxmlformats.org/officeDocument/2006/relationships" xmlns:p="http://schemas.openxmlformats.org/presentationml/2006/main">
   <p:cSld>
     <p:bg>
       <p:bgPr>
         <a:solidFill>
           <a:srgbClr val="FFFFFF"/>
         </a:solidFill>
+        <a:effectLst/>
       </p:bgPr>
     </p:bg>
     <p:spTree>
@@ -3680,7 +3703,7 @@
           <a:noFill/>
         </p:spPr>
         <p:txBody>
-          <a:bodyPr wrap="square" lIns="0" rIns="0" tIns="0" bIns="0">
+          <a:bodyPr wrap="square" lIns="0" tIns="0" rIns="0" bIns="0">
             <a:spAutoFit/>
           </a:bodyPr>
           <a:lstStyle/>
@@ -3690,10 +3713,16 @@
                 <a:solidFill>
                   <a:srgbClr val="F2A93B"/>
                 </a:solidFill>
-                <a:latin typeface="Calibri"/>
+                <a:latin typeface="Calibri" panose="020F0502020204030204"/>
               </a:rPr>
               <a:t>STEP 14</a:t>
             </a:r>
+            <a:endParaRPr sz="1300" b="1" spc="200">
+              <a:solidFill>
+                <a:srgbClr val="F2A93B"/>
+              </a:solidFill>
+              <a:latin typeface="Calibri" panose="020F0502020204030204"/>
+            </a:endParaRPr>
           </a:p>
         </p:txBody>
       </p:sp>
@@ -3714,7 +3743,7 @@
           <a:noFill/>
         </p:spPr>
         <p:txBody>
-          <a:bodyPr wrap="square" lIns="0" rIns="0" tIns="0" bIns="0">
+          <a:bodyPr wrap="square" lIns="0" tIns="0" rIns="0" bIns="0">
             <a:spAutoFit/>
           </a:bodyPr>
           <a:lstStyle/>
@@ -3724,10 +3753,16 @@
                 <a:solidFill>
                   <a:srgbClr val="1E2761"/>
                 </a:solidFill>
-                <a:latin typeface="Cambria"/>
+                <a:latin typeface="Cambria" panose="02040503050406030204"/>
               </a:rPr>
               <a:t>Find Cost Management + Billing</a:t>
             </a:r>
+            <a:endParaRPr sz="3000" b="1">
+              <a:solidFill>
+                <a:srgbClr val="1E2761"/>
+              </a:solidFill>
+              <a:latin typeface="Cambria" panose="02040503050406030204"/>
+            </a:endParaRPr>
           </a:p>
         </p:txBody>
       </p:sp>
@@ -3748,7 +3783,7 @@
           <a:noFill/>
         </p:spPr>
         <p:txBody>
-          <a:bodyPr wrap="square" lIns="0" rIns="0" tIns="0" bIns="0">
+          <a:bodyPr wrap="square" lIns="0" tIns="0" rIns="0" bIns="0">
             <a:spAutoFit/>
           </a:bodyPr>
           <a:lstStyle/>
@@ -3758,10 +3793,16 @@
                 <a:solidFill>
                   <a:srgbClr val="1F2430"/>
                 </a:solidFill>
-                <a:latin typeface="Calibri"/>
+                <a:latin typeface="Calibri" panose="020F0502020204030204"/>
               </a:rPr>
               <a:t>Portal menu, left-hand rail. This is the first thing to configure — before creating a single resource.</a:t>
             </a:r>
+            <a:endParaRPr sz="1400" b="0">
+              <a:solidFill>
+                <a:srgbClr val="1F2430"/>
+              </a:solidFill>
+              <a:latin typeface="Calibri" panose="020F0502020204030204"/>
+            </a:endParaRPr>
           </a:p>
         </p:txBody>
       </p:sp>
@@ -3774,7 +3815,7 @@
           <p:nvPr/>
         </p:nvPicPr>
         <p:blipFill>
-          <a:blip r:embed="rId2"/>
+          <a:blip r:embed="rId1"/>
           <a:stretch>
             <a:fillRect/>
           </a:stretch>
@@ -3809,13 +3850,12 @@
             <a:avLst/>
           </a:prstGeom>
           <a:noFill/>
-          <a:ln/>
         </p:spPr>
         <p:txBody>
           <a:bodyPr wrap="square" lIns="0" tIns="0" rIns="0" bIns="0" rtlCol="0" anchor="ctr"/>
           <a:lstStyle/>
           <a:p>
-            <a:pPr algn="l" indent="0" marL="0">
+            <a:pPr marL="0" indent="0" algn="l">
               <a:buNone/>
             </a:pPr>
             <a:r>
@@ -3823,9 +3863,9 @@
                 <a:solidFill>
                   <a:srgbClr val="6B7280"/>
                 </a:solidFill>
-                <a:latin typeface="Calibri" pitchFamily="34" charset="0"/>
-                <a:ea typeface="Calibri" pitchFamily="34" charset="-122"/>
-                <a:cs typeface="Calibri" pitchFamily="34" charset="-120"/>
+                <a:latin typeface="Calibri" panose="020F0502020204030204" pitchFamily="34" charset="0"/>
+                <a:ea typeface="Calibri" panose="020F0502020204030204" pitchFamily="34" charset="-122"/>
+                <a:cs typeface="Calibri" panose="020F0502020204030204" pitchFamily="34" charset="-120"/>
               </a:rPr>
               <a:t>Modern Enterprise Software Engineering  |  ÉSTIAM  |  Day 1</a:t>
             </a:r>
@@ -3842,13 +3882,14 @@
 </file>
 
 <file path=ppt/slides/slide17.xml><?xml version="1.0" encoding="utf-8"?>
-<p:sld xmlns:a="http://schemas.openxmlformats.org/drawingml/2006/main" xmlns:p="http://schemas.openxmlformats.org/presentationml/2006/main" xmlns:r="http://schemas.openxmlformats.org/officeDocument/2006/relationships">
+<p:sld xmlns:a="http://schemas.openxmlformats.org/drawingml/2006/main" xmlns:r="http://schemas.openxmlformats.org/officeDocument/2006/relationships" xmlns:p="http://schemas.openxmlformats.org/presentationml/2006/main">
   <p:cSld>
     <p:bg>
       <p:bgPr>
         <a:solidFill>
           <a:srgbClr val="FFFFFF"/>
         </a:solidFill>
+        <a:effectLst/>
       </p:bgPr>
     </p:bg>
     <p:spTree>
@@ -3875,7 +3916,7 @@
           <a:noFill/>
         </p:spPr>
         <p:txBody>
-          <a:bodyPr wrap="square" lIns="0" rIns="0" tIns="0" bIns="0">
+          <a:bodyPr wrap="square" lIns="0" tIns="0" rIns="0" bIns="0">
             <a:spAutoFit/>
           </a:bodyPr>
           <a:lstStyle/>
@@ -3885,10 +3926,16 @@
                 <a:solidFill>
                   <a:srgbClr val="F2A93B"/>
                 </a:solidFill>
-                <a:latin typeface="Calibri"/>
+                <a:latin typeface="Calibri" panose="020F0502020204030204"/>
               </a:rPr>
               <a:t>STEP 15</a:t>
             </a:r>
+            <a:endParaRPr sz="1300" b="1" spc="200">
+              <a:solidFill>
+                <a:srgbClr val="F2A93B"/>
+              </a:solidFill>
+              <a:latin typeface="Calibri" panose="020F0502020204030204"/>
+            </a:endParaRPr>
           </a:p>
         </p:txBody>
       </p:sp>
@@ -3909,7 +3956,7 @@
           <a:noFill/>
         </p:spPr>
         <p:txBody>
-          <a:bodyPr wrap="square" lIns="0" rIns="0" tIns="0" bIns="0">
+          <a:bodyPr wrap="square" lIns="0" tIns="0" rIns="0" bIns="0">
             <a:spAutoFit/>
           </a:bodyPr>
           <a:lstStyle/>
@@ -3919,10 +3966,16 @@
                 <a:solidFill>
                   <a:srgbClr val="1E2761"/>
                 </a:solidFill>
-                <a:latin typeface="Cambria"/>
+                <a:latin typeface="Cambria" panose="02040503050406030204"/>
               </a:rPr>
               <a:t>Billing scopes</a:t>
             </a:r>
+            <a:endParaRPr sz="3000" b="1">
+              <a:solidFill>
+                <a:srgbClr val="1E2761"/>
+              </a:solidFill>
+              <a:latin typeface="Cambria" panose="02040503050406030204"/>
+            </a:endParaRPr>
           </a:p>
         </p:txBody>
       </p:sp>
@@ -3943,7 +3996,7 @@
           <a:noFill/>
         </p:spPr>
         <p:txBody>
-          <a:bodyPr wrap="square" lIns="0" rIns="0" tIns="0" bIns="0">
+          <a:bodyPr wrap="square" lIns="0" tIns="0" rIns="0" bIns="0">
             <a:spAutoFit/>
           </a:bodyPr>
           <a:lstStyle/>
@@ -3953,10 +4006,16 @@
                 <a:solidFill>
                   <a:srgbClr val="1F2430"/>
                 </a:solidFill>
-                <a:latin typeface="Calibri"/>
+                <a:latin typeface="Calibri" panose="020F0502020204030204"/>
               </a:rPr>
               <a:t>Your billing account appears here. Open it — budgets are set on a scope, not on an individual resource.</a:t>
             </a:r>
+            <a:endParaRPr sz="1400" b="0">
+              <a:solidFill>
+                <a:srgbClr val="1F2430"/>
+              </a:solidFill>
+              <a:latin typeface="Calibri" panose="020F0502020204030204"/>
+            </a:endParaRPr>
           </a:p>
         </p:txBody>
       </p:sp>
@@ -3969,7 +4028,7 @@
           <p:nvPr/>
         </p:nvPicPr>
         <p:blipFill>
-          <a:blip r:embed="rId2"/>
+          <a:blip r:embed="rId1"/>
           <a:stretch>
             <a:fillRect/>
           </a:stretch>
@@ -4004,13 +4063,12 @@
             <a:avLst/>
           </a:prstGeom>
           <a:noFill/>
-          <a:ln/>
         </p:spPr>
         <p:txBody>
           <a:bodyPr wrap="square" lIns="0" tIns="0" rIns="0" bIns="0" rtlCol="0" anchor="ctr"/>
           <a:lstStyle/>
           <a:p>
-            <a:pPr algn="l" indent="0" marL="0">
+            <a:pPr marL="0" indent="0" algn="l">
               <a:buNone/>
             </a:pPr>
             <a:r>
@@ -4018,9 +4076,9 @@
                 <a:solidFill>
                   <a:srgbClr val="6B7280"/>
                 </a:solidFill>
-                <a:latin typeface="Calibri" pitchFamily="34" charset="0"/>
-                <a:ea typeface="Calibri" pitchFamily="34" charset="-122"/>
-                <a:cs typeface="Calibri" pitchFamily="34" charset="-120"/>
+                <a:latin typeface="Calibri" panose="020F0502020204030204" pitchFamily="34" charset="0"/>
+                <a:ea typeface="Calibri" panose="020F0502020204030204" pitchFamily="34" charset="-122"/>
+                <a:cs typeface="Calibri" panose="020F0502020204030204" pitchFamily="34" charset="-120"/>
               </a:rPr>
               <a:t>Modern Enterprise Software Engineering  |  ÉSTIAM  |  Day 1</a:t>
             </a:r>
@@ -4037,13 +4095,14 @@
 </file>
 
 <file path=ppt/slides/slide18.xml><?xml version="1.0" encoding="utf-8"?>
-<p:sld xmlns:a="http://schemas.openxmlformats.org/drawingml/2006/main" xmlns:p="http://schemas.openxmlformats.org/presentationml/2006/main" xmlns:r="http://schemas.openxmlformats.org/officeDocument/2006/relationships">
+<p:sld xmlns:a="http://schemas.openxmlformats.org/drawingml/2006/main" xmlns:r="http://schemas.openxmlformats.org/officeDocument/2006/relationships" xmlns:p="http://schemas.openxmlformats.org/presentationml/2006/main">
   <p:cSld>
     <p:bg>
       <p:bgPr>
         <a:solidFill>
           <a:srgbClr val="FFFFFF"/>
         </a:solidFill>
+        <a:effectLst/>
       </p:bgPr>
     </p:bg>
     <p:spTree>
@@ -4070,7 +4129,7 @@
           <a:noFill/>
         </p:spPr>
         <p:txBody>
-          <a:bodyPr wrap="square" lIns="0" rIns="0" tIns="0" bIns="0">
+          <a:bodyPr wrap="square" lIns="0" tIns="0" rIns="0" bIns="0">
             <a:spAutoFit/>
           </a:bodyPr>
           <a:lstStyle/>
@@ -4080,10 +4139,16 @@
                 <a:solidFill>
                   <a:srgbClr val="F2A93B"/>
                 </a:solidFill>
-                <a:latin typeface="Calibri"/>
+                <a:latin typeface="Calibri" panose="020F0502020204030204"/>
               </a:rPr>
               <a:t>STEP 16</a:t>
             </a:r>
+            <a:endParaRPr sz="1300" b="1" spc="200">
+              <a:solidFill>
+                <a:srgbClr val="F2A93B"/>
+              </a:solidFill>
+              <a:latin typeface="Calibri" panose="020F0502020204030204"/>
+            </a:endParaRPr>
           </a:p>
         </p:txBody>
       </p:sp>
@@ -4104,7 +4169,7 @@
           <a:noFill/>
         </p:spPr>
         <p:txBody>
-          <a:bodyPr wrap="square" lIns="0" rIns="0" tIns="0" bIns="0">
+          <a:bodyPr wrap="square" lIns="0" tIns="0" rIns="0" bIns="0">
             <a:spAutoFit/>
           </a:bodyPr>
           <a:lstStyle/>
@@ -4114,10 +4179,16 @@
                 <a:solidFill>
                   <a:srgbClr val="1E2761"/>
                 </a:solidFill>
-                <a:latin typeface="Cambria"/>
+                <a:latin typeface="Cambria" panose="02040503050406030204"/>
               </a:rPr>
               <a:t>Billing account overview</a:t>
             </a:r>
+            <a:endParaRPr sz="3000" b="1">
+              <a:solidFill>
+                <a:srgbClr val="1E2761"/>
+              </a:solidFill>
+              <a:latin typeface="Cambria" panose="02040503050406030204"/>
+            </a:endParaRPr>
           </a:p>
         </p:txBody>
       </p:sp>
@@ -4138,7 +4209,7 @@
           <a:noFill/>
         </p:spPr>
         <p:txBody>
-          <a:bodyPr wrap="square" lIns="0" rIns="0" tIns="0" bIns="0">
+          <a:bodyPr wrap="square" lIns="0" tIns="0" rIns="0" bIns="0">
             <a:spAutoFit/>
           </a:bodyPr>
           <a:lstStyle/>
@@ -4148,10 +4219,16 @@
                 <a:solidFill>
                   <a:srgbClr val="1F2430"/>
                 </a:solidFill>
-                <a:latin typeface="Calibri"/>
+                <a:latin typeface="Calibri" panose="020F0502020204030204"/>
               </a:rPr>
               <a:t>€0.00 due, free credit expiring in 30 days. Cost management → Budgets is where the guardrail goes.</a:t>
             </a:r>
+            <a:endParaRPr sz="1400" b="0">
+              <a:solidFill>
+                <a:srgbClr val="1F2430"/>
+              </a:solidFill>
+              <a:latin typeface="Calibri" panose="020F0502020204030204"/>
+            </a:endParaRPr>
           </a:p>
         </p:txBody>
       </p:sp>
@@ -4164,7 +4241,7 @@
           <p:nvPr/>
         </p:nvPicPr>
         <p:blipFill>
-          <a:blip r:embed="rId2"/>
+          <a:blip r:embed="rId1"/>
           <a:stretch>
             <a:fillRect/>
           </a:stretch>
@@ -4199,13 +4276,12 @@
             <a:avLst/>
           </a:prstGeom>
           <a:noFill/>
-          <a:ln/>
         </p:spPr>
         <p:txBody>
           <a:bodyPr wrap="square" lIns="0" tIns="0" rIns="0" bIns="0" rtlCol="0" anchor="ctr"/>
           <a:lstStyle/>
           <a:p>
-            <a:pPr algn="l" indent="0" marL="0">
+            <a:pPr marL="0" indent="0" algn="l">
               <a:buNone/>
             </a:pPr>
             <a:r>
@@ -4213,9 +4289,9 @@
                 <a:solidFill>
                   <a:srgbClr val="6B7280"/>
                 </a:solidFill>
-                <a:latin typeface="Calibri" pitchFamily="34" charset="0"/>
-                <a:ea typeface="Calibri" pitchFamily="34" charset="-122"/>
-                <a:cs typeface="Calibri" pitchFamily="34" charset="-120"/>
+                <a:latin typeface="Calibri" panose="020F0502020204030204" pitchFamily="34" charset="0"/>
+                <a:ea typeface="Calibri" panose="020F0502020204030204" pitchFamily="34" charset="-122"/>
+                <a:cs typeface="Calibri" panose="020F0502020204030204" pitchFamily="34" charset="-120"/>
               </a:rPr>
               <a:t>Modern Enterprise Software Engineering  |  ÉSTIAM  |  Day 1</a:t>
             </a:r>
@@ -4232,13 +4308,14 @@
 </file>
 
 <file path=ppt/slides/slide19.xml><?xml version="1.0" encoding="utf-8"?>
-<p:sld xmlns:a="http://schemas.openxmlformats.org/drawingml/2006/main" xmlns:p="http://schemas.openxmlformats.org/presentationml/2006/main" xmlns:r="http://schemas.openxmlformats.org/officeDocument/2006/relationships">
+<p:sld xmlns:a="http://schemas.openxmlformats.org/drawingml/2006/main" xmlns:r="http://schemas.openxmlformats.org/officeDocument/2006/relationships" xmlns:p="http://schemas.openxmlformats.org/presentationml/2006/main">
   <p:cSld>
     <p:bg>
       <p:bgPr>
         <a:solidFill>
           <a:srgbClr val="FFFFFF"/>
         </a:solidFill>
+        <a:effectLst/>
       </p:bgPr>
     </p:bg>
     <p:spTree>
@@ -4265,7 +4342,7 @@
           <a:noFill/>
         </p:spPr>
         <p:txBody>
-          <a:bodyPr wrap="square" lIns="0" rIns="0" tIns="0" bIns="0">
+          <a:bodyPr wrap="square" lIns="0" tIns="0" rIns="0" bIns="0">
             <a:spAutoFit/>
           </a:bodyPr>
           <a:lstStyle/>
@@ -4275,10 +4352,16 @@
                 <a:solidFill>
                   <a:srgbClr val="F2A93B"/>
                 </a:solidFill>
-                <a:latin typeface="Calibri"/>
+                <a:latin typeface="Calibri" panose="020F0502020204030204"/>
               </a:rPr>
               <a:t>STEP 17</a:t>
             </a:r>
+            <a:endParaRPr sz="1300" b="1" spc="200">
+              <a:solidFill>
+                <a:srgbClr val="F2A93B"/>
+              </a:solidFill>
+              <a:latin typeface="Calibri" panose="020F0502020204030204"/>
+            </a:endParaRPr>
           </a:p>
         </p:txBody>
       </p:sp>
@@ -4299,7 +4382,7 @@
           <a:noFill/>
         </p:spPr>
         <p:txBody>
-          <a:bodyPr wrap="square" lIns="0" rIns="0" tIns="0" bIns="0">
+          <a:bodyPr wrap="square" lIns="0" tIns="0" rIns="0" bIns="0">
             <a:spAutoFit/>
           </a:bodyPr>
           <a:lstStyle/>
@@ -4309,10 +4392,16 @@
                 <a:solidFill>
                   <a:srgbClr val="1E2761"/>
                 </a:solidFill>
-                <a:latin typeface="Cambria"/>
+                <a:latin typeface="Cambria" panose="02040503050406030204"/>
               </a:rPr>
               <a:t>Create a budget</a:t>
             </a:r>
+            <a:endParaRPr sz="3000" b="1">
+              <a:solidFill>
+                <a:srgbClr val="1E2761"/>
+              </a:solidFill>
+              <a:latin typeface="Cambria" panose="02040503050406030204"/>
+            </a:endParaRPr>
           </a:p>
         </p:txBody>
       </p:sp>
@@ -4333,7 +4422,7 @@
           <a:noFill/>
         </p:spPr>
         <p:txBody>
-          <a:bodyPr wrap="square" lIns="0" rIns="0" tIns="0" bIns="0">
+          <a:bodyPr wrap="square" lIns="0" tIns="0" rIns="0" bIns="0">
             <a:spAutoFit/>
           </a:bodyPr>
           <a:lstStyle/>
@@ -4343,10 +4432,16 @@
                 <a:solidFill>
                   <a:srgbClr val="1F2430"/>
                 </a:solidFill>
-                <a:latin typeface="Calibri"/>
+                <a:latin typeface="Calibri" panose="020F0502020204030204"/>
               </a:rPr>
               <a:t>Name it, choose a reset period, set a low amount. This one is annual, €10 — on a free account the point is the alert, not the ceiling.</a:t>
             </a:r>
+            <a:endParaRPr sz="1400" b="0">
+              <a:solidFill>
+                <a:srgbClr val="1F2430"/>
+              </a:solidFill>
+              <a:latin typeface="Calibri" panose="020F0502020204030204"/>
+            </a:endParaRPr>
           </a:p>
         </p:txBody>
       </p:sp>
@@ -4359,7 +4454,7 @@
           <p:nvPr/>
         </p:nvPicPr>
         <p:blipFill>
-          <a:blip r:embed="rId2"/>
+          <a:blip r:embed="rId1"/>
           <a:stretch>
             <a:fillRect/>
           </a:stretch>
@@ -4394,13 +4489,12 @@
             <a:avLst/>
           </a:prstGeom>
           <a:noFill/>
-          <a:ln/>
         </p:spPr>
         <p:txBody>
           <a:bodyPr wrap="square" lIns="0" tIns="0" rIns="0" bIns="0" rtlCol="0" anchor="ctr"/>
           <a:lstStyle/>
           <a:p>
-            <a:pPr algn="l" indent="0" marL="0">
+            <a:pPr marL="0" indent="0" algn="l">
               <a:buNone/>
             </a:pPr>
             <a:r>
@@ -4408,9 +4502,9 @@
                 <a:solidFill>
                   <a:srgbClr val="6B7280"/>
                 </a:solidFill>
-                <a:latin typeface="Calibri" pitchFamily="34" charset="0"/>
-                <a:ea typeface="Calibri" pitchFamily="34" charset="-122"/>
-                <a:cs typeface="Calibri" pitchFamily="34" charset="-120"/>
+                <a:latin typeface="Calibri" panose="020F0502020204030204" pitchFamily="34" charset="0"/>
+                <a:ea typeface="Calibri" panose="020F0502020204030204" pitchFamily="34" charset="-122"/>
+                <a:cs typeface="Calibri" panose="020F0502020204030204" pitchFamily="34" charset="-120"/>
               </a:rPr>
               <a:t>Modern Enterprise Software Engineering  |  ÉSTIAM  |  Day 1</a:t>
             </a:r>
@@ -4427,13 +4521,14 @@
 </file>
 
 <file path=ppt/slides/slide2.xml><?xml version="1.0" encoding="utf-8"?>
-<p:sld xmlns:a="http://schemas.openxmlformats.org/drawingml/2006/main" xmlns:p="http://schemas.openxmlformats.org/presentationml/2006/main" xmlns:r="http://schemas.openxmlformats.org/officeDocument/2006/relationships">
+<p:sld xmlns:a="http://schemas.openxmlformats.org/drawingml/2006/main" xmlns:r="http://schemas.openxmlformats.org/officeDocument/2006/relationships" xmlns:p="http://schemas.openxmlformats.org/presentationml/2006/main">
   <p:cSld>
     <p:bg>
       <p:bgPr>
         <a:solidFill>
           <a:srgbClr val="FFFFFF"/>
         </a:solidFill>
+        <a:effectLst/>
       </p:bgPr>
     </p:bg>
     <p:spTree>
@@ -4458,23 +4553,22 @@
             <a:avLst/>
           </a:prstGeom>
           <a:noFill/>
-          <a:ln/>
         </p:spPr>
         <p:txBody>
           <a:bodyPr wrap="square" lIns="0" tIns="0" rIns="0" bIns="0" rtlCol="0" anchor="ctr"/>
           <a:lstStyle/>
           <a:p>
-            <a:pPr indent="0" marL="0">
+            <a:pPr marL="0" indent="0">
               <a:buNone/>
             </a:pPr>
             <a:r>
-              <a:rPr lang="en-US" sz="1300" b="1" spc="200" kern="0" dirty="0">
+              <a:rPr lang="en-US" sz="1300" b="1" kern="0" spc="200" dirty="0">
                 <a:solidFill>
                   <a:srgbClr val="F2A93B"/>
                 </a:solidFill>
-                <a:latin typeface="Calibri" pitchFamily="34" charset="0"/>
-                <a:ea typeface="Calibri" pitchFamily="34" charset="-122"/>
-                <a:cs typeface="Calibri" pitchFamily="34" charset="-120"/>
+                <a:latin typeface="Calibri" panose="020F0502020204030204" pitchFamily="34" charset="0"/>
+                <a:ea typeface="Calibri" panose="020F0502020204030204" pitchFamily="34" charset="-122"/>
+                <a:cs typeface="Calibri" panose="020F0502020204030204" pitchFamily="34" charset="-120"/>
               </a:rPr>
               <a:t>AGENDA</a:t>
             </a:r>
@@ -4497,13 +4591,12 @@
             <a:avLst/>
           </a:prstGeom>
           <a:noFill/>
-          <a:ln/>
         </p:spPr>
         <p:txBody>
           <a:bodyPr wrap="square" lIns="0" tIns="0" rIns="0" bIns="0" rtlCol="0" anchor="ctr"/>
           <a:lstStyle/>
           <a:p>
-            <a:pPr indent="0" marL="0">
+            <a:pPr marL="0" indent="0">
               <a:buNone/>
             </a:pPr>
             <a:r>
@@ -4511,9 +4604,9 @@
                 <a:solidFill>
                   <a:srgbClr val="1E2761"/>
                 </a:solidFill>
-                <a:latin typeface="Cambria" pitchFamily="34" charset="0"/>
-                <a:ea typeface="Cambria" pitchFamily="34" charset="-122"/>
-                <a:cs typeface="Cambria" pitchFamily="34" charset="-120"/>
+                <a:latin typeface="Cambria" panose="02040503050406030204" pitchFamily="34" charset="0"/>
+                <a:ea typeface="Cambria" panose="02040503050406030204" pitchFamily="34" charset="-122"/>
+                <a:cs typeface="Cambria" panose="02040503050406030204" pitchFamily="34" charset="-120"/>
               </a:rPr>
               <a:t>What we'll set up</a:t>
             </a:r>
@@ -4538,7 +4631,6 @@
           <a:solidFill>
             <a:srgbClr val="F2A93B"/>
           </a:solidFill>
-          <a:ln/>
         </p:spPr>
       </p:sp>
       <p:sp>
@@ -4556,13 +4648,12 @@
             <a:avLst/>
           </a:prstGeom>
           <a:noFill/>
-          <a:ln/>
         </p:spPr>
         <p:txBody>
           <a:bodyPr wrap="square" lIns="0" tIns="0" rIns="0" bIns="0" rtlCol="0" anchor="ctr"/>
           <a:lstStyle/>
           <a:p>
-            <a:pPr algn="ctr" indent="0" marL="0">
+            <a:pPr marL="0" indent="0" algn="ctr">
               <a:buNone/>
             </a:pPr>
             <a:r>
@@ -4570,9 +4661,9 @@
                 <a:solidFill>
                   <a:srgbClr val="1E2761"/>
                 </a:solidFill>
-                <a:latin typeface="Calibri" pitchFamily="34" charset="0"/>
-                <a:ea typeface="Calibri" pitchFamily="34" charset="-122"/>
-                <a:cs typeface="Calibri" pitchFamily="34" charset="-120"/>
+                <a:latin typeface="Calibri" panose="020F0502020204030204" pitchFamily="34" charset="0"/>
+                <a:ea typeface="Calibri" panose="020F0502020204030204" pitchFamily="34" charset="-122"/>
+                <a:cs typeface="Calibri" panose="020F0502020204030204" pitchFamily="34" charset="-120"/>
               </a:rPr>
               <a:t>1</a:t>
             </a:r>
@@ -4595,13 +4686,12 @@
             <a:avLst/>
           </a:prstGeom>
           <a:noFill/>
-          <a:ln/>
         </p:spPr>
         <p:txBody>
           <a:bodyPr wrap="square" lIns="0" tIns="0" rIns="0" bIns="0" rtlCol="0" anchor="ctr"/>
           <a:lstStyle/>
           <a:p>
-            <a:pPr indent="0" marL="0">
+            <a:pPr marL="0" indent="0">
               <a:buNone/>
             </a:pPr>
             <a:r>
@@ -4609,9 +4699,9 @@
                 <a:solidFill>
                   <a:srgbClr val="1F2430"/>
                 </a:solidFill>
-                <a:latin typeface="Calibri" pitchFamily="34" charset="0"/>
-                <a:ea typeface="Calibri" pitchFamily="34" charset="-122"/>
-                <a:cs typeface="Calibri" pitchFamily="34" charset="-120"/>
+                <a:latin typeface="Calibri" panose="020F0502020204030204" pitchFamily="34" charset="0"/>
+                <a:ea typeface="Calibri" panose="020F0502020204030204" pitchFamily="34" charset="-122"/>
+                <a:cs typeface="Calibri" panose="020F0502020204030204" pitchFamily="34" charset="-120"/>
               </a:rPr>
               <a:t>Choosing an account type — free account vs. pay as you go, and why it matters here</a:t>
             </a:r>
@@ -4636,7 +4726,6 @@
           <a:solidFill>
             <a:srgbClr val="F2A93B"/>
           </a:solidFill>
-          <a:ln/>
         </p:spPr>
       </p:sp>
       <p:sp>
@@ -4654,13 +4743,12 @@
             <a:avLst/>
           </a:prstGeom>
           <a:noFill/>
-          <a:ln/>
         </p:spPr>
         <p:txBody>
           <a:bodyPr wrap="square" lIns="0" tIns="0" rIns="0" bIns="0" rtlCol="0" anchor="ctr"/>
           <a:lstStyle/>
           <a:p>
-            <a:pPr algn="ctr" indent="0" marL="0">
+            <a:pPr marL="0" indent="0" algn="ctr">
               <a:buNone/>
             </a:pPr>
             <a:r>
@@ -4668,9 +4756,9 @@
                 <a:solidFill>
                   <a:srgbClr val="1E2761"/>
                 </a:solidFill>
-                <a:latin typeface="Calibri" pitchFamily="34" charset="0"/>
-                <a:ea typeface="Calibri" pitchFamily="34" charset="-122"/>
-                <a:cs typeface="Calibri" pitchFamily="34" charset="-120"/>
+                <a:latin typeface="Calibri" panose="020F0502020204030204" pitchFamily="34" charset="0"/>
+                <a:ea typeface="Calibri" panose="020F0502020204030204" pitchFamily="34" charset="-122"/>
+                <a:cs typeface="Calibri" panose="020F0502020204030204" pitchFamily="34" charset="-120"/>
               </a:rPr>
               <a:t>2</a:t>
             </a:r>
@@ -4693,13 +4781,12 @@
             <a:avLst/>
           </a:prstGeom>
           <a:noFill/>
-          <a:ln/>
         </p:spPr>
         <p:txBody>
           <a:bodyPr wrap="square" lIns="0" tIns="0" rIns="0" bIns="0" rtlCol="0" anchor="ctr"/>
           <a:lstStyle/>
           <a:p>
-            <a:pPr indent="0" marL="0">
+            <a:pPr marL="0" indent="0">
               <a:buNone/>
             </a:pPr>
             <a:r>
@@ -4707,9 +4794,9 @@
                 <a:solidFill>
                   <a:srgbClr val="1F2430"/>
                 </a:solidFill>
-                <a:latin typeface="Calibri" pitchFamily="34" charset="0"/>
-                <a:ea typeface="Calibri" pitchFamily="34" charset="-122"/>
-                <a:cs typeface="Calibri" pitchFamily="34" charset="-120"/>
+                <a:latin typeface="Calibri" panose="020F0502020204030204" pitchFamily="34" charset="0"/>
+                <a:ea typeface="Calibri" panose="020F0502020204030204" pitchFamily="34" charset="-122"/>
+                <a:cs typeface="Calibri" panose="020F0502020204030204" pitchFamily="34" charset="-120"/>
               </a:rPr>
               <a:t>Creating the personal Microsoft account the subscription will sit on</a:t>
             </a:r>
@@ -4734,7 +4821,6 @@
           <a:solidFill>
             <a:srgbClr val="F2A93B"/>
           </a:solidFill>
-          <a:ln/>
         </p:spPr>
       </p:sp>
       <p:sp>
@@ -4752,13 +4838,12 @@
             <a:avLst/>
           </a:prstGeom>
           <a:noFill/>
-          <a:ln/>
         </p:spPr>
         <p:txBody>
           <a:bodyPr wrap="square" lIns="0" tIns="0" rIns="0" bIns="0" rtlCol="0" anchor="ctr"/>
           <a:lstStyle/>
           <a:p>
-            <a:pPr algn="ctr" indent="0" marL="0">
+            <a:pPr marL="0" indent="0" algn="ctr">
               <a:buNone/>
             </a:pPr>
             <a:r>
@@ -4766,9 +4851,9 @@
                 <a:solidFill>
                   <a:srgbClr val="1E2761"/>
                 </a:solidFill>
-                <a:latin typeface="Calibri" pitchFamily="34" charset="0"/>
-                <a:ea typeface="Calibri" pitchFamily="34" charset="-122"/>
-                <a:cs typeface="Calibri" pitchFamily="34" charset="-120"/>
+                <a:latin typeface="Calibri" panose="020F0502020204030204" pitchFamily="34" charset="0"/>
+                <a:ea typeface="Calibri" panose="020F0502020204030204" pitchFamily="34" charset="-122"/>
+                <a:cs typeface="Calibri" panose="020F0502020204030204" pitchFamily="34" charset="-120"/>
               </a:rPr>
               <a:t>3</a:t>
             </a:r>
@@ -4791,13 +4876,12 @@
             <a:avLst/>
           </a:prstGeom>
           <a:noFill/>
-          <a:ln/>
         </p:spPr>
         <p:txBody>
           <a:bodyPr wrap="square" lIns="0" tIns="0" rIns="0" bIns="0" rtlCol="0" anchor="ctr"/>
           <a:lstStyle/>
           <a:p>
-            <a:pPr indent="0" marL="0">
+            <a:pPr marL="0" indent="0">
               <a:buNone/>
             </a:pPr>
             <a:r>
@@ -4805,9 +4889,9 @@
                 <a:solidFill>
                   <a:srgbClr val="1F2430"/>
                 </a:solidFill>
-                <a:latin typeface="Calibri" pitchFamily="34" charset="0"/>
-                <a:ea typeface="Calibri" pitchFamily="34" charset="-122"/>
-                <a:cs typeface="Calibri" pitchFamily="34" charset="-120"/>
+                <a:latin typeface="Calibri" panose="020F0502020204030204" pitchFamily="34" charset="0"/>
+                <a:ea typeface="Calibri" panose="020F0502020204030204" pitchFamily="34" charset="-122"/>
+                <a:cs typeface="Calibri" panose="020F0502020204030204" pitchFamily="34" charset="-120"/>
               </a:rPr>
               <a:t>Azure free account sign-up — profile, identity, and the card that won't be charged</a:t>
             </a:r>
@@ -4832,7 +4916,6 @@
           <a:solidFill>
             <a:srgbClr val="F2A93B"/>
           </a:solidFill>
-          <a:ln/>
         </p:spPr>
       </p:sp>
       <p:sp>
@@ -4850,13 +4933,12 @@
             <a:avLst/>
           </a:prstGeom>
           <a:noFill/>
-          <a:ln/>
         </p:spPr>
         <p:txBody>
           <a:bodyPr wrap="square" lIns="0" tIns="0" rIns="0" bIns="0" rtlCol="0" anchor="ctr"/>
           <a:lstStyle/>
           <a:p>
-            <a:pPr algn="ctr" indent="0" marL="0">
+            <a:pPr marL="0" indent="0" algn="ctr">
               <a:buNone/>
             </a:pPr>
             <a:r>
@@ -4864,9 +4946,9 @@
                 <a:solidFill>
                   <a:srgbClr val="1E2761"/>
                 </a:solidFill>
-                <a:latin typeface="Calibri" pitchFamily="34" charset="0"/>
-                <a:ea typeface="Calibri" pitchFamily="34" charset="-122"/>
-                <a:cs typeface="Calibri" pitchFamily="34" charset="-120"/>
+                <a:latin typeface="Calibri" panose="020F0502020204030204" pitchFamily="34" charset="0"/>
+                <a:ea typeface="Calibri" panose="020F0502020204030204" pitchFamily="34" charset="-122"/>
+                <a:cs typeface="Calibri" panose="020F0502020204030204" pitchFamily="34" charset="-120"/>
               </a:rPr>
               <a:t>4</a:t>
             </a:r>
@@ -4889,13 +4971,12 @@
             <a:avLst/>
           </a:prstGeom>
           <a:noFill/>
-          <a:ln/>
         </p:spPr>
         <p:txBody>
           <a:bodyPr wrap="square" lIns="0" tIns="0" rIns="0" bIns="0" rtlCol="0" anchor="ctr"/>
           <a:lstStyle/>
           <a:p>
-            <a:pPr indent="0" marL="0">
+            <a:pPr marL="0" indent="0">
               <a:buNone/>
             </a:pPr>
             <a:r>
@@ -4903,9 +4984,9 @@
                 <a:solidFill>
                   <a:srgbClr val="1F2430"/>
                 </a:solidFill>
-                <a:latin typeface="Calibri" pitchFamily="34" charset="0"/>
-                <a:ea typeface="Calibri" pitchFamily="34" charset="-122"/>
-                <a:cs typeface="Calibri" pitchFamily="34" charset="-120"/>
+                <a:latin typeface="Calibri" panose="020F0502020204030204" pitchFamily="34" charset="0"/>
+                <a:ea typeface="Calibri" panose="020F0502020204030204" pitchFamily="34" charset="-122"/>
+                <a:cs typeface="Calibri" panose="020F0502020204030204" pitchFamily="34" charset="-120"/>
               </a:rPr>
               <a:t>First sign-in — and the two things that look broken but aren't</a:t>
             </a:r>
@@ -4930,7 +5011,6 @@
           <a:solidFill>
             <a:srgbClr val="F2A93B"/>
           </a:solidFill>
-          <a:ln/>
         </p:spPr>
       </p:sp>
       <p:sp>
@@ -4948,13 +5028,12 @@
             <a:avLst/>
           </a:prstGeom>
           <a:noFill/>
-          <a:ln/>
         </p:spPr>
         <p:txBody>
           <a:bodyPr wrap="square" lIns="0" tIns="0" rIns="0" bIns="0" rtlCol="0" anchor="ctr"/>
           <a:lstStyle/>
           <a:p>
-            <a:pPr algn="ctr" indent="0" marL="0">
+            <a:pPr marL="0" indent="0" algn="ctr">
               <a:buNone/>
             </a:pPr>
             <a:r>
@@ -4962,9 +5041,9 @@
                 <a:solidFill>
                   <a:srgbClr val="1E2761"/>
                 </a:solidFill>
-                <a:latin typeface="Calibri" pitchFamily="34" charset="0"/>
-                <a:ea typeface="Calibri" pitchFamily="34" charset="-122"/>
-                <a:cs typeface="Calibri" pitchFamily="34" charset="-120"/>
+                <a:latin typeface="Calibri" panose="020F0502020204030204" pitchFamily="34" charset="0"/>
+                <a:ea typeface="Calibri" panose="020F0502020204030204" pitchFamily="34" charset="-122"/>
+                <a:cs typeface="Calibri" panose="020F0502020204030204" pitchFamily="34" charset="-120"/>
               </a:rPr>
               <a:t>5</a:t>
             </a:r>
@@ -4987,13 +5066,12 @@
             <a:avLst/>
           </a:prstGeom>
           <a:noFill/>
-          <a:ln/>
         </p:spPr>
         <p:txBody>
           <a:bodyPr wrap="square" lIns="0" tIns="0" rIns="0" bIns="0" rtlCol="0" anchor="ctr"/>
           <a:lstStyle/>
           <a:p>
-            <a:pPr indent="0" marL="0">
+            <a:pPr marL="0" indent="0">
               <a:buNone/>
             </a:pPr>
             <a:r>
@@ -5001,9 +5079,9 @@
                 <a:solidFill>
                   <a:srgbClr val="1F2430"/>
                 </a:solidFill>
-                <a:latin typeface="Calibri" pitchFamily="34" charset="0"/>
-                <a:ea typeface="Calibri" pitchFamily="34" charset="-122"/>
-                <a:cs typeface="Calibri" pitchFamily="34" charset="-120"/>
+                <a:latin typeface="Calibri" panose="020F0502020204030204" pitchFamily="34" charset="0"/>
+                <a:ea typeface="Calibri" panose="020F0502020204030204" pitchFamily="34" charset="-122"/>
+                <a:cs typeface="Calibri" panose="020F0502020204030204" pitchFamily="34" charset="-120"/>
               </a:rPr>
               <a:t>Cost Management + Billing — finding your billing scope in the portal</a:t>
             </a:r>
@@ -5028,7 +5106,6 @@
           <a:solidFill>
             <a:srgbClr val="F2A93B"/>
           </a:solidFill>
-          <a:ln/>
         </p:spPr>
       </p:sp>
       <p:sp>
@@ -5046,13 +5123,12 @@
             <a:avLst/>
           </a:prstGeom>
           <a:noFill/>
-          <a:ln/>
         </p:spPr>
         <p:txBody>
           <a:bodyPr wrap="square" lIns="0" tIns="0" rIns="0" bIns="0" rtlCol="0" anchor="ctr"/>
           <a:lstStyle/>
           <a:p>
-            <a:pPr algn="ctr" indent="0" marL="0">
+            <a:pPr marL="0" indent="0" algn="ctr">
               <a:buNone/>
             </a:pPr>
             <a:r>
@@ -5060,9 +5136,9 @@
                 <a:solidFill>
                   <a:srgbClr val="1E2761"/>
                 </a:solidFill>
-                <a:latin typeface="Calibri" pitchFamily="34" charset="0"/>
-                <a:ea typeface="Calibri" pitchFamily="34" charset="-122"/>
-                <a:cs typeface="Calibri" pitchFamily="34" charset="-120"/>
+                <a:latin typeface="Calibri" panose="020F0502020204030204" pitchFamily="34" charset="0"/>
+                <a:ea typeface="Calibri" panose="020F0502020204030204" pitchFamily="34" charset="-122"/>
+                <a:cs typeface="Calibri" panose="020F0502020204030204" pitchFamily="34" charset="-120"/>
               </a:rPr>
               <a:t>6</a:t>
             </a:r>
@@ -5085,13 +5161,12 @@
             <a:avLst/>
           </a:prstGeom>
           <a:noFill/>
-          <a:ln/>
         </p:spPr>
         <p:txBody>
           <a:bodyPr wrap="square" lIns="0" tIns="0" rIns="0" bIns="0" rtlCol="0" anchor="ctr"/>
           <a:lstStyle/>
           <a:p>
-            <a:pPr indent="0" marL="0">
+            <a:pPr marL="0" indent="0">
               <a:buNone/>
             </a:pPr>
             <a:r>
@@ -5099,9 +5174,9 @@
                 <a:solidFill>
                   <a:srgbClr val="1F2430"/>
                 </a:solidFill>
-                <a:latin typeface="Calibri" pitchFamily="34" charset="0"/>
-                <a:ea typeface="Calibri" pitchFamily="34" charset="-122"/>
-                <a:cs typeface="Calibri" pitchFamily="34" charset="-120"/>
+                <a:latin typeface="Calibri" panose="020F0502020204030204" pitchFamily="34" charset="0"/>
+                <a:ea typeface="Calibri" panose="020F0502020204030204" pitchFamily="34" charset="-122"/>
+                <a:cs typeface="Calibri" panose="020F0502020204030204" pitchFamily="34" charset="-120"/>
               </a:rPr>
               <a:t>A budget and an alert — the guardrail to set before creating a single resource</a:t>
             </a:r>
@@ -5124,13 +5199,12 @@
             <a:avLst/>
           </a:prstGeom>
           <a:noFill/>
-          <a:ln/>
         </p:spPr>
         <p:txBody>
           <a:bodyPr wrap="square" lIns="0" tIns="0" rIns="0" bIns="0" rtlCol="0" anchor="ctr"/>
           <a:lstStyle/>
           <a:p>
-            <a:pPr algn="l" indent="0" marL="0">
+            <a:pPr marL="0" indent="0" algn="l">
               <a:buNone/>
             </a:pPr>
             <a:r>
@@ -5138,9 +5212,9 @@
                 <a:solidFill>
                   <a:srgbClr val="6B7280"/>
                 </a:solidFill>
-                <a:latin typeface="Calibri" pitchFamily="34" charset="0"/>
-                <a:ea typeface="Calibri" pitchFamily="34" charset="-122"/>
-                <a:cs typeface="Calibri" pitchFamily="34" charset="-120"/>
+                <a:latin typeface="Calibri" panose="020F0502020204030204" pitchFamily="34" charset="0"/>
+                <a:ea typeface="Calibri" panose="020F0502020204030204" pitchFamily="34" charset="-122"/>
+                <a:cs typeface="Calibri" panose="020F0502020204030204" pitchFamily="34" charset="-120"/>
               </a:rPr>
               <a:t>Modern Enterprise Software Engineering  |  ÉSTIAM  |  Day 1</a:t>
             </a:r>
@@ -5157,13 +5231,14 @@
 </file>
 
 <file path=ppt/slides/slide20.xml><?xml version="1.0" encoding="utf-8"?>
-<p:sld xmlns:a="http://schemas.openxmlformats.org/drawingml/2006/main" xmlns:p="http://schemas.openxmlformats.org/presentationml/2006/main" xmlns:r="http://schemas.openxmlformats.org/officeDocument/2006/relationships">
+<p:sld xmlns:a="http://schemas.openxmlformats.org/drawingml/2006/main" xmlns:r="http://schemas.openxmlformats.org/officeDocument/2006/relationships" xmlns:p="http://schemas.openxmlformats.org/presentationml/2006/main">
   <p:cSld>
     <p:bg>
       <p:bgPr>
         <a:solidFill>
           <a:srgbClr val="FFFFFF"/>
         </a:solidFill>
+        <a:effectLst/>
       </p:bgPr>
     </p:bg>
     <p:spTree>
@@ -5190,7 +5265,7 @@
           <a:noFill/>
         </p:spPr>
         <p:txBody>
-          <a:bodyPr wrap="square" lIns="0" rIns="0" tIns="0" bIns="0">
+          <a:bodyPr wrap="square" lIns="0" tIns="0" rIns="0" bIns="0">
             <a:spAutoFit/>
           </a:bodyPr>
           <a:lstStyle/>
@@ -5200,10 +5275,16 @@
                 <a:solidFill>
                   <a:srgbClr val="F2A93B"/>
                 </a:solidFill>
-                <a:latin typeface="Calibri"/>
+                <a:latin typeface="Calibri" panose="020F0502020204030204"/>
               </a:rPr>
               <a:t>STEP 18</a:t>
             </a:r>
+            <a:endParaRPr sz="1300" b="1" spc="200">
+              <a:solidFill>
+                <a:srgbClr val="F2A93B"/>
+              </a:solidFill>
+              <a:latin typeface="Calibri" panose="020F0502020204030204"/>
+            </a:endParaRPr>
           </a:p>
         </p:txBody>
       </p:sp>
@@ -5224,7 +5305,7 @@
           <a:noFill/>
         </p:spPr>
         <p:txBody>
-          <a:bodyPr wrap="square" lIns="0" rIns="0" tIns="0" bIns="0">
+          <a:bodyPr wrap="square" lIns="0" tIns="0" rIns="0" bIns="0">
             <a:spAutoFit/>
           </a:bodyPr>
           <a:lstStyle/>
@@ -5234,10 +5315,16 @@
                 <a:solidFill>
                   <a:srgbClr val="1E2761"/>
                 </a:solidFill>
-                <a:latin typeface="Cambria"/>
+                <a:latin typeface="Cambria" panose="02040503050406030204"/>
               </a:rPr>
               <a:t>Set the alert</a:t>
             </a:r>
+            <a:endParaRPr sz="3000" b="1">
+              <a:solidFill>
+                <a:srgbClr val="1E2761"/>
+              </a:solidFill>
+              <a:latin typeface="Cambria" panose="02040503050406030204"/>
+            </a:endParaRPr>
           </a:p>
         </p:txBody>
       </p:sp>
@@ -5258,7 +5345,7 @@
           <a:noFill/>
         </p:spPr>
         <p:txBody>
-          <a:bodyPr wrap="square" lIns="0" rIns="0" tIns="0" bIns="0">
+          <a:bodyPr wrap="square" lIns="0" tIns="0" rIns="0" bIns="0">
             <a:spAutoFit/>
           </a:bodyPr>
           <a:lstStyle/>
@@ -5268,10 +5355,16 @@
                 <a:solidFill>
                   <a:srgbClr val="1F2430"/>
                 </a:solidFill>
-                <a:latin typeface="Calibri"/>
+                <a:latin typeface="Calibri" panose="020F0502020204030204"/>
               </a:rPr>
               <a:t>Actual cost at 50% of budget, emailed to you. A budget does not stop spending — it tells you. Allow-list azure-noreply@microsoft.com.</a:t>
             </a:r>
+            <a:endParaRPr sz="1400" b="0">
+              <a:solidFill>
+                <a:srgbClr val="1F2430"/>
+              </a:solidFill>
+              <a:latin typeface="Calibri" panose="020F0502020204030204"/>
+            </a:endParaRPr>
           </a:p>
         </p:txBody>
       </p:sp>
@@ -5284,7 +5377,7 @@
           <p:nvPr/>
         </p:nvPicPr>
         <p:blipFill>
-          <a:blip r:embed="rId2"/>
+          <a:blip r:embed="rId1"/>
           <a:stretch>
             <a:fillRect/>
           </a:stretch>
@@ -5319,13 +5412,12 @@
             <a:avLst/>
           </a:prstGeom>
           <a:noFill/>
-          <a:ln/>
         </p:spPr>
         <p:txBody>
           <a:bodyPr wrap="square" lIns="0" tIns="0" rIns="0" bIns="0" rtlCol="0" anchor="ctr"/>
           <a:lstStyle/>
           <a:p>
-            <a:pPr algn="l" indent="0" marL="0">
+            <a:pPr marL="0" indent="0" algn="l">
               <a:buNone/>
             </a:pPr>
             <a:r>
@@ -5333,9 +5425,9 @@
                 <a:solidFill>
                   <a:srgbClr val="6B7280"/>
                 </a:solidFill>
-                <a:latin typeface="Calibri" pitchFamily="34" charset="0"/>
-                <a:ea typeface="Calibri" pitchFamily="34" charset="-122"/>
-                <a:cs typeface="Calibri" pitchFamily="34" charset="-120"/>
+                <a:latin typeface="Calibri" panose="020F0502020204030204" pitchFamily="34" charset="0"/>
+                <a:ea typeface="Calibri" panose="020F0502020204030204" pitchFamily="34" charset="-122"/>
+                <a:cs typeface="Calibri" panose="020F0502020204030204" pitchFamily="34" charset="-120"/>
               </a:rPr>
               <a:t>Modern Enterprise Software Engineering  |  ÉSTIAM  |  Day 1</a:t>
             </a:r>
@@ -5352,13 +5444,14 @@
 </file>
 
 <file path=ppt/slides/slide21.xml><?xml version="1.0" encoding="utf-8"?>
-<p:sld xmlns:a="http://schemas.openxmlformats.org/drawingml/2006/main" xmlns:p="http://schemas.openxmlformats.org/presentationml/2006/main" xmlns:r="http://schemas.openxmlformats.org/officeDocument/2006/relationships">
+<p:sld xmlns:a="http://schemas.openxmlformats.org/drawingml/2006/main" xmlns:r="http://schemas.openxmlformats.org/officeDocument/2006/relationships" xmlns:p="http://schemas.openxmlformats.org/presentationml/2006/main">
   <p:cSld>
     <p:bg>
       <p:bgPr>
         <a:solidFill>
           <a:srgbClr val="1E2761"/>
         </a:solidFill>
+        <a:effectLst/>
       </p:bgPr>
     </p:bg>
     <p:spTree>
@@ -5385,7 +5478,6 @@
           <a:solidFill>
             <a:srgbClr val="F2A93B"/>
           </a:solidFill>
-          <a:ln/>
         </p:spPr>
       </p:sp>
       <p:sp>
@@ -5403,13 +5495,12 @@
             <a:avLst/>
           </a:prstGeom>
           <a:noFill/>
-          <a:ln/>
         </p:spPr>
         <p:txBody>
           <a:bodyPr wrap="square" lIns="0" tIns="0" rIns="0" bIns="0" rtlCol="0" anchor="ctr"/>
           <a:lstStyle/>
           <a:p>
-            <a:pPr indent="0" marL="0">
+            <a:pPr marL="0" indent="0">
               <a:buNone/>
             </a:pPr>
             <a:r>
@@ -5417,9 +5508,9 @@
                 <a:solidFill>
                   <a:srgbClr val="FFFFFF"/>
                 </a:solidFill>
-                <a:latin typeface="Cambria" pitchFamily="34" charset="0"/>
-                <a:ea typeface="Cambria" pitchFamily="34" charset="-122"/>
-                <a:cs typeface="Cambria" pitchFamily="34" charset="-120"/>
+                <a:latin typeface="Cambria" panose="02040503050406030204" pitchFamily="34" charset="0"/>
+                <a:ea typeface="Cambria" panose="02040503050406030204" pitchFamily="34" charset="-122"/>
+                <a:cs typeface="Cambria" panose="02040503050406030204" pitchFamily="34" charset="-120"/>
               </a:rPr>
               <a:t>Next: Module 1 — Develop Azure Computing Solutions</a:t>
             </a:r>
@@ -5442,13 +5533,12 @@
             <a:avLst/>
           </a:prstGeom>
           <a:noFill/>
-          <a:ln/>
         </p:spPr>
         <p:txBody>
           <a:bodyPr wrap="square" lIns="0" tIns="0" rIns="0" bIns="0" rtlCol="0" anchor="ctr"/>
           <a:lstStyle/>
           <a:p>
-            <a:pPr indent="0" marL="0">
+            <a:pPr marL="0" indent="0">
               <a:lnSpc>
                 <a:spcPct val="125000"/>
               </a:lnSpc>
@@ -5459,9 +5549,9 @@
                 <a:solidFill>
                   <a:srgbClr val="CADCFC"/>
                 </a:solidFill>
-                <a:latin typeface="Calibri" pitchFamily="34" charset="0"/>
-                <a:ea typeface="Calibri" pitchFamily="34" charset="-122"/>
-                <a:cs typeface="Calibri" pitchFamily="34" charset="-120"/>
+                <a:latin typeface="Calibri" panose="020F0502020204030204" pitchFamily="34" charset="0"/>
+                <a:ea typeface="Calibri" panose="020F0502020204030204" pitchFamily="34" charset="-122"/>
+                <a:cs typeface="Calibri" panose="020F0502020204030204" pitchFamily="34" charset="-120"/>
               </a:rPr>
               <a:t>Everyone has a subscription and a budget alert on it. Now let's put something in it — and start paying attention to what that something costs.</a:t>
             </a:r>
@@ -5478,13 +5568,14 @@
 </file>
 
 <file path=ppt/slides/slide3.xml><?xml version="1.0" encoding="utf-8"?>
-<p:sld xmlns:a="http://schemas.openxmlformats.org/drawingml/2006/main" xmlns:p="http://schemas.openxmlformats.org/presentationml/2006/main" xmlns:r="http://schemas.openxmlformats.org/officeDocument/2006/relationships">
+<p:sld xmlns:a="http://schemas.openxmlformats.org/drawingml/2006/main" xmlns:r="http://schemas.openxmlformats.org/officeDocument/2006/relationships" xmlns:p="http://schemas.openxmlformats.org/presentationml/2006/main">
   <p:cSld>
     <p:bg>
       <p:bgPr>
         <a:solidFill>
           <a:srgbClr val="FFFFFF"/>
         </a:solidFill>
+        <a:effectLst/>
       </p:bgPr>
     </p:bg>
     <p:spTree>
@@ -5511,7 +5602,7 @@
           <a:noFill/>
         </p:spPr>
         <p:txBody>
-          <a:bodyPr wrap="square" lIns="0" rIns="0" tIns="0" bIns="0">
+          <a:bodyPr wrap="square" lIns="0" tIns="0" rIns="0" bIns="0">
             <a:spAutoFit/>
           </a:bodyPr>
           <a:lstStyle/>
@@ -5521,10 +5612,16 @@
                 <a:solidFill>
                   <a:srgbClr val="F2A93B"/>
                 </a:solidFill>
-                <a:latin typeface="Calibri"/>
+                <a:latin typeface="Calibri" panose="020F0502020204030204"/>
               </a:rPr>
               <a:t>STEP 01</a:t>
             </a:r>
+            <a:endParaRPr sz="1300" b="1" spc="200">
+              <a:solidFill>
+                <a:srgbClr val="F2A93B"/>
+              </a:solidFill>
+              <a:latin typeface="Calibri" panose="020F0502020204030204"/>
+            </a:endParaRPr>
           </a:p>
         </p:txBody>
       </p:sp>
@@ -5545,7 +5642,7 @@
           <a:noFill/>
         </p:spPr>
         <p:txBody>
-          <a:bodyPr wrap="square" lIns="0" rIns="0" tIns="0" bIns="0">
+          <a:bodyPr wrap="square" lIns="0" tIns="0" rIns="0" bIns="0">
             <a:spAutoFit/>
           </a:bodyPr>
           <a:lstStyle/>
@@ -5555,10 +5652,16 @@
                 <a:solidFill>
                   <a:srgbClr val="1E2761"/>
                 </a:solidFill>
-                <a:latin typeface="Cambria"/>
+                <a:latin typeface="Cambria" panose="02040503050406030204"/>
               </a:rPr>
               <a:t>Start at azure.microsoft.com</a:t>
             </a:r>
+            <a:endParaRPr sz="3000" b="1">
+              <a:solidFill>
+                <a:srgbClr val="1E2761"/>
+              </a:solidFill>
+              <a:latin typeface="Cambria" panose="02040503050406030204"/>
+            </a:endParaRPr>
           </a:p>
         </p:txBody>
       </p:sp>
@@ -5579,7 +5682,7 @@
           <a:noFill/>
         </p:spPr>
         <p:txBody>
-          <a:bodyPr wrap="square" lIns="0" rIns="0" tIns="0" bIns="0">
+          <a:bodyPr wrap="square" lIns="0" tIns="0" rIns="0" bIns="0">
             <a:spAutoFit/>
           </a:bodyPr>
           <a:lstStyle/>
@@ -5589,10 +5692,16 @@
                 <a:solidFill>
                   <a:srgbClr val="1F2430"/>
                 </a:solidFill>
-                <a:latin typeface="Calibri"/>
+                <a:latin typeface="Calibri" panose="020F0502020204030204"/>
               </a:rPr>
               <a:t>Two doors on the landing page: Pay as you go, or Try Azure for free. For this course, take the free account.</a:t>
             </a:r>
+            <a:endParaRPr sz="1400" b="0">
+              <a:solidFill>
+                <a:srgbClr val="1F2430"/>
+              </a:solidFill>
+              <a:latin typeface="Calibri" panose="020F0502020204030204"/>
+            </a:endParaRPr>
           </a:p>
         </p:txBody>
       </p:sp>
@@ -5605,7 +5714,7 @@
           <p:nvPr/>
         </p:nvPicPr>
         <p:blipFill>
-          <a:blip r:embed="rId2"/>
+          <a:blip r:embed="rId1"/>
           <a:stretch>
             <a:fillRect/>
           </a:stretch>
@@ -5640,13 +5749,12 @@
             <a:avLst/>
           </a:prstGeom>
           <a:noFill/>
-          <a:ln/>
         </p:spPr>
         <p:txBody>
           <a:bodyPr wrap="square" lIns="0" tIns="0" rIns="0" bIns="0" rtlCol="0" anchor="ctr"/>
           <a:lstStyle/>
           <a:p>
-            <a:pPr algn="l" indent="0" marL="0">
+            <a:pPr marL="0" indent="0" algn="l">
               <a:buNone/>
             </a:pPr>
             <a:r>
@@ -5654,9 +5762,9 @@
                 <a:solidFill>
                   <a:srgbClr val="6B7280"/>
                 </a:solidFill>
-                <a:latin typeface="Calibri" pitchFamily="34" charset="0"/>
-                <a:ea typeface="Calibri" pitchFamily="34" charset="-122"/>
-                <a:cs typeface="Calibri" pitchFamily="34" charset="-120"/>
+                <a:latin typeface="Calibri" panose="020F0502020204030204" pitchFamily="34" charset="0"/>
+                <a:ea typeface="Calibri" panose="020F0502020204030204" pitchFamily="34" charset="-122"/>
+                <a:cs typeface="Calibri" panose="020F0502020204030204" pitchFamily="34" charset="-120"/>
               </a:rPr>
               <a:t>Modern Enterprise Software Engineering  |  ÉSTIAM  |  Day 1</a:t>
             </a:r>
@@ -5673,13 +5781,14 @@
 </file>
 
 <file path=ppt/slides/slide4.xml><?xml version="1.0" encoding="utf-8"?>
-<p:sld xmlns:a="http://schemas.openxmlformats.org/drawingml/2006/main" xmlns:p="http://schemas.openxmlformats.org/presentationml/2006/main" xmlns:r="http://schemas.openxmlformats.org/officeDocument/2006/relationships">
+<p:sld xmlns:a="http://schemas.openxmlformats.org/drawingml/2006/main" xmlns:r="http://schemas.openxmlformats.org/officeDocument/2006/relationships" xmlns:p="http://schemas.openxmlformats.org/presentationml/2006/main">
   <p:cSld>
     <p:bg>
       <p:bgPr>
         <a:solidFill>
           <a:srgbClr val="FFFFFF"/>
         </a:solidFill>
+        <a:effectLst/>
       </p:bgPr>
     </p:bg>
     <p:spTree>
@@ -5706,7 +5815,7 @@
           <a:noFill/>
         </p:spPr>
         <p:txBody>
-          <a:bodyPr wrap="square" lIns="0" rIns="0" tIns="0" bIns="0">
+          <a:bodyPr wrap="square" lIns="0" tIns="0" rIns="0" bIns="0">
             <a:spAutoFit/>
           </a:bodyPr>
           <a:lstStyle/>
@@ -5716,10 +5825,16 @@
                 <a:solidFill>
                   <a:srgbClr val="F2A93B"/>
                 </a:solidFill>
-                <a:latin typeface="Calibri"/>
+                <a:latin typeface="Calibri" panose="020F0502020204030204"/>
               </a:rPr>
               <a:t>STEP 02</a:t>
             </a:r>
+            <a:endParaRPr sz="1300" b="1" spc="200">
+              <a:solidFill>
+                <a:srgbClr val="F2A93B"/>
+              </a:solidFill>
+              <a:latin typeface="Calibri" panose="020F0502020204030204"/>
+            </a:endParaRPr>
           </a:p>
         </p:txBody>
       </p:sp>
@@ -5740,7 +5855,7 @@
           <a:noFill/>
         </p:spPr>
         <p:txBody>
-          <a:bodyPr wrap="square" lIns="0" rIns="0" tIns="0" bIns="0">
+          <a:bodyPr wrap="square" lIns="0" tIns="0" rIns="0" bIns="0">
             <a:spAutoFit/>
           </a:bodyPr>
           <a:lstStyle/>
@@ -5750,10 +5865,16 @@
                 <a:solidFill>
                   <a:srgbClr val="1E2761"/>
                 </a:solidFill>
-                <a:latin typeface="Cambria"/>
+                <a:latin typeface="Cambria" panose="02040503050406030204"/>
               </a:rPr>
               <a:t>Free account vs. pay as you go</a:t>
             </a:r>
+            <a:endParaRPr sz="3000" b="1">
+              <a:solidFill>
+                <a:srgbClr val="1E2761"/>
+              </a:solidFill>
+              <a:latin typeface="Cambria" panose="02040503050406030204"/>
+            </a:endParaRPr>
           </a:p>
         </p:txBody>
       </p:sp>
@@ -5774,7 +5895,7 @@
           <a:noFill/>
         </p:spPr>
         <p:txBody>
-          <a:bodyPr wrap="square" lIns="0" rIns="0" tIns="0" bIns="0">
+          <a:bodyPr wrap="square" lIns="0" tIns="0" rIns="0" bIns="0">
             <a:spAutoFit/>
           </a:bodyPr>
           <a:lstStyle/>
@@ -5784,10 +5905,16 @@
                 <a:solidFill>
                   <a:srgbClr val="1F2430"/>
                 </a:solidFill>
-                <a:latin typeface="Calibri"/>
+                <a:latin typeface="Calibri" panose="020F0502020204030204"/>
               </a:rPr>
               <a:t>Free account: USD200 credit for 30 days, 12 months of popular services free, and spending protection — the card is not charged automatically.</a:t>
             </a:r>
+            <a:endParaRPr sz="1400" b="0">
+              <a:solidFill>
+                <a:srgbClr val="1F2430"/>
+              </a:solidFill>
+              <a:latin typeface="Calibri" panose="020F0502020204030204"/>
+            </a:endParaRPr>
           </a:p>
         </p:txBody>
       </p:sp>
@@ -5800,7 +5927,7 @@
           <p:nvPr/>
         </p:nvPicPr>
         <p:blipFill>
-          <a:blip r:embed="rId2"/>
+          <a:blip r:embed="rId1"/>
           <a:stretch>
             <a:fillRect/>
           </a:stretch>
@@ -5835,13 +5962,12 @@
             <a:avLst/>
           </a:prstGeom>
           <a:noFill/>
-          <a:ln/>
         </p:spPr>
         <p:txBody>
           <a:bodyPr wrap="square" lIns="0" tIns="0" rIns="0" bIns="0" rtlCol="0" anchor="ctr"/>
           <a:lstStyle/>
           <a:p>
-            <a:pPr algn="l" indent="0" marL="0">
+            <a:pPr marL="0" indent="0" algn="l">
               <a:buNone/>
             </a:pPr>
             <a:r>
@@ -5849,9 +5975,9 @@
                 <a:solidFill>
                   <a:srgbClr val="6B7280"/>
                 </a:solidFill>
-                <a:latin typeface="Calibri" pitchFamily="34" charset="0"/>
-                <a:ea typeface="Calibri" pitchFamily="34" charset="-122"/>
-                <a:cs typeface="Calibri" pitchFamily="34" charset="-120"/>
+                <a:latin typeface="Calibri" panose="020F0502020204030204" pitchFamily="34" charset="0"/>
+                <a:ea typeface="Calibri" panose="020F0502020204030204" pitchFamily="34" charset="-122"/>
+                <a:cs typeface="Calibri" panose="020F0502020204030204" pitchFamily="34" charset="-120"/>
               </a:rPr>
               <a:t>Modern Enterprise Software Engineering  |  ÉSTIAM  |  Day 1</a:t>
             </a:r>
@@ -5868,13 +5994,14 @@
 </file>
 
 <file path=ppt/slides/slide5.xml><?xml version="1.0" encoding="utf-8"?>
-<p:sld xmlns:a="http://schemas.openxmlformats.org/drawingml/2006/main" xmlns:p="http://schemas.openxmlformats.org/presentationml/2006/main" xmlns:r="http://schemas.openxmlformats.org/officeDocument/2006/relationships">
+<p:sld xmlns:a="http://schemas.openxmlformats.org/drawingml/2006/main" xmlns:r="http://schemas.openxmlformats.org/officeDocument/2006/relationships" xmlns:p="http://schemas.openxmlformats.org/presentationml/2006/main">
   <p:cSld>
     <p:bg>
       <p:bgPr>
         <a:solidFill>
           <a:srgbClr val="FFFFFF"/>
         </a:solidFill>
+        <a:effectLst/>
       </p:bgPr>
     </p:bg>
     <p:spTree>
@@ -5901,7 +6028,7 @@
           <a:noFill/>
         </p:spPr>
         <p:txBody>
-          <a:bodyPr wrap="square" lIns="0" rIns="0" tIns="0" bIns="0">
+          <a:bodyPr wrap="square" lIns="0" tIns="0" rIns="0" bIns="0">
             <a:spAutoFit/>
           </a:bodyPr>
           <a:lstStyle/>
@@ -5911,10 +6038,16 @@
                 <a:solidFill>
                   <a:srgbClr val="F2A93B"/>
                 </a:solidFill>
-                <a:latin typeface="Calibri"/>
+                <a:latin typeface="Calibri" panose="020F0502020204030204"/>
               </a:rPr>
               <a:t>STEP 03</a:t>
             </a:r>
+            <a:endParaRPr sz="1300" b="1" spc="200">
+              <a:solidFill>
+                <a:srgbClr val="F2A93B"/>
+              </a:solidFill>
+              <a:latin typeface="Calibri" panose="020F0502020204030204"/>
+            </a:endParaRPr>
           </a:p>
         </p:txBody>
       </p:sp>
@@ -5935,7 +6068,7 @@
           <a:noFill/>
         </p:spPr>
         <p:txBody>
-          <a:bodyPr wrap="square" lIns="0" rIns="0" tIns="0" bIns="0">
+          <a:bodyPr wrap="square" lIns="0" tIns="0" rIns="0" bIns="0">
             <a:spAutoFit/>
           </a:bodyPr>
           <a:lstStyle/>
@@ -5945,10 +6078,16 @@
                 <a:solidFill>
                   <a:srgbClr val="1E2761"/>
                 </a:solidFill>
-                <a:latin typeface="Cambria"/>
+                <a:latin typeface="Cambria" panose="02040503050406030204"/>
               </a:rPr>
               <a:t>Pick an account — carefully</a:t>
             </a:r>
+            <a:endParaRPr sz="3000" b="1">
+              <a:solidFill>
+                <a:srgbClr val="1E2761"/>
+              </a:solidFill>
+              <a:latin typeface="Cambria" panose="02040503050406030204"/>
+            </a:endParaRPr>
           </a:p>
         </p:txBody>
       </p:sp>
@@ -5969,7 +6108,7 @@
           <a:noFill/>
         </p:spPr>
         <p:txBody>
-          <a:bodyPr wrap="square" lIns="0" rIns="0" tIns="0" bIns="0">
+          <a:bodyPr wrap="square" lIns="0" tIns="0" rIns="0" bIns="0">
             <a:spAutoFit/>
           </a:bodyPr>
           <a:lstStyle/>
@@ -5979,10 +6118,16 @@
                 <a:solidFill>
                   <a:srgbClr val="1F2430"/>
                 </a:solidFill>
-                <a:latin typeface="Calibri"/>
+                <a:latin typeface="Calibri" panose="020F0502020204030204"/>
               </a:rPr>
               <a:t>Windows offers accounts you are already signed in to. Do not use a work or school account here — choose 'Use another account'.</a:t>
             </a:r>
+            <a:endParaRPr sz="1400" b="0">
+              <a:solidFill>
+                <a:srgbClr val="1F2430"/>
+              </a:solidFill>
+              <a:latin typeface="Calibri" panose="020F0502020204030204"/>
+            </a:endParaRPr>
           </a:p>
         </p:txBody>
       </p:sp>
@@ -5995,7 +6140,7 @@
           <p:nvPr/>
         </p:nvPicPr>
         <p:blipFill>
-          <a:blip r:embed="rId2"/>
+          <a:blip r:embed="rId1"/>
           <a:stretch>
             <a:fillRect/>
           </a:stretch>
@@ -6030,13 +6175,12 @@
             <a:avLst/>
           </a:prstGeom>
           <a:noFill/>
-          <a:ln/>
         </p:spPr>
         <p:txBody>
           <a:bodyPr wrap="square" lIns="0" tIns="0" rIns="0" bIns="0" rtlCol="0" anchor="ctr"/>
           <a:lstStyle/>
           <a:p>
-            <a:pPr algn="l" indent="0" marL="0">
+            <a:pPr marL="0" indent="0" algn="l">
               <a:buNone/>
             </a:pPr>
             <a:r>
@@ -6044,9 +6188,9 @@
                 <a:solidFill>
                   <a:srgbClr val="6B7280"/>
                 </a:solidFill>
-                <a:latin typeface="Calibri" pitchFamily="34" charset="0"/>
-                <a:ea typeface="Calibri" pitchFamily="34" charset="-122"/>
-                <a:cs typeface="Calibri" pitchFamily="34" charset="-120"/>
+                <a:latin typeface="Calibri" panose="020F0502020204030204" pitchFamily="34" charset="0"/>
+                <a:ea typeface="Calibri" panose="020F0502020204030204" pitchFamily="34" charset="-122"/>
+                <a:cs typeface="Calibri" panose="020F0502020204030204" pitchFamily="34" charset="-120"/>
               </a:rPr>
               <a:t>Modern Enterprise Software Engineering  |  ÉSTIAM  |  Day 1</a:t>
             </a:r>
@@ -6063,13 +6207,14 @@
 </file>
 
 <file path=ppt/slides/slide6.xml><?xml version="1.0" encoding="utf-8"?>
-<p:sld xmlns:a="http://schemas.openxmlformats.org/drawingml/2006/main" xmlns:p="http://schemas.openxmlformats.org/presentationml/2006/main" xmlns:r="http://schemas.openxmlformats.org/officeDocument/2006/relationships">
+<p:sld xmlns:a="http://schemas.openxmlformats.org/drawingml/2006/main" xmlns:r="http://schemas.openxmlformats.org/officeDocument/2006/relationships" xmlns:p="http://schemas.openxmlformats.org/presentationml/2006/main">
   <p:cSld>
     <p:bg>
       <p:bgPr>
         <a:solidFill>
           <a:srgbClr val="FFFFFF"/>
         </a:solidFill>
+        <a:effectLst/>
       </p:bgPr>
     </p:bg>
     <p:spTree>
@@ -6096,7 +6241,7 @@
           <a:noFill/>
         </p:spPr>
         <p:txBody>
-          <a:bodyPr wrap="square" lIns="0" rIns="0" tIns="0" bIns="0">
+          <a:bodyPr wrap="square" lIns="0" tIns="0" rIns="0" bIns="0">
             <a:spAutoFit/>
           </a:bodyPr>
           <a:lstStyle/>
@@ -6106,10 +6251,16 @@
                 <a:solidFill>
                   <a:srgbClr val="F2A93B"/>
                 </a:solidFill>
-                <a:latin typeface="Calibri"/>
+                <a:latin typeface="Calibri" panose="020F0502020204030204"/>
               </a:rPr>
               <a:t>STEP 04</a:t>
             </a:r>
+            <a:endParaRPr sz="1300" b="1" spc="200">
+              <a:solidFill>
+                <a:srgbClr val="F2A93B"/>
+              </a:solidFill>
+              <a:latin typeface="Calibri" panose="020F0502020204030204"/>
+            </a:endParaRPr>
           </a:p>
         </p:txBody>
       </p:sp>
@@ -6130,7 +6281,7 @@
           <a:noFill/>
         </p:spPr>
         <p:txBody>
-          <a:bodyPr wrap="square" lIns="0" rIns="0" tIns="0" bIns="0">
+          <a:bodyPr wrap="square" lIns="0" tIns="0" rIns="0" bIns="0">
             <a:spAutoFit/>
           </a:bodyPr>
           <a:lstStyle/>
@@ -6140,10 +6291,16 @@
                 <a:solidFill>
                   <a:srgbClr val="1E2761"/>
                 </a:solidFill>
-                <a:latin typeface="Cambria"/>
+                <a:latin typeface="Cambria" panose="02040503050406030204"/>
               </a:rPr>
               <a:t>Sign in, or create one</a:t>
             </a:r>
+            <a:endParaRPr sz="3000" b="1">
+              <a:solidFill>
+                <a:srgbClr val="1E2761"/>
+              </a:solidFill>
+              <a:latin typeface="Cambria" panose="02040503050406030204"/>
+            </a:endParaRPr>
           </a:p>
         </p:txBody>
       </p:sp>
@@ -6164,7 +6321,7 @@
           <a:noFill/>
         </p:spPr>
         <p:txBody>
-          <a:bodyPr wrap="square" lIns="0" rIns="0" tIns="0" bIns="0">
+          <a:bodyPr wrap="square" lIns="0" tIns="0" rIns="0" bIns="0">
             <a:spAutoFit/>
           </a:bodyPr>
           <a:lstStyle/>
@@ -6174,10 +6331,16 @@
                 <a:solidFill>
                   <a:srgbClr val="1F2430"/>
                 </a:solidFill>
-                <a:latin typeface="Calibri"/>
+                <a:latin typeface="Calibri" panose="020F0502020204030204"/>
               </a:rPr>
               <a:t>No personal Microsoft account yet? 'Create one!' branches into account creation before the Azure sign-up resumes.</a:t>
             </a:r>
+            <a:endParaRPr sz="1400" b="0">
+              <a:solidFill>
+                <a:srgbClr val="1F2430"/>
+              </a:solidFill>
+              <a:latin typeface="Calibri" panose="020F0502020204030204"/>
+            </a:endParaRPr>
           </a:p>
         </p:txBody>
       </p:sp>
@@ -6190,7 +6353,7 @@
           <p:nvPr/>
         </p:nvPicPr>
         <p:blipFill>
-          <a:blip r:embed="rId2"/>
+          <a:blip r:embed="rId1"/>
           <a:stretch>
             <a:fillRect/>
           </a:stretch>
@@ -6225,13 +6388,12 @@
             <a:avLst/>
           </a:prstGeom>
           <a:noFill/>
-          <a:ln/>
         </p:spPr>
         <p:txBody>
           <a:bodyPr wrap="square" lIns="0" tIns="0" rIns="0" bIns="0" rtlCol="0" anchor="ctr"/>
           <a:lstStyle/>
           <a:p>
-            <a:pPr algn="l" indent="0" marL="0">
+            <a:pPr marL="0" indent="0" algn="l">
               <a:buNone/>
             </a:pPr>
             <a:r>
@@ -6239,9 +6401,9 @@
                 <a:solidFill>
                   <a:srgbClr val="6B7280"/>
                 </a:solidFill>
-                <a:latin typeface="Calibri" pitchFamily="34" charset="0"/>
-                <a:ea typeface="Calibri" pitchFamily="34" charset="-122"/>
-                <a:cs typeface="Calibri" pitchFamily="34" charset="-120"/>
+                <a:latin typeface="Calibri" panose="020F0502020204030204" pitchFamily="34" charset="0"/>
+                <a:ea typeface="Calibri" panose="020F0502020204030204" pitchFamily="34" charset="-122"/>
+                <a:cs typeface="Calibri" panose="020F0502020204030204" pitchFamily="34" charset="-120"/>
               </a:rPr>
               <a:t>Modern Enterprise Software Engineering  |  ÉSTIAM  |  Day 1</a:t>
             </a:r>
@@ -6258,13 +6420,14 @@
 </file>
 
 <file path=ppt/slides/slide7.xml><?xml version="1.0" encoding="utf-8"?>
-<p:sld xmlns:a="http://schemas.openxmlformats.org/drawingml/2006/main" xmlns:p="http://schemas.openxmlformats.org/presentationml/2006/main" xmlns:r="http://schemas.openxmlformats.org/officeDocument/2006/relationships">
+<p:sld xmlns:a="http://schemas.openxmlformats.org/drawingml/2006/main" xmlns:r="http://schemas.openxmlformats.org/officeDocument/2006/relationships" xmlns:p="http://schemas.openxmlformats.org/presentationml/2006/main">
   <p:cSld>
     <p:bg>
       <p:bgPr>
         <a:solidFill>
           <a:srgbClr val="FFFFFF"/>
         </a:solidFill>
+        <a:effectLst/>
       </p:bgPr>
     </p:bg>
     <p:spTree>
@@ -6291,7 +6454,7 @@
           <a:noFill/>
         </p:spPr>
         <p:txBody>
-          <a:bodyPr wrap="square" lIns="0" rIns="0" tIns="0" bIns="0">
+          <a:bodyPr wrap="square" lIns="0" tIns="0" rIns="0" bIns="0">
             <a:spAutoFit/>
           </a:bodyPr>
           <a:lstStyle/>
@@ -6301,10 +6464,16 @@
                 <a:solidFill>
                   <a:srgbClr val="F2A93B"/>
                 </a:solidFill>
-                <a:latin typeface="Calibri"/>
+                <a:latin typeface="Calibri" panose="020F0502020204030204"/>
               </a:rPr>
               <a:t>STEP 05</a:t>
             </a:r>
+            <a:endParaRPr sz="1300" b="1" spc="200">
+              <a:solidFill>
+                <a:srgbClr val="F2A93B"/>
+              </a:solidFill>
+              <a:latin typeface="Calibri" panose="020F0502020204030204"/>
+            </a:endParaRPr>
           </a:p>
         </p:txBody>
       </p:sp>
@@ -6325,7 +6494,7 @@
           <a:noFill/>
         </p:spPr>
         <p:txBody>
-          <a:bodyPr wrap="square" lIns="0" rIns="0" tIns="0" bIns="0">
+          <a:bodyPr wrap="square" lIns="0" tIns="0" rIns="0" bIns="0">
             <a:spAutoFit/>
           </a:bodyPr>
           <a:lstStyle/>
@@ -6335,10 +6504,16 @@
                 <a:solidFill>
                   <a:srgbClr val="1E2761"/>
                 </a:solidFill>
-                <a:latin typeface="Cambria"/>
+                <a:latin typeface="Cambria" panose="02040503050406030204"/>
               </a:rPr>
               <a:t>Create your Microsoft account</a:t>
             </a:r>
+            <a:endParaRPr sz="3000" b="1">
+              <a:solidFill>
+                <a:srgbClr val="1E2761"/>
+              </a:solidFill>
+              <a:latin typeface="Cambria" panose="02040503050406030204"/>
+            </a:endParaRPr>
           </a:p>
         </p:txBody>
       </p:sp>
@@ -6359,7 +6534,7 @@
           <a:noFill/>
         </p:spPr>
         <p:txBody>
-          <a:bodyPr wrap="square" lIns="0" rIns="0" tIns="0" bIns="0">
+          <a:bodyPr wrap="square" lIns="0" tIns="0" rIns="0" bIns="0">
             <a:spAutoFit/>
           </a:bodyPr>
           <a:lstStyle/>
@@ -6369,10 +6544,16 @@
                 <a:solidFill>
                   <a:srgbClr val="1F2430"/>
                 </a:solidFill>
-                <a:latin typeface="Calibri"/>
+                <a:latin typeface="Calibri" panose="020F0502020204030204"/>
               </a:rPr>
               <a:t>Pick a new @outlook.com address, or use the dropdown to register an email you already own.</a:t>
             </a:r>
+            <a:endParaRPr sz="1400" b="0">
+              <a:solidFill>
+                <a:srgbClr val="1F2430"/>
+              </a:solidFill>
+              <a:latin typeface="Calibri" panose="020F0502020204030204"/>
+            </a:endParaRPr>
           </a:p>
         </p:txBody>
       </p:sp>
@@ -6385,7 +6566,7 @@
           <p:nvPr/>
         </p:nvPicPr>
         <p:blipFill>
-          <a:blip r:embed="rId2"/>
+          <a:blip r:embed="rId1"/>
           <a:stretch>
             <a:fillRect/>
           </a:stretch>
@@ -6420,13 +6601,12 @@
             <a:avLst/>
           </a:prstGeom>
           <a:noFill/>
-          <a:ln/>
         </p:spPr>
         <p:txBody>
           <a:bodyPr wrap="square" lIns="0" tIns="0" rIns="0" bIns="0" rtlCol="0" anchor="ctr"/>
           <a:lstStyle/>
           <a:p>
-            <a:pPr algn="l" indent="0" marL="0">
+            <a:pPr marL="0" indent="0" algn="l">
               <a:buNone/>
             </a:pPr>
             <a:r>
@@ -6434,9 +6614,9 @@
                 <a:solidFill>
                   <a:srgbClr val="6B7280"/>
                 </a:solidFill>
-                <a:latin typeface="Calibri" pitchFamily="34" charset="0"/>
-                <a:ea typeface="Calibri" pitchFamily="34" charset="-122"/>
-                <a:cs typeface="Calibri" pitchFamily="34" charset="-120"/>
+                <a:latin typeface="Calibri" panose="020F0502020204030204" pitchFamily="34" charset="0"/>
+                <a:ea typeface="Calibri" panose="020F0502020204030204" pitchFamily="34" charset="-122"/>
+                <a:cs typeface="Calibri" panose="020F0502020204030204" pitchFamily="34" charset="-120"/>
               </a:rPr>
               <a:t>Modern Enterprise Software Engineering  |  ÉSTIAM  |  Day 1</a:t>
             </a:r>
@@ -6453,13 +6633,14 @@
 </file>
 
 <file path=ppt/slides/slide8.xml><?xml version="1.0" encoding="utf-8"?>
-<p:sld xmlns:a="http://schemas.openxmlformats.org/drawingml/2006/main" xmlns:p="http://schemas.openxmlformats.org/presentationml/2006/main" xmlns:r="http://schemas.openxmlformats.org/officeDocument/2006/relationships">
+<p:sld xmlns:a="http://schemas.openxmlformats.org/drawingml/2006/main" xmlns:r="http://schemas.openxmlformats.org/officeDocument/2006/relationships" xmlns:p="http://schemas.openxmlformats.org/presentationml/2006/main">
   <p:cSld>
     <p:bg>
       <p:bgPr>
         <a:solidFill>
           <a:srgbClr val="FFFFFF"/>
         </a:solidFill>
+        <a:effectLst/>
       </p:bgPr>
     </p:bg>
     <p:spTree>
@@ -6486,7 +6667,7 @@
           <a:noFill/>
         </p:spPr>
         <p:txBody>
-          <a:bodyPr wrap="square" lIns="0" rIns="0" tIns="0" bIns="0">
+          <a:bodyPr wrap="square" lIns="0" tIns="0" rIns="0" bIns="0">
             <a:spAutoFit/>
           </a:bodyPr>
           <a:lstStyle/>
@@ -6496,10 +6677,16 @@
                 <a:solidFill>
                   <a:srgbClr val="F2A93B"/>
                 </a:solidFill>
-                <a:latin typeface="Calibri"/>
+                <a:latin typeface="Calibri" panose="020F0502020204030204"/>
               </a:rPr>
               <a:t>STEP 06</a:t>
             </a:r>
+            <a:endParaRPr sz="1300" b="1" spc="200">
+              <a:solidFill>
+                <a:srgbClr val="F2A93B"/>
+              </a:solidFill>
+              <a:latin typeface="Calibri" panose="020F0502020204030204"/>
+            </a:endParaRPr>
           </a:p>
         </p:txBody>
       </p:sp>
@@ -6520,7 +6707,7 @@
           <a:noFill/>
         </p:spPr>
         <p:txBody>
-          <a:bodyPr wrap="square" lIns="0" rIns="0" tIns="0" bIns="0">
+          <a:bodyPr wrap="square" lIns="0" tIns="0" rIns="0" bIns="0">
             <a:spAutoFit/>
           </a:bodyPr>
           <a:lstStyle/>
@@ -6530,10 +6717,16 @@
                 <a:solidFill>
                   <a:srgbClr val="1E2761"/>
                 </a:solidFill>
-                <a:latin typeface="Cambria"/>
+                <a:latin typeface="Cambria" panose="02040503050406030204"/>
               </a:rPr>
               <a:t>Country/region and date of birth</a:t>
             </a:r>
+            <a:endParaRPr sz="3000" b="1">
+              <a:solidFill>
+                <a:srgbClr val="1E2761"/>
+              </a:solidFill>
+              <a:latin typeface="Cambria" panose="02040503050406030204"/>
+            </a:endParaRPr>
           </a:p>
         </p:txBody>
       </p:sp>
@@ -6554,7 +6747,7 @@
           <a:noFill/>
         </p:spPr>
         <p:txBody>
-          <a:bodyPr wrap="square" lIns="0" rIns="0" tIns="0" bIns="0">
+          <a:bodyPr wrap="square" lIns="0" tIns="0" rIns="0" bIns="0">
             <a:spAutoFit/>
           </a:bodyPr>
           <a:lstStyle/>
@@ -6564,10 +6757,16 @@
                 <a:solidFill>
                   <a:srgbClr val="1F2430"/>
                 </a:solidFill>
-                <a:latin typeface="Calibri"/>
+                <a:latin typeface="Calibri" panose="020F0502020204030204"/>
               </a:rPr>
               <a:t>This country setting is about age-appropriate defaults. The billing country comes later — and that one cannot be changed afterwards.</a:t>
             </a:r>
+            <a:endParaRPr sz="1400" b="0">
+              <a:solidFill>
+                <a:srgbClr val="1F2430"/>
+              </a:solidFill>
+              <a:latin typeface="Calibri" panose="020F0502020204030204"/>
+            </a:endParaRPr>
           </a:p>
         </p:txBody>
       </p:sp>
@@ -6580,7 +6779,7 @@
           <p:nvPr/>
         </p:nvPicPr>
         <p:blipFill>
-          <a:blip r:embed="rId2"/>
+          <a:blip r:embed="rId1"/>
           <a:stretch>
             <a:fillRect/>
           </a:stretch>
@@ -6615,13 +6814,12 @@
             <a:avLst/>
           </a:prstGeom>
           <a:noFill/>
-          <a:ln/>
         </p:spPr>
         <p:txBody>
           <a:bodyPr wrap="square" lIns="0" tIns="0" rIns="0" bIns="0" rtlCol="0" anchor="ctr"/>
           <a:lstStyle/>
           <a:p>
-            <a:pPr algn="l" indent="0" marL="0">
+            <a:pPr marL="0" indent="0" algn="l">
               <a:buNone/>
             </a:pPr>
             <a:r>
@@ -6629,9 +6827,9 @@
                 <a:solidFill>
                   <a:srgbClr val="6B7280"/>
                 </a:solidFill>
-                <a:latin typeface="Calibri" pitchFamily="34" charset="0"/>
-                <a:ea typeface="Calibri" pitchFamily="34" charset="-122"/>
-                <a:cs typeface="Calibri" pitchFamily="34" charset="-120"/>
+                <a:latin typeface="Calibri" panose="020F0502020204030204" pitchFamily="34" charset="0"/>
+                <a:ea typeface="Calibri" panose="020F0502020204030204" pitchFamily="34" charset="-122"/>
+                <a:cs typeface="Calibri" panose="020F0502020204030204" pitchFamily="34" charset="-120"/>
               </a:rPr>
               <a:t>Modern Enterprise Software Engineering  |  ÉSTIAM  |  Day 1</a:t>
             </a:r>
@@ -6648,13 +6846,14 @@
 </file>
 
 <file path=ppt/slides/slide9.xml><?xml version="1.0" encoding="utf-8"?>
-<p:sld xmlns:a="http://schemas.openxmlformats.org/drawingml/2006/main" xmlns:p="http://schemas.openxmlformats.org/presentationml/2006/main" xmlns:r="http://schemas.openxmlformats.org/officeDocument/2006/relationships">
+<p:sld xmlns:a="http://schemas.openxmlformats.org/drawingml/2006/main" xmlns:r="http://schemas.openxmlformats.org/officeDocument/2006/relationships" xmlns:p="http://schemas.openxmlformats.org/presentationml/2006/main">
   <p:cSld>
     <p:bg>
       <p:bgPr>
         <a:solidFill>
           <a:srgbClr val="FFFFFF"/>
         </a:solidFill>
+        <a:effectLst/>
       </p:bgPr>
     </p:bg>
     <p:spTree>
@@ -6681,7 +6880,7 @@
           <a:noFill/>
         </p:spPr>
         <p:txBody>
-          <a:bodyPr wrap="square" lIns="0" rIns="0" tIns="0" bIns="0">
+          <a:bodyPr wrap="square" lIns="0" tIns="0" rIns="0" bIns="0">
             <a:spAutoFit/>
           </a:bodyPr>
           <a:lstStyle/>
@@ -6691,10 +6890,16 @@
                 <a:solidFill>
                   <a:srgbClr val="F2A93B"/>
                 </a:solidFill>
-                <a:latin typeface="Calibri"/>
+                <a:latin typeface="Calibri" panose="020F0502020204030204"/>
               </a:rPr>
               <a:t>STEP 07</a:t>
             </a:r>
+            <a:endParaRPr sz="1300" b="1" spc="200">
+              <a:solidFill>
+                <a:srgbClr val="F2A93B"/>
+              </a:solidFill>
+              <a:latin typeface="Calibri" panose="020F0502020204030204"/>
+            </a:endParaRPr>
           </a:p>
         </p:txBody>
       </p:sp>
@@ -6715,7 +6920,7 @@
           <a:noFill/>
         </p:spPr>
         <p:txBody>
-          <a:bodyPr wrap="square" lIns="0" rIns="0" tIns="0" bIns="0">
+          <a:bodyPr wrap="square" lIns="0" tIns="0" rIns="0" bIns="0">
             <a:spAutoFit/>
           </a:bodyPr>
           <a:lstStyle/>
@@ -6725,10 +6930,16 @@
                 <a:solidFill>
                   <a:srgbClr val="1E2761"/>
                 </a:solidFill>
-                <a:latin typeface="Cambria"/>
+                <a:latin typeface="Cambria" panose="02040503050406030204"/>
               </a:rPr>
               <a:t>Name on the account</a:t>
             </a:r>
+            <a:endParaRPr sz="3000" b="1">
+              <a:solidFill>
+                <a:srgbClr val="1E2761"/>
+              </a:solidFill>
+              <a:latin typeface="Cambria" panose="02040503050406030204"/>
+            </a:endParaRPr>
           </a:p>
         </p:txBody>
       </p:sp>
@@ -6749,7 +6960,7 @@
           <a:noFill/>
         </p:spPr>
         <p:txBody>
-          <a:bodyPr wrap="square" lIns="0" rIns="0" tIns="0" bIns="0">
+          <a:bodyPr wrap="square" lIns="0" tIns="0" rIns="0" bIns="0">
             <a:spAutoFit/>
           </a:bodyPr>
           <a:lstStyle/>
@@ -6759,10 +6970,16 @@
                 <a:solidFill>
                   <a:srgbClr val="1F2430"/>
                 </a:solidFill>
-                <a:latin typeface="Calibri"/>
+                <a:latin typeface="Calibri" panose="020F0502020204030204"/>
               </a:rPr>
               <a:t>Use the real name — it has to match the card details entered at the payment step.</a:t>
             </a:r>
+            <a:endParaRPr sz="1400" b="0">
+              <a:solidFill>
+                <a:srgbClr val="1F2430"/>
+              </a:solidFill>
+              <a:latin typeface="Calibri" panose="020F0502020204030204"/>
+            </a:endParaRPr>
           </a:p>
         </p:txBody>
       </p:sp>
@@ -6775,7 +6992,7 @@
           <p:nvPr/>
         </p:nvPicPr>
         <p:blipFill>
-          <a:blip r:embed="rId2"/>
+          <a:blip r:embed="rId1"/>
           <a:stretch>
             <a:fillRect/>
           </a:stretch>
@@ -6810,13 +7027,12 @@
             <a:avLst/>
           </a:prstGeom>
           <a:noFill/>
-          <a:ln/>
         </p:spPr>
         <p:txBody>
           <a:bodyPr wrap="square" lIns="0" tIns="0" rIns="0" bIns="0" rtlCol="0" anchor="ctr"/>
           <a:lstStyle/>
           <a:p>
-            <a:pPr algn="l" indent="0" marL="0">
+            <a:pPr marL="0" indent="0" algn="l">
               <a:buNone/>
             </a:pPr>
             <a:r>
@@ -6824,9 +7040,9 @@
                 <a:solidFill>
                   <a:srgbClr val="6B7280"/>
                 </a:solidFill>
-                <a:latin typeface="Calibri" pitchFamily="34" charset="0"/>
-                <a:ea typeface="Calibri" pitchFamily="34" charset="-122"/>
-                <a:cs typeface="Calibri" pitchFamily="34" charset="-120"/>
+                <a:latin typeface="Calibri" panose="020F0502020204030204" pitchFamily="34" charset="0"/>
+                <a:ea typeface="Calibri" panose="020F0502020204030204" pitchFamily="34" charset="-122"/>
+                <a:cs typeface="Calibri" panose="020F0502020204030204" pitchFamily="34" charset="-120"/>
               </a:rPr>
               <a:t>Modern Enterprise Software Engineering  |  ÉSTIAM  |  Day 1</a:t>
             </a:r>
@@ -6885,7 +7101,7 @@
     </a:clrScheme>
     <a:fontScheme name="Office">
       <a:majorFont>
-        <a:latin typeface="Calibri Light" panose="020F0302020204030204"/>
+        <a:latin typeface="Calibri Light"/>
         <a:ea typeface=""/>
         <a:cs typeface=""/>
         <a:font script="Jpan" typeface="游ゴシック Light"/>
@@ -6918,26 +7134,9 @@
         <a:font script="Viet" typeface="Times New Roman"/>
         <a:font script="Uigh" typeface="Microsoft Uighur"/>
         <a:font script="Geor" typeface="Sylfaen"/>
-        <a:font script="Armn" typeface="Arial"/>
-        <a:font script="Bugi" typeface="Leelawadee UI"/>
-        <a:font script="Bopo" typeface="Microsoft JhengHei"/>
-        <a:font script="Java" typeface="Javanese Text"/>
-        <a:font script="Lisu" typeface="Segoe UI"/>
-        <a:font script="Mymr" typeface="Myanmar Text"/>
-        <a:font script="Nkoo" typeface="Ebrima"/>
-        <a:font script="Olck" typeface="Nirmala UI"/>
-        <a:font script="Osma" typeface="Ebrima"/>
-        <a:font script="Phag" typeface="Phagspa"/>
-        <a:font script="Syrn" typeface="Estrangelo Edessa"/>
-        <a:font script="Syrj" typeface="Estrangelo Edessa"/>
-        <a:font script="Syre" typeface="Estrangelo Edessa"/>
-        <a:font script="Sora" typeface="Nirmala UI"/>
-        <a:font script="Tale" typeface="Microsoft Tai Le"/>
-        <a:font script="Talu" typeface="Microsoft New Tai Lue"/>
-        <a:font script="Tfng" typeface="Ebrima"/>
       </a:majorFont>
       <a:minorFont>
-        <a:latin typeface="Calibri" panose="020F0502020204030204"/>
+        <a:latin typeface="Calibri"/>
         <a:ea typeface=""/>
         <a:cs typeface=""/>
         <a:font script="Jpan" typeface="游ゴシック"/>
@@ -6970,23 +7169,6 @@
         <a:font script="Viet" typeface="Arial"/>
         <a:font script="Uigh" typeface="Microsoft Uighur"/>
         <a:font script="Geor" typeface="Sylfaen"/>
-        <a:font script="Armn" typeface="Arial"/>
-        <a:font script="Bugi" typeface="Leelawadee UI"/>
-        <a:font script="Bopo" typeface="Microsoft JhengHei"/>
-        <a:font script="Java" typeface="Javanese Text"/>
-        <a:font script="Lisu" typeface="Segoe UI"/>
-        <a:font script="Mymr" typeface="Myanmar Text"/>
-        <a:font script="Nkoo" typeface="Ebrima"/>
-        <a:font script="Olck" typeface="Nirmala UI"/>
-        <a:font script="Osma" typeface="Ebrima"/>
-        <a:font script="Phag" typeface="Phagspa"/>
-        <a:font script="Syrn" typeface="Estrangelo Edessa"/>
-        <a:font script="Syrj" typeface="Estrangelo Edessa"/>
-        <a:font script="Syre" typeface="Estrangelo Edessa"/>
-        <a:font script="Sora" typeface="Nirmala UI"/>
-        <a:font script="Tale" typeface="Microsoft Tai Le"/>
-        <a:font script="Talu" typeface="Microsoft New Tai Lue"/>
-        <a:font script="Tfng" typeface="Ebrima"/>
       </a:minorFont>
     </a:fontScheme>
     <a:fmtScheme name="Office">
@@ -7127,8 +7309,265 @@
       </a:bgFillStyleLst>
     </a:fmtScheme>
   </a:themeElements>
-  <a:objectDefaults/>
-  <a:extraClrSchemeLst/>
+  <a:extLst>
+    <a:ext uri="{05A4C25C-085E-4340-85A3-A5531E510DB2}">
+      <thm15:themeFamily xmlns:thm15="http://schemas.microsoft.com/office/thememl/2012/main" name="Office Theme" id="{62F939B6-93AF-4DB8-9C6B-D6C7DFDC589F}" vid="{4A3C46E8-61CC-4603-A589-7422A47A8E4A}"/>
+    </a:ext>
+  </a:extLst>
+</a:theme>
+</file>
+
+<file path=ppt/theme/theme2.xml><?xml version="1.0" encoding="utf-8"?>
+<a:theme xmlns:a="http://schemas.openxmlformats.org/drawingml/2006/main" name="Office Theme">
+  <a:themeElements>
+    <a:clrScheme name="Office">
+      <a:dk1>
+        <a:sysClr val="windowText" lastClr="000000"/>
+      </a:dk1>
+      <a:lt1>
+        <a:sysClr val="window" lastClr="FFFFFF"/>
+      </a:lt1>
+      <a:dk2>
+        <a:srgbClr val="44546A"/>
+      </a:dk2>
+      <a:lt2>
+        <a:srgbClr val="E7E6E6"/>
+      </a:lt2>
+      <a:accent1>
+        <a:srgbClr val="4472C4"/>
+      </a:accent1>
+      <a:accent2>
+        <a:srgbClr val="ED7D31"/>
+      </a:accent2>
+      <a:accent3>
+        <a:srgbClr val="A5A5A5"/>
+      </a:accent3>
+      <a:accent4>
+        <a:srgbClr val="FFC000"/>
+      </a:accent4>
+      <a:accent5>
+        <a:srgbClr val="5B9BD5"/>
+      </a:accent5>
+      <a:accent6>
+        <a:srgbClr val="70AD47"/>
+      </a:accent6>
+      <a:hlink>
+        <a:srgbClr val="0563C1"/>
+      </a:hlink>
+      <a:folHlink>
+        <a:srgbClr val="954F72"/>
+      </a:folHlink>
+    </a:clrScheme>
+    <a:fontScheme name="Office">
+      <a:majorFont>
+        <a:latin typeface="Calibri Light"/>
+        <a:ea typeface=""/>
+        <a:cs typeface=""/>
+        <a:font script="Jpan" typeface="游ゴシック Light"/>
+        <a:font script="Hang" typeface="맑은 고딕"/>
+        <a:font script="Hans" typeface="等线 Light"/>
+        <a:font script="Hant" typeface="新細明體"/>
+        <a:font script="Arab" typeface="Times New Roman"/>
+        <a:font script="Hebr" typeface="Times New Roman"/>
+        <a:font script="Thai" typeface="Angsana New"/>
+        <a:font script="Ethi" typeface="Nyala"/>
+        <a:font script="Beng" typeface="Vrinda"/>
+        <a:font script="Gujr" typeface="Shruti"/>
+        <a:font script="Khmr" typeface="MoolBoran"/>
+        <a:font script="Knda" typeface="Tunga"/>
+        <a:font script="Guru" typeface="Raavi"/>
+        <a:font script="Cans" typeface="Euphemia"/>
+        <a:font script="Cher" typeface="Plantagenet Cherokee"/>
+        <a:font script="Yiii" typeface="Microsoft Yi Baiti"/>
+        <a:font script="Tibt" typeface="Microsoft Himalaya"/>
+        <a:font script="Thaa" typeface="MV Boli"/>
+        <a:font script="Deva" typeface="Mangal"/>
+        <a:font script="Telu" typeface="Gautami"/>
+        <a:font script="Taml" typeface="Latha"/>
+        <a:font script="Syrc" typeface="Estrangelo Edessa"/>
+        <a:font script="Orya" typeface="Kalinga"/>
+        <a:font script="Mlym" typeface="Kartika"/>
+        <a:font script="Laoo" typeface="DokChampa"/>
+        <a:font script="Sinh" typeface="Iskoola Pota"/>
+        <a:font script="Mong" typeface="Mongolian Baiti"/>
+        <a:font script="Viet" typeface="Times New Roman"/>
+        <a:font script="Uigh" typeface="Microsoft Uighur"/>
+        <a:font script="Geor" typeface="Sylfaen"/>
+      </a:majorFont>
+      <a:minorFont>
+        <a:latin typeface="Calibri"/>
+        <a:ea typeface=""/>
+        <a:cs typeface=""/>
+        <a:font script="Jpan" typeface="游ゴシック"/>
+        <a:font script="Hang" typeface="맑은 고딕"/>
+        <a:font script="Hans" typeface="等线"/>
+        <a:font script="Hant" typeface="新細明體"/>
+        <a:font script="Arab" typeface="Arial"/>
+        <a:font script="Hebr" typeface="Arial"/>
+        <a:font script="Thai" typeface="Cordia New"/>
+        <a:font script="Ethi" typeface="Nyala"/>
+        <a:font script="Beng" typeface="Vrinda"/>
+        <a:font script="Gujr" typeface="Shruti"/>
+        <a:font script="Khmr" typeface="DaunPenh"/>
+        <a:font script="Knda" typeface="Tunga"/>
+        <a:font script="Guru" typeface="Raavi"/>
+        <a:font script="Cans" typeface="Euphemia"/>
+        <a:font script="Cher" typeface="Plantagenet Cherokee"/>
+        <a:font script="Yiii" typeface="Microsoft Yi Baiti"/>
+        <a:font script="Tibt" typeface="Microsoft Himalaya"/>
+        <a:font script="Thaa" typeface="MV Boli"/>
+        <a:font script="Deva" typeface="Mangal"/>
+        <a:font script="Telu" typeface="Gautami"/>
+        <a:font script="Taml" typeface="Latha"/>
+        <a:font script="Syrc" typeface="Estrangelo Edessa"/>
+        <a:font script="Orya" typeface="Kalinga"/>
+        <a:font script="Mlym" typeface="Kartika"/>
+        <a:font script="Laoo" typeface="DokChampa"/>
+        <a:font script="Sinh" typeface="Iskoola Pota"/>
+        <a:font script="Mong" typeface="Mongolian Baiti"/>
+        <a:font script="Viet" typeface="Arial"/>
+        <a:font script="Uigh" typeface="Microsoft Uighur"/>
+        <a:font script="Geor" typeface="Sylfaen"/>
+      </a:minorFont>
+    </a:fontScheme>
+    <a:fmtScheme name="Office">
+      <a:fillStyleLst>
+        <a:solidFill>
+          <a:schemeClr val="phClr"/>
+        </a:solidFill>
+        <a:gradFill rotWithShape="1">
+          <a:gsLst>
+            <a:gs pos="0">
+              <a:schemeClr val="phClr">
+                <a:lumMod val="110000"/>
+                <a:satMod val="105000"/>
+                <a:tint val="67000"/>
+              </a:schemeClr>
+            </a:gs>
+            <a:gs pos="50000">
+              <a:schemeClr val="phClr">
+                <a:lumMod val="105000"/>
+                <a:satMod val="103000"/>
+                <a:tint val="73000"/>
+              </a:schemeClr>
+            </a:gs>
+            <a:gs pos="100000">
+              <a:schemeClr val="phClr">
+                <a:lumMod val="105000"/>
+                <a:satMod val="109000"/>
+                <a:tint val="81000"/>
+              </a:schemeClr>
+            </a:gs>
+          </a:gsLst>
+          <a:lin ang="5400000" scaled="0"/>
+        </a:gradFill>
+        <a:gradFill rotWithShape="1">
+          <a:gsLst>
+            <a:gs pos="0">
+              <a:schemeClr val="phClr">
+                <a:satMod val="103000"/>
+                <a:lumMod val="102000"/>
+                <a:tint val="94000"/>
+              </a:schemeClr>
+            </a:gs>
+            <a:gs pos="50000">
+              <a:schemeClr val="phClr">
+                <a:satMod val="110000"/>
+                <a:lumMod val="100000"/>
+                <a:shade val="100000"/>
+              </a:schemeClr>
+            </a:gs>
+            <a:gs pos="100000">
+              <a:schemeClr val="phClr">
+                <a:lumMod val="99000"/>
+                <a:satMod val="120000"/>
+                <a:shade val="78000"/>
+              </a:schemeClr>
+            </a:gs>
+          </a:gsLst>
+          <a:lin ang="5400000" scaled="0"/>
+        </a:gradFill>
+      </a:fillStyleLst>
+      <a:lnStyleLst>
+        <a:ln w="6350" cap="flat" cmpd="sng" algn="ctr">
+          <a:solidFill>
+            <a:schemeClr val="phClr"/>
+          </a:solidFill>
+          <a:prstDash val="solid"/>
+          <a:miter lim="800000"/>
+        </a:ln>
+        <a:ln w="12700" cap="flat" cmpd="sng" algn="ctr">
+          <a:solidFill>
+            <a:schemeClr val="phClr"/>
+          </a:solidFill>
+          <a:prstDash val="solid"/>
+          <a:miter lim="800000"/>
+        </a:ln>
+        <a:ln w="19050" cap="flat" cmpd="sng" algn="ctr">
+          <a:solidFill>
+            <a:schemeClr val="phClr"/>
+          </a:solidFill>
+          <a:prstDash val="solid"/>
+          <a:miter lim="800000"/>
+        </a:ln>
+      </a:lnStyleLst>
+      <a:effectStyleLst>
+        <a:effectStyle>
+          <a:effectLst/>
+        </a:effectStyle>
+        <a:effectStyle>
+          <a:effectLst/>
+        </a:effectStyle>
+        <a:effectStyle>
+          <a:effectLst>
+            <a:outerShdw blurRad="57150" dist="19050" dir="5400000" algn="ctr" rotWithShape="0">
+              <a:srgbClr val="000000">
+                <a:alpha val="63000"/>
+              </a:srgbClr>
+            </a:outerShdw>
+          </a:effectLst>
+        </a:effectStyle>
+      </a:effectStyleLst>
+      <a:bgFillStyleLst>
+        <a:solidFill>
+          <a:schemeClr val="phClr"/>
+        </a:solidFill>
+        <a:solidFill>
+          <a:schemeClr val="phClr">
+            <a:tint val="95000"/>
+            <a:satMod val="170000"/>
+          </a:schemeClr>
+        </a:solidFill>
+        <a:gradFill rotWithShape="1">
+          <a:gsLst>
+            <a:gs pos="0">
+              <a:schemeClr val="phClr">
+                <a:tint val="93000"/>
+                <a:satMod val="150000"/>
+                <a:shade val="98000"/>
+                <a:lumMod val="102000"/>
+              </a:schemeClr>
+            </a:gs>
+            <a:gs pos="50000">
+              <a:schemeClr val="phClr">
+                <a:tint val="98000"/>
+                <a:satMod val="130000"/>
+                <a:shade val="90000"/>
+                <a:lumMod val="103000"/>
+              </a:schemeClr>
+            </a:gs>
+            <a:gs pos="100000">
+              <a:schemeClr val="phClr">
+                <a:shade val="63000"/>
+                <a:satMod val="120000"/>
+              </a:schemeClr>
+            </a:gs>
+          </a:gsLst>
+          <a:lin ang="5400000" scaled="0"/>
+        </a:gradFill>
+      </a:bgFillStyleLst>
+    </a:fmtScheme>
+  </a:themeElements>
   <a:extLst>
     <a:ext uri="{05A4C25C-085E-4340-85A3-A5531E510DB2}">
       <thm15:themeFamily xmlns:thm15="http://schemas.microsoft.com/office/thememl/2012/main" name="Office Theme" id="{62F939B6-93AF-4DB8-9C6B-D6C7DFDC589F}" vid="{4A3C46E8-61CC-4603-A589-7422A47A8E4A}"/>

</xml_diff>